<commit_message>
SQL Week 3 complete
</commit_message>
<xml_diff>
--- a/ICTPRG431-SQL/week_3-database-queries/resources/03-SQL-Queries.pptx
+++ b/ICTPRG431-SQL/week_3-database-queries/resources/03-SQL-Queries.pptx
@@ -363,7 +363,7 @@
           <a:p>
             <a:fld id="{77EA1514-F326-1840-B15D-D4720038598B}" type="datetimeFigureOut">
               <a:rPr lang="en-US" smtClean="0"/>
-              <a:t>8/6/2025</a:t>
+              <a:t>8/12/2025</a:t>
             </a:fld>
             <a:endParaRPr lang="en-US"/>
           </a:p>
@@ -6497,7 +6497,7 @@
           <a:p>
             <a:fld id="{56F489C6-6277-454E-AECF-6C3872A9450F}" type="datetimeFigureOut">
               <a:rPr lang="en-US" smtClean="0"/>
-              <a:t>8/6/2025</a:t>
+              <a:t>8/12/2025</a:t>
             </a:fld>
             <a:endParaRPr lang="en-US"/>
           </a:p>
@@ -7176,7 +7176,7 @@
           <a:p>
             <a:fld id="{56F489C6-6277-454E-AECF-6C3872A9450F}" type="datetimeFigureOut">
               <a:rPr lang="en-US" smtClean="0"/>
-              <a:t>8/6/2025</a:t>
+              <a:t>8/12/2025</a:t>
             </a:fld>
             <a:endParaRPr lang="en-US"/>
           </a:p>
@@ -7229,7 +7229,7 @@
           <p:cNvPr id="6" name="Picture Placeholder 8">
             <a:extLst>
               <a:ext uri="{FF2B5EF4-FFF2-40B4-BE49-F238E27FC236}">
-                <a16:creationId xmlns:a16="http://schemas.microsoft.com/office/drawing/2014/main" xmlns="" id="{C9126EA6-A663-AD41-9474-BAFD5F860789}"/>
+                <a16:creationId xmlns:a16="http://schemas.microsoft.com/office/drawing/2014/main" id="{C9126EA6-A663-AD41-9474-BAFD5F860789}"/>
               </a:ext>
             </a:extLst>
           </p:cNvPr>
@@ -7327,7 +7327,7 @@
           <a:p>
             <a:fld id="{56F489C6-6277-454E-AECF-6C3872A9450F}" type="datetimeFigureOut">
               <a:rPr lang="en-US" smtClean="0"/>
-              <a:t>8/6/2025</a:t>
+              <a:t>8/12/2025</a:t>
             </a:fld>
             <a:endParaRPr lang="en-US"/>
           </a:p>
@@ -7380,7 +7380,7 @@
           <p:cNvPr id="10" name="Picture Placeholder 8">
             <a:extLst>
               <a:ext uri="{FF2B5EF4-FFF2-40B4-BE49-F238E27FC236}">
-                <a16:creationId xmlns:a16="http://schemas.microsoft.com/office/drawing/2014/main" xmlns="" id="{C9126EA6-A663-AD41-9474-BAFD5F860789}"/>
+                <a16:creationId xmlns:a16="http://schemas.microsoft.com/office/drawing/2014/main" id="{C9126EA6-A663-AD41-9474-BAFD5F860789}"/>
               </a:ext>
             </a:extLst>
           </p:cNvPr>
@@ -7515,7 +7515,7 @@
           <a:p>
             <a:fld id="{56F489C6-6277-454E-AECF-6C3872A9450F}" type="datetimeFigureOut">
               <a:rPr lang="en-US" smtClean="0"/>
-              <a:t>8/6/2025</a:t>
+              <a:t>8/12/2025</a:t>
             </a:fld>
             <a:endParaRPr lang="en-US"/>
           </a:p>
@@ -7568,7 +7568,7 @@
           <p:cNvPr id="9" name="Picture Placeholder 8">
             <a:extLst>
               <a:ext uri="{FF2B5EF4-FFF2-40B4-BE49-F238E27FC236}">
-                <a16:creationId xmlns:a16="http://schemas.microsoft.com/office/drawing/2014/main" xmlns="" id="{ED779252-2DB5-164E-B413-9653D35CC4E5}"/>
+                <a16:creationId xmlns:a16="http://schemas.microsoft.com/office/drawing/2014/main" id="{ED779252-2DB5-164E-B413-9653D35CC4E5}"/>
               </a:ext>
             </a:extLst>
           </p:cNvPr>
@@ -7619,7 +7619,7 @@
           <p:cNvPr id="13" name="Text Placeholder 12">
             <a:extLst>
               <a:ext uri="{FF2B5EF4-FFF2-40B4-BE49-F238E27FC236}">
-                <a16:creationId xmlns:a16="http://schemas.microsoft.com/office/drawing/2014/main" xmlns="" id="{FFC5ADCF-7EA1-3644-9B75-D84582085EDA}"/>
+                <a16:creationId xmlns:a16="http://schemas.microsoft.com/office/drawing/2014/main" id="{FFC5ADCF-7EA1-3644-9B75-D84582085EDA}"/>
               </a:ext>
             </a:extLst>
           </p:cNvPr>
@@ -7765,7 +7765,7 @@
           <a:p>
             <a:fld id="{56F489C6-6277-454E-AECF-6C3872A9450F}" type="datetimeFigureOut">
               <a:rPr lang="en-US" smtClean="0"/>
-              <a:t>8/6/2025</a:t>
+              <a:t>8/12/2025</a:t>
             </a:fld>
             <a:endParaRPr lang="en-US"/>
           </a:p>
@@ -7818,7 +7818,7 @@
           <p:cNvPr id="7" name="Picture Placeholder 8">
             <a:extLst>
               <a:ext uri="{FF2B5EF4-FFF2-40B4-BE49-F238E27FC236}">
-                <a16:creationId xmlns:a16="http://schemas.microsoft.com/office/drawing/2014/main" xmlns="" id="{F7D5DACE-FF0F-2D46-93D3-295ECF1DA88A}"/>
+                <a16:creationId xmlns:a16="http://schemas.microsoft.com/office/drawing/2014/main" id="{F7D5DACE-FF0F-2D46-93D3-295ECF1DA88A}"/>
               </a:ext>
             </a:extLst>
           </p:cNvPr>
@@ -8038,7 +8038,7 @@
           <a:p>
             <a:fld id="{56F489C6-6277-454E-AECF-6C3872A9450F}" type="datetimeFigureOut">
               <a:rPr lang="en-US" smtClean="0"/>
-              <a:t>8/6/2025</a:t>
+              <a:t>8/12/2025</a:t>
             </a:fld>
             <a:endParaRPr lang="en-US"/>
           </a:p>
@@ -8318,7 +8318,7 @@
           <a:p>
             <a:fld id="{56F489C6-6277-454E-AECF-6C3872A9450F}" type="datetimeFigureOut">
               <a:rPr lang="en-US" smtClean="0"/>
-              <a:t>8/6/2025</a:t>
+              <a:t>8/12/2025</a:t>
             </a:fld>
             <a:endParaRPr lang="en-US"/>
           </a:p>
@@ -8589,7 +8589,7 @@
           <a:p>
             <a:fld id="{56F489C6-6277-454E-AECF-6C3872A9450F}" type="datetimeFigureOut">
               <a:rPr lang="en-US" smtClean="0"/>
-              <a:t>8/6/2025</a:t>
+              <a:t>8/12/2025</a:t>
             </a:fld>
             <a:endParaRPr lang="en-US"/>
           </a:p>
@@ -8838,7 +8838,7 @@
           <a:p>
             <a:fld id="{56F489C6-6277-454E-AECF-6C3872A9450F}" type="datetimeFigureOut">
               <a:rPr lang="en-AU" noProof="0" smtClean="0"/>
-              <a:t>6/08/2025</a:t>
+              <a:t>12/08/2025</a:t>
             </a:fld>
             <a:endParaRPr lang="en-AU" noProof="0"/>
           </a:p>
@@ -9016,7 +9016,7 @@
           <a:p>
             <a:fld id="{56F489C6-6277-454E-AECF-6C3872A9450F}" type="datetimeFigureOut">
               <a:rPr lang="en-US" smtClean="0"/>
-              <a:t>8/6/2025</a:t>
+              <a:t>8/12/2025</a:t>
             </a:fld>
             <a:endParaRPr lang="en-US"/>
           </a:p>
@@ -9199,7 +9199,7 @@
           <a:p>
             <a:fld id="{56F489C6-6277-454E-AECF-6C3872A9450F}" type="datetimeFigureOut">
               <a:rPr lang="en-US" smtClean="0"/>
-              <a:t>8/6/2025</a:t>
+              <a:t>8/12/2025</a:t>
             </a:fld>
             <a:endParaRPr lang="en-US"/>
           </a:p>
@@ -9252,7 +9252,7 @@
           <p:cNvPr id="7" name="Content Placeholder 2">
             <a:extLst>
               <a:ext uri="{FF2B5EF4-FFF2-40B4-BE49-F238E27FC236}">
-                <a16:creationId xmlns:a16="http://schemas.microsoft.com/office/drawing/2014/main" xmlns="" id="{E2FB0483-D927-6C4B-9F8E-0CBFBED89EAE}"/>
+                <a16:creationId xmlns:a16="http://schemas.microsoft.com/office/drawing/2014/main" id="{E2FB0483-D927-6C4B-9F8E-0CBFBED89EAE}"/>
               </a:ext>
             </a:extLst>
           </p:cNvPr>
@@ -9558,7 +9558,7 @@
           <a:p>
             <a:fld id="{56F489C6-6277-454E-AECF-6C3872A9450F}" type="datetimeFigureOut">
               <a:rPr lang="en-US" smtClean="0"/>
-              <a:t>8/6/2025</a:t>
+              <a:t>8/12/2025</a:t>
             </a:fld>
             <a:endParaRPr lang="en-US"/>
           </a:p>
@@ -9988,7 +9988,7 @@
           <a:p>
             <a:fld id="{56F489C6-6277-454E-AECF-6C3872A9450F}" type="datetimeFigureOut">
               <a:rPr lang="en-US" smtClean="0"/>
-              <a:t>8/6/2025</a:t>
+              <a:t>8/12/2025</a:t>
             </a:fld>
             <a:endParaRPr lang="en-US"/>
           </a:p>
@@ -10237,7 +10237,7 @@
           <a:p>
             <a:fld id="{56F489C6-6277-454E-AECF-6C3872A9450F}" type="datetimeFigureOut">
               <a:rPr lang="en-US" smtClean="0"/>
-              <a:t>8/6/2025</a:t>
+              <a:t>8/12/2025</a:t>
             </a:fld>
             <a:endParaRPr lang="en-US"/>
           </a:p>
@@ -10290,7 +10290,7 @@
           <p:cNvPr id="7" name="Picture Placeholder 8">
             <a:extLst>
               <a:ext uri="{FF2B5EF4-FFF2-40B4-BE49-F238E27FC236}">
-                <a16:creationId xmlns:a16="http://schemas.microsoft.com/office/drawing/2014/main" xmlns="" id="{F7D5DACE-FF0F-2D46-93D3-295ECF1DA88A}"/>
+                <a16:creationId xmlns:a16="http://schemas.microsoft.com/office/drawing/2014/main" id="{F7D5DACE-FF0F-2D46-93D3-295ECF1DA88A}"/>
               </a:ext>
             </a:extLst>
           </p:cNvPr>
@@ -10504,7 +10504,7 @@
           <a:p>
             <a:fld id="{56F489C6-6277-454E-AECF-6C3872A9450F}" type="datetimeFigureOut">
               <a:rPr lang="en-US" smtClean="0"/>
-              <a:t>8/6/2025</a:t>
+              <a:t>8/12/2025</a:t>
             </a:fld>
             <a:endParaRPr lang="en-US"/>
           </a:p>
@@ -10557,7 +10557,7 @@
           <p:cNvPr id="8" name="Picture Placeholder 8">
             <a:extLst>
               <a:ext uri="{FF2B5EF4-FFF2-40B4-BE49-F238E27FC236}">
-                <a16:creationId xmlns:a16="http://schemas.microsoft.com/office/drawing/2014/main" xmlns="" id="{CB08A67E-3ED8-7842-9A36-FDA51ABEB2AC}"/>
+                <a16:creationId xmlns:a16="http://schemas.microsoft.com/office/drawing/2014/main" id="{CB08A67E-3ED8-7842-9A36-FDA51ABEB2AC}"/>
               </a:ext>
             </a:extLst>
           </p:cNvPr>
@@ -10685,7 +10685,7 @@
           <a:p>
             <a:fld id="{56F489C6-6277-454E-AECF-6C3872A9450F}" type="datetimeFigureOut">
               <a:rPr lang="en-US" smtClean="0"/>
-              <a:t>8/6/2025</a:t>
+              <a:t>8/12/2025</a:t>
             </a:fld>
             <a:endParaRPr lang="en-US"/>
           </a:p>
@@ -10875,7 +10875,7 @@
             <a:fld id="{56F489C6-6277-454E-AECF-6C3872A9450F}" type="datetimeFigureOut">
               <a:rPr lang="en-US" smtClean="0"/>
               <a:pPr/>
-              <a:t>8/6/2025</a:t>
+              <a:t>8/12/2025</a:t>
             </a:fld>
             <a:endParaRPr lang="en-US"/>
           </a:p>
@@ -10965,7 +10965,7 @@
           <p:cNvPr id="15" name="Title Placeholder 14">
             <a:extLst>
               <a:ext uri="{FF2B5EF4-FFF2-40B4-BE49-F238E27FC236}">
-                <a16:creationId xmlns:a16="http://schemas.microsoft.com/office/drawing/2014/main" xmlns="" id="{ED1A118C-2DC5-9B4D-B303-C0863344BC99}"/>
+                <a16:creationId xmlns:a16="http://schemas.microsoft.com/office/drawing/2014/main" id="{ED1A118C-2DC5-9B4D-B303-C0863344BC99}"/>
               </a:ext>
             </a:extLst>
           </p:cNvPr>
@@ -11004,7 +11004,7 @@
           <p:cNvPr id="7" name="TextBox 6">
             <a:extLst>
               <a:ext uri="{FF2B5EF4-FFF2-40B4-BE49-F238E27FC236}">
-                <a16:creationId xmlns:a16="http://schemas.microsoft.com/office/drawing/2014/main" xmlns="" id="{3E7ECD42-B939-4B06-55CB-B2D2ACBCD01A}"/>
+                <a16:creationId xmlns:a16="http://schemas.microsoft.com/office/drawing/2014/main" id="{3E7ECD42-B939-4B06-55CB-B2D2ACBCD01A}"/>
               </a:ext>
             </a:extLst>
           </p:cNvPr>
@@ -11012,7 +11012,7 @@
           <p:nvPr userDrawn="1">
             <p:extLst>
               <p:ext uri="{1162E1C5-73C7-4A58-AE30-91384D911F3F}">
-                <p184:classification xmlns:p184="http://schemas.microsoft.com/office/powerpoint/2018/4/main" xmlns="" val="hdr"/>
+                <p184:classification xmlns="" xmlns:p184="http://schemas.microsoft.com/office/powerpoint/2018/4/main" val="hdr"/>
               </p:ext>
             </p:extLst>
           </p:nvPr>
@@ -11408,14 +11408,14 @@
                 <a:gridCol w="1718238">
                   <a:extLst>
                     <a:ext uri="{9D8B030D-6E8A-4147-A177-3AD203B41FA5}">
-                      <a16:colId xmlns:a16="http://schemas.microsoft.com/office/drawing/2014/main" xmlns="" val="1432791058"/>
+                      <a16:colId xmlns:a16="http://schemas.microsoft.com/office/drawing/2014/main" val="1432791058"/>
                     </a:ext>
                   </a:extLst>
                 </a:gridCol>
                 <a:gridCol w="8365562">
                   <a:extLst>
                     <a:ext uri="{9D8B030D-6E8A-4147-A177-3AD203B41FA5}">
-                      <a16:colId xmlns:a16="http://schemas.microsoft.com/office/drawing/2014/main" xmlns="" val="517524959"/>
+                      <a16:colId xmlns:a16="http://schemas.microsoft.com/office/drawing/2014/main" val="517524959"/>
                     </a:ext>
                   </a:extLst>
                 </a:gridCol>
@@ -11463,7 +11463,7 @@
                 </a:tc>
                 <a:extLst>
                   <a:ext uri="{0D108BD9-81ED-4DB2-BD59-A6C34878D82A}">
-                    <a16:rowId xmlns:a16="http://schemas.microsoft.com/office/drawing/2014/main" xmlns="" val="2402270444"/>
+                    <a16:rowId xmlns:a16="http://schemas.microsoft.com/office/drawing/2014/main" val="2402270444"/>
                   </a:ext>
                 </a:extLst>
               </a:tr>
@@ -11537,7 +11537,7 @@
                 </a:tc>
                 <a:extLst>
                   <a:ext uri="{0D108BD9-81ED-4DB2-BD59-A6C34878D82A}">
-                    <a16:rowId xmlns:a16="http://schemas.microsoft.com/office/drawing/2014/main" xmlns="" val="2629681324"/>
+                    <a16:rowId xmlns:a16="http://schemas.microsoft.com/office/drawing/2014/main" val="2629681324"/>
                   </a:ext>
                 </a:extLst>
               </a:tr>
@@ -11709,7 +11709,7 @@
           <p:cNvPr id="2" name="Title 1">
             <a:extLst>
               <a:ext uri="{FF2B5EF4-FFF2-40B4-BE49-F238E27FC236}">
-                <a16:creationId xmlns:a16="http://schemas.microsoft.com/office/drawing/2014/main" xmlns="" id="{DB6314FB-3ABC-D4A9-EFC6-14A5F89A2AB4}"/>
+                <a16:creationId xmlns:a16="http://schemas.microsoft.com/office/drawing/2014/main" id="{DB6314FB-3ABC-D4A9-EFC6-14A5F89A2AB4}"/>
               </a:ext>
             </a:extLst>
           </p:cNvPr>
@@ -11739,7 +11739,7 @@
           <p:cNvPr id="3" name="Content Placeholder 2">
             <a:extLst>
               <a:ext uri="{FF2B5EF4-FFF2-40B4-BE49-F238E27FC236}">
-                <a16:creationId xmlns:a16="http://schemas.microsoft.com/office/drawing/2014/main" xmlns="" id="{17DB5FFD-59B7-3B19-88C6-86B675830BCA}"/>
+                <a16:creationId xmlns:a16="http://schemas.microsoft.com/office/drawing/2014/main" id="{17DB5FFD-59B7-3B19-88C6-86B675830BCA}"/>
               </a:ext>
             </a:extLst>
           </p:cNvPr>
@@ -12051,7 +12051,7 @@
           <p:cNvPr id="2" name="Title 1">
             <a:extLst>
               <a:ext uri="{FF2B5EF4-FFF2-40B4-BE49-F238E27FC236}">
-                <a16:creationId xmlns:a16="http://schemas.microsoft.com/office/drawing/2014/main" xmlns="" id="{DB6314FB-3ABC-D4A9-EFC6-14A5F89A2AB4}"/>
+                <a16:creationId xmlns:a16="http://schemas.microsoft.com/office/drawing/2014/main" id="{DB6314FB-3ABC-D4A9-EFC6-14A5F89A2AB4}"/>
               </a:ext>
             </a:extLst>
           </p:cNvPr>
@@ -12081,7 +12081,7 @@
           <p:cNvPr id="3" name="Content Placeholder 2">
             <a:extLst>
               <a:ext uri="{FF2B5EF4-FFF2-40B4-BE49-F238E27FC236}">
-                <a16:creationId xmlns:a16="http://schemas.microsoft.com/office/drawing/2014/main" xmlns="" id="{17DB5FFD-59B7-3B19-88C6-86B675830BCA}"/>
+                <a16:creationId xmlns:a16="http://schemas.microsoft.com/office/drawing/2014/main" id="{17DB5FFD-59B7-3B19-88C6-86B675830BCA}"/>
               </a:ext>
             </a:extLst>
           </p:cNvPr>
@@ -12436,13 +12436,13 @@
           <a:lstStyle/>
           <a:p>
             <a:r>
-              <a:rPr lang="en-AU"/>
+              <a:rPr lang="en-AU" dirty="0"/>
               <a:t>Given the information below for the table “books”,</a:t>
             </a:r>
           </a:p>
           <a:p>
             <a:r>
-              <a:rPr lang="en-AU"/>
+              <a:rPr lang="en-AU" dirty="0"/>
               <a:t>Create the SQL to create the table:</a:t>
             </a:r>
           </a:p>
@@ -12476,63 +12476,63 @@
                 <a:gridCol w="1534112">
                   <a:extLst>
                     <a:ext uri="{9D8B030D-6E8A-4147-A177-3AD203B41FA5}">
-                      <a16:colId xmlns:a16="http://schemas.microsoft.com/office/drawing/2014/main" xmlns="" val="4070237601"/>
+                      <a16:colId xmlns:a16="http://schemas.microsoft.com/office/drawing/2014/main" val="4070237601"/>
                     </a:ext>
                   </a:extLst>
                 </a:gridCol>
                 <a:gridCol w="1525113">
                   <a:extLst>
                     <a:ext uri="{9D8B030D-6E8A-4147-A177-3AD203B41FA5}">
-                      <a16:colId xmlns:a16="http://schemas.microsoft.com/office/drawing/2014/main" xmlns="" val="795111159"/>
+                      <a16:colId xmlns:a16="http://schemas.microsoft.com/office/drawing/2014/main" val="795111159"/>
                     </a:ext>
                   </a:extLst>
                 </a:gridCol>
                 <a:gridCol w="1525113">
                   <a:extLst>
                     <a:ext uri="{9D8B030D-6E8A-4147-A177-3AD203B41FA5}">
-                      <a16:colId xmlns:a16="http://schemas.microsoft.com/office/drawing/2014/main" xmlns="" val="2176141039"/>
+                      <a16:colId xmlns:a16="http://schemas.microsoft.com/office/drawing/2014/main" val="2176141039"/>
                     </a:ext>
                   </a:extLst>
                 </a:gridCol>
                 <a:gridCol w="677750">
                   <a:extLst>
                     <a:ext uri="{9D8B030D-6E8A-4147-A177-3AD203B41FA5}">
-                      <a16:colId xmlns:a16="http://schemas.microsoft.com/office/drawing/2014/main" xmlns="" val="1279049190"/>
+                      <a16:colId xmlns:a16="http://schemas.microsoft.com/office/drawing/2014/main" val="1279049190"/>
                     </a:ext>
                   </a:extLst>
                 </a:gridCol>
                 <a:gridCol w="1321244">
                   <a:extLst>
                     <a:ext uri="{9D8B030D-6E8A-4147-A177-3AD203B41FA5}">
-                      <a16:colId xmlns:a16="http://schemas.microsoft.com/office/drawing/2014/main" xmlns="" val="360597995"/>
+                      <a16:colId xmlns:a16="http://schemas.microsoft.com/office/drawing/2014/main" val="360597995"/>
                     </a:ext>
                   </a:extLst>
                 </a:gridCol>
                 <a:gridCol w="653282">
                   <a:extLst>
                     <a:ext uri="{9D8B030D-6E8A-4147-A177-3AD203B41FA5}">
-                      <a16:colId xmlns:a16="http://schemas.microsoft.com/office/drawing/2014/main" xmlns="" val="3021564120"/>
+                      <a16:colId xmlns:a16="http://schemas.microsoft.com/office/drawing/2014/main" val="3021564120"/>
                     </a:ext>
                   </a:extLst>
                 </a:gridCol>
                 <a:gridCol w="1093697">
                   <a:extLst>
                     <a:ext uri="{9D8B030D-6E8A-4147-A177-3AD203B41FA5}">
-                      <a16:colId xmlns:a16="http://schemas.microsoft.com/office/drawing/2014/main" xmlns="" val="1813909588"/>
+                      <a16:colId xmlns:a16="http://schemas.microsoft.com/office/drawing/2014/main" val="1813909588"/>
                     </a:ext>
                   </a:extLst>
                 </a:gridCol>
                 <a:gridCol w="1321244">
                   <a:extLst>
                     <a:ext uri="{9D8B030D-6E8A-4147-A177-3AD203B41FA5}">
-                      <a16:colId xmlns:a16="http://schemas.microsoft.com/office/drawing/2014/main" xmlns="" val="1278746662"/>
+                      <a16:colId xmlns:a16="http://schemas.microsoft.com/office/drawing/2014/main" val="1278746662"/>
                     </a:ext>
                   </a:extLst>
                 </a:gridCol>
                 <a:gridCol w="1321244">
                   <a:extLst>
                     <a:ext uri="{9D8B030D-6E8A-4147-A177-3AD203B41FA5}">
-                      <a16:colId xmlns:a16="http://schemas.microsoft.com/office/drawing/2014/main" xmlns="" val="539335442"/>
+                      <a16:colId xmlns:a16="http://schemas.microsoft.com/office/drawing/2014/main" val="539335442"/>
                     </a:ext>
                   </a:extLst>
                 </a:gridCol>
@@ -12701,7 +12701,7 @@
                 </a:tc>
                 <a:extLst>
                   <a:ext uri="{0D108BD9-81ED-4DB2-BD59-A6C34878D82A}">
-                    <a16:rowId xmlns:a16="http://schemas.microsoft.com/office/drawing/2014/main" xmlns="" val="4204937884"/>
+                    <a16:rowId xmlns:a16="http://schemas.microsoft.com/office/drawing/2014/main" val="4204937884"/>
                   </a:ext>
                 </a:extLst>
               </a:tr>
@@ -12834,7 +12834,7 @@
                 </a:tc>
                 <a:extLst>
                   <a:ext uri="{0D108BD9-81ED-4DB2-BD59-A6C34878D82A}">
-                    <a16:rowId xmlns:a16="http://schemas.microsoft.com/office/drawing/2014/main" xmlns="" val="1664324930"/>
+                    <a16:rowId xmlns:a16="http://schemas.microsoft.com/office/drawing/2014/main" val="1664324930"/>
                   </a:ext>
                 </a:extLst>
               </a:tr>
@@ -13002,7 +13002,7 @@
                 </a:tc>
                 <a:extLst>
                   <a:ext uri="{0D108BD9-81ED-4DB2-BD59-A6C34878D82A}">
-                    <a16:rowId xmlns:a16="http://schemas.microsoft.com/office/drawing/2014/main" xmlns="" val="3442888030"/>
+                    <a16:rowId xmlns:a16="http://schemas.microsoft.com/office/drawing/2014/main" val="3442888030"/>
                   </a:ext>
                 </a:extLst>
               </a:tr>
@@ -13169,7 +13169,7 @@
                 </a:tc>
                 <a:extLst>
                   <a:ext uri="{0D108BD9-81ED-4DB2-BD59-A6C34878D82A}">
-                    <a16:rowId xmlns:a16="http://schemas.microsoft.com/office/drawing/2014/main" xmlns="" val="1067306469"/>
+                    <a16:rowId xmlns:a16="http://schemas.microsoft.com/office/drawing/2014/main" val="1067306469"/>
                   </a:ext>
                 </a:extLst>
               </a:tr>
@@ -13302,7 +13302,7 @@
                 </a:tc>
                 <a:extLst>
                   <a:ext uri="{0D108BD9-81ED-4DB2-BD59-A6C34878D82A}">
-                    <a16:rowId xmlns:a16="http://schemas.microsoft.com/office/drawing/2014/main" xmlns="" val="1144237521"/>
+                    <a16:rowId xmlns:a16="http://schemas.microsoft.com/office/drawing/2014/main" val="1144237521"/>
                   </a:ext>
                 </a:extLst>
               </a:tr>
@@ -13435,7 +13435,7 @@
                 </a:tc>
                 <a:extLst>
                   <a:ext uri="{0D108BD9-81ED-4DB2-BD59-A6C34878D82A}">
-                    <a16:rowId xmlns:a16="http://schemas.microsoft.com/office/drawing/2014/main" xmlns="" val="2763584230"/>
+                    <a16:rowId xmlns:a16="http://schemas.microsoft.com/office/drawing/2014/main" val="2763584230"/>
                   </a:ext>
                 </a:extLst>
               </a:tr>
@@ -13574,7 +13574,7 @@
                 </a:tc>
                 <a:extLst>
                   <a:ext uri="{0D108BD9-81ED-4DB2-BD59-A6C34878D82A}">
-                    <a16:rowId xmlns:a16="http://schemas.microsoft.com/office/drawing/2014/main" xmlns="" val="2879572142"/>
+                    <a16:rowId xmlns:a16="http://schemas.microsoft.com/office/drawing/2014/main" val="2879572142"/>
                   </a:ext>
                 </a:extLst>
               </a:tr>
@@ -13636,7 +13636,7 @@
                     <a:bodyPr/>
                     <a:lstStyle/>
                     <a:p>
-                      <a:endParaRPr lang="en-AU"/>
+                      <a:endParaRPr lang="en-AU" dirty="0"/>
                     </a:p>
                   </a:txBody>
                   <a:tcPr/>
@@ -13694,7 +13694,7 @@
                     <a:bodyPr/>
                     <a:lstStyle/>
                     <a:p>
-                      <a:endParaRPr lang="en-AU"/>
+                      <a:endParaRPr lang="en-AU" dirty="0"/>
                     </a:p>
                   </a:txBody>
                   <a:tcPr>
@@ -13707,7 +13707,7 @@
                 </a:tc>
                 <a:extLst>
                   <a:ext uri="{0D108BD9-81ED-4DB2-BD59-A6C34878D82A}">
-                    <a16:rowId xmlns:a16="http://schemas.microsoft.com/office/drawing/2014/main" xmlns="" val="3314419130"/>
+                    <a16:rowId xmlns:a16="http://schemas.microsoft.com/office/drawing/2014/main" val="3314419130"/>
                   </a:ext>
                 </a:extLst>
               </a:tr>
@@ -13823,56 +13823,56 @@
                 <a:gridCol w="1781759">
                   <a:extLst>
                     <a:ext uri="{9D8B030D-6E8A-4147-A177-3AD203B41FA5}">
-                      <a16:colId xmlns:a16="http://schemas.microsoft.com/office/drawing/2014/main" xmlns="" val="4070237601"/>
+                      <a16:colId xmlns:a16="http://schemas.microsoft.com/office/drawing/2014/main" val="4070237601"/>
                     </a:ext>
                   </a:extLst>
                 </a:gridCol>
                 <a:gridCol w="1771308">
                   <a:extLst>
                     <a:ext uri="{9D8B030D-6E8A-4147-A177-3AD203B41FA5}">
-                      <a16:colId xmlns:a16="http://schemas.microsoft.com/office/drawing/2014/main" xmlns="" val="2176141039"/>
+                      <a16:colId xmlns:a16="http://schemas.microsoft.com/office/drawing/2014/main" val="2176141039"/>
                     </a:ext>
                   </a:extLst>
                 </a:gridCol>
                 <a:gridCol w="787157">
                   <a:extLst>
                     <a:ext uri="{9D8B030D-6E8A-4147-A177-3AD203B41FA5}">
-                      <a16:colId xmlns:a16="http://schemas.microsoft.com/office/drawing/2014/main" xmlns="" val="1279049190"/>
+                      <a16:colId xmlns:a16="http://schemas.microsoft.com/office/drawing/2014/main" val="1279049190"/>
                     </a:ext>
                   </a:extLst>
                 </a:gridCol>
                 <a:gridCol w="1534529">
                   <a:extLst>
                     <a:ext uri="{9D8B030D-6E8A-4147-A177-3AD203B41FA5}">
-                      <a16:colId xmlns:a16="http://schemas.microsoft.com/office/drawing/2014/main" xmlns="" val="360597995"/>
+                      <a16:colId xmlns:a16="http://schemas.microsoft.com/office/drawing/2014/main" val="360597995"/>
                     </a:ext>
                   </a:extLst>
                 </a:gridCol>
                 <a:gridCol w="758739">
                   <a:extLst>
                     <a:ext uri="{9D8B030D-6E8A-4147-A177-3AD203B41FA5}">
-                      <a16:colId xmlns:a16="http://schemas.microsoft.com/office/drawing/2014/main" xmlns="" val="3021564120"/>
+                      <a16:colId xmlns:a16="http://schemas.microsoft.com/office/drawing/2014/main" val="3021564120"/>
                     </a:ext>
                   </a:extLst>
                 </a:gridCol>
                 <a:gridCol w="1270249">
                   <a:extLst>
                     <a:ext uri="{9D8B030D-6E8A-4147-A177-3AD203B41FA5}">
-                      <a16:colId xmlns:a16="http://schemas.microsoft.com/office/drawing/2014/main" xmlns="" val="1813909588"/>
+                      <a16:colId xmlns:a16="http://schemas.microsoft.com/office/drawing/2014/main" val="1813909588"/>
                     </a:ext>
                   </a:extLst>
                 </a:gridCol>
                 <a:gridCol w="1534529">
                   <a:extLst>
                     <a:ext uri="{9D8B030D-6E8A-4147-A177-3AD203B41FA5}">
-                      <a16:colId xmlns:a16="http://schemas.microsoft.com/office/drawing/2014/main" xmlns="" val="1278746662"/>
+                      <a16:colId xmlns:a16="http://schemas.microsoft.com/office/drawing/2014/main" val="1278746662"/>
                     </a:ext>
                   </a:extLst>
                 </a:gridCol>
                 <a:gridCol w="1534529">
                   <a:extLst>
                     <a:ext uri="{9D8B030D-6E8A-4147-A177-3AD203B41FA5}">
-                      <a16:colId xmlns:a16="http://schemas.microsoft.com/office/drawing/2014/main" xmlns="" val="539335442"/>
+                      <a16:colId xmlns:a16="http://schemas.microsoft.com/office/drawing/2014/main" val="539335442"/>
                     </a:ext>
                   </a:extLst>
                 </a:gridCol>
@@ -14008,7 +14008,7 @@
                 </a:tc>
                 <a:extLst>
                   <a:ext uri="{0D108BD9-81ED-4DB2-BD59-A6C34878D82A}">
-                    <a16:rowId xmlns:a16="http://schemas.microsoft.com/office/drawing/2014/main" xmlns="" val="4204937884"/>
+                    <a16:rowId xmlns:a16="http://schemas.microsoft.com/office/drawing/2014/main" val="4204937884"/>
                   </a:ext>
                 </a:extLst>
               </a:tr>
@@ -14129,7 +14129,7 @@
                 </a:tc>
                 <a:extLst>
                   <a:ext uri="{0D108BD9-81ED-4DB2-BD59-A6C34878D82A}">
-                    <a16:rowId xmlns:a16="http://schemas.microsoft.com/office/drawing/2014/main" xmlns="" val="1664324930"/>
+                    <a16:rowId xmlns:a16="http://schemas.microsoft.com/office/drawing/2014/main" val="1664324930"/>
                   </a:ext>
                 </a:extLst>
               </a:tr>
@@ -14266,7 +14266,7 @@
                 </a:tc>
                 <a:extLst>
                   <a:ext uri="{0D108BD9-81ED-4DB2-BD59-A6C34878D82A}">
-                    <a16:rowId xmlns:a16="http://schemas.microsoft.com/office/drawing/2014/main" xmlns="" val="3442888030"/>
+                    <a16:rowId xmlns:a16="http://schemas.microsoft.com/office/drawing/2014/main" val="3442888030"/>
                   </a:ext>
                 </a:extLst>
               </a:tr>
@@ -14403,7 +14403,7 @@
                 </a:tc>
                 <a:extLst>
                   <a:ext uri="{0D108BD9-81ED-4DB2-BD59-A6C34878D82A}">
-                    <a16:rowId xmlns:a16="http://schemas.microsoft.com/office/drawing/2014/main" xmlns="" val="1067306469"/>
+                    <a16:rowId xmlns:a16="http://schemas.microsoft.com/office/drawing/2014/main" val="1067306469"/>
                   </a:ext>
                 </a:extLst>
               </a:tr>
@@ -14523,7 +14523,7 @@
                 </a:tc>
                 <a:extLst>
                   <a:ext uri="{0D108BD9-81ED-4DB2-BD59-A6C34878D82A}">
-                    <a16:rowId xmlns:a16="http://schemas.microsoft.com/office/drawing/2014/main" xmlns="" val="1144237521"/>
+                    <a16:rowId xmlns:a16="http://schemas.microsoft.com/office/drawing/2014/main" val="1144237521"/>
                   </a:ext>
                 </a:extLst>
               </a:tr>
@@ -14640,7 +14640,7 @@
                 </a:tc>
                 <a:extLst>
                   <a:ext uri="{0D108BD9-81ED-4DB2-BD59-A6C34878D82A}">
-                    <a16:rowId xmlns:a16="http://schemas.microsoft.com/office/drawing/2014/main" xmlns="" val="2763584230"/>
+                    <a16:rowId xmlns:a16="http://schemas.microsoft.com/office/drawing/2014/main" val="2763584230"/>
                   </a:ext>
                 </a:extLst>
               </a:tr>
@@ -14751,7 +14751,7 @@
                 </a:tc>
                 <a:extLst>
                   <a:ext uri="{0D108BD9-81ED-4DB2-BD59-A6C34878D82A}">
-                    <a16:rowId xmlns:a16="http://schemas.microsoft.com/office/drawing/2014/main" xmlns="" val="3137393036"/>
+                    <a16:rowId xmlns:a16="http://schemas.microsoft.com/office/drawing/2014/main" val="3137393036"/>
                   </a:ext>
                 </a:extLst>
               </a:tr>
@@ -17109,7 +17109,7 @@
           <p:cNvPr id="2" name="Title 1">
             <a:extLst>
               <a:ext uri="{FF2B5EF4-FFF2-40B4-BE49-F238E27FC236}">
-                <a16:creationId xmlns:a16="http://schemas.microsoft.com/office/drawing/2014/main" xmlns="" id="{16698908-DAC8-EA92-AB87-E73D383B7748}"/>
+                <a16:creationId xmlns:a16="http://schemas.microsoft.com/office/drawing/2014/main" id="{16698908-DAC8-EA92-AB87-E73D383B7748}"/>
               </a:ext>
             </a:extLst>
           </p:cNvPr>
@@ -17137,7 +17137,7 @@
           <p:cNvPr id="3" name="Content Placeholder 2">
             <a:extLst>
               <a:ext uri="{FF2B5EF4-FFF2-40B4-BE49-F238E27FC236}">
-                <a16:creationId xmlns:a16="http://schemas.microsoft.com/office/drawing/2014/main" xmlns="" id="{47B1AEAF-5664-2A2E-0CD6-1F9C239E6BF6}"/>
+                <a16:creationId xmlns:a16="http://schemas.microsoft.com/office/drawing/2014/main" id="{47B1AEAF-5664-2A2E-0CD6-1F9C239E6BF6}"/>
               </a:ext>
             </a:extLst>
           </p:cNvPr>
@@ -17262,7 +17262,7 @@
           <p:cNvPr id="2" name="Title 1">
             <a:extLst>
               <a:ext uri="{FF2B5EF4-FFF2-40B4-BE49-F238E27FC236}">
-                <a16:creationId xmlns:a16="http://schemas.microsoft.com/office/drawing/2014/main" xmlns="" id="{67D7746F-F59E-E1C3-08EA-24D4572ED52A}"/>
+                <a16:creationId xmlns:a16="http://schemas.microsoft.com/office/drawing/2014/main" id="{67D7746F-F59E-E1C3-08EA-24D4572ED52A}"/>
               </a:ext>
             </a:extLst>
           </p:cNvPr>
@@ -17298,7 +17298,7 @@
           <p:cNvPr id="3" name="Content Placeholder 2">
             <a:extLst>
               <a:ext uri="{FF2B5EF4-FFF2-40B4-BE49-F238E27FC236}">
-                <a16:creationId xmlns:a16="http://schemas.microsoft.com/office/drawing/2014/main" xmlns="" id="{5F3AEBA8-63F2-ACFC-4C56-6BC40EF2DE61}"/>
+                <a16:creationId xmlns:a16="http://schemas.microsoft.com/office/drawing/2014/main" id="{5F3AEBA8-63F2-ACFC-4C56-6BC40EF2DE61}"/>
               </a:ext>
             </a:extLst>
           </p:cNvPr>
@@ -18166,7 +18166,7 @@
           <p:cNvPr id="2" name="Title 1">
             <a:extLst>
               <a:ext uri="{FF2B5EF4-FFF2-40B4-BE49-F238E27FC236}">
-                <a16:creationId xmlns:a16="http://schemas.microsoft.com/office/drawing/2014/main" xmlns="" id="{95464069-D5B1-2F99-D125-958499ED2256}"/>
+                <a16:creationId xmlns:a16="http://schemas.microsoft.com/office/drawing/2014/main" id="{95464069-D5B1-2F99-D125-958499ED2256}"/>
               </a:ext>
             </a:extLst>
           </p:cNvPr>
@@ -18194,7 +18194,7 @@
           <p:cNvPr id="3" name="Text Placeholder 2">
             <a:extLst>
               <a:ext uri="{FF2B5EF4-FFF2-40B4-BE49-F238E27FC236}">
-                <a16:creationId xmlns:a16="http://schemas.microsoft.com/office/drawing/2014/main" xmlns="" id="{E89557D1-4F43-4027-4638-2EDD53CADDF3}"/>
+                <a16:creationId xmlns:a16="http://schemas.microsoft.com/office/drawing/2014/main" id="{E89557D1-4F43-4027-4638-2EDD53CADDF3}"/>
               </a:ext>
             </a:extLst>
           </p:cNvPr>
@@ -18249,7 +18249,7 @@
           <p:cNvPr id="2" name="Title 1">
             <a:extLst>
               <a:ext uri="{FF2B5EF4-FFF2-40B4-BE49-F238E27FC236}">
-                <a16:creationId xmlns:a16="http://schemas.microsoft.com/office/drawing/2014/main" xmlns="" id="{27D38E1E-4968-612E-B834-8CDBBF8451E4}"/>
+                <a16:creationId xmlns:a16="http://schemas.microsoft.com/office/drawing/2014/main" id="{27D38E1E-4968-612E-B834-8CDBBF8451E4}"/>
               </a:ext>
             </a:extLst>
           </p:cNvPr>
@@ -18277,7 +18277,7 @@
           <p:cNvPr id="3" name="Content Placeholder 2">
             <a:extLst>
               <a:ext uri="{FF2B5EF4-FFF2-40B4-BE49-F238E27FC236}">
-                <a16:creationId xmlns:a16="http://schemas.microsoft.com/office/drawing/2014/main" xmlns="" id="{1D1843DF-B7C3-536A-F240-457BB94E6C86}"/>
+                <a16:creationId xmlns:a16="http://schemas.microsoft.com/office/drawing/2014/main" id="{1D1843DF-B7C3-536A-F240-457BB94E6C86}"/>
               </a:ext>
             </a:extLst>
           </p:cNvPr>
@@ -18488,7 +18488,7 @@
           <p:cNvPr id="2" name="Title 1">
             <a:extLst>
               <a:ext uri="{FF2B5EF4-FFF2-40B4-BE49-F238E27FC236}">
-                <a16:creationId xmlns:a16="http://schemas.microsoft.com/office/drawing/2014/main" xmlns="" id="{6BC23802-9B2F-7770-1A4F-5F213D78C0E1}"/>
+                <a16:creationId xmlns:a16="http://schemas.microsoft.com/office/drawing/2014/main" id="{6BC23802-9B2F-7770-1A4F-5F213D78C0E1}"/>
               </a:ext>
             </a:extLst>
           </p:cNvPr>
@@ -18516,7 +18516,7 @@
           <p:cNvPr id="3" name="Content Placeholder 2">
             <a:extLst>
               <a:ext uri="{FF2B5EF4-FFF2-40B4-BE49-F238E27FC236}">
-                <a16:creationId xmlns:a16="http://schemas.microsoft.com/office/drawing/2014/main" xmlns="" id="{4BD0F07B-75EE-E0E2-769A-E023A02C3441}"/>
+                <a16:creationId xmlns:a16="http://schemas.microsoft.com/office/drawing/2014/main" id="{4BD0F07B-75EE-E0E2-769A-E023A02C3441}"/>
               </a:ext>
             </a:extLst>
           </p:cNvPr>
@@ -18906,7 +18906,7 @@
           <p:cNvPr id="2" name="Title 1">
             <a:extLst>
               <a:ext uri="{FF2B5EF4-FFF2-40B4-BE49-F238E27FC236}">
-                <a16:creationId xmlns:a16="http://schemas.microsoft.com/office/drawing/2014/main" xmlns="" id="{7CCEFA68-DC27-0136-EB8A-A26C3B49BC88}"/>
+                <a16:creationId xmlns:a16="http://schemas.microsoft.com/office/drawing/2014/main" id="{7CCEFA68-DC27-0136-EB8A-A26C3B49BC88}"/>
               </a:ext>
             </a:extLst>
           </p:cNvPr>
@@ -18930,24 +18930,24 @@
           <a:lstStyle/>
           <a:p>
             <a:r>
-              <a:rPr lang="en-AU" sz="3100"/>
+              <a:rPr lang="en-AU" sz="3100" dirty="0"/>
               <a:t>To Update table by adding a new column and values.</a:t>
             </a:r>
             <a:br>
-              <a:rPr lang="en-AU" sz="3100"/>
+              <a:rPr lang="en-AU" sz="3100" dirty="0"/>
             </a:br>
             <a:r>
-              <a:rPr lang="en-AU" sz="3100"/>
+              <a:rPr lang="en-AU" sz="3100" dirty="0"/>
               <a:t>To update the values in the table Set command is used</a:t>
             </a:r>
             <a:r>
-              <a:rPr lang="en-AU"/>
+              <a:rPr lang="en-AU" dirty="0"/>
               <a:t/>
             </a:r>
             <a:br>
-              <a:rPr lang="en-AU"/>
+              <a:rPr lang="en-AU" dirty="0"/>
             </a:br>
-            <a:endParaRPr lang="en-AU"/>
+            <a:endParaRPr lang="en-AU" dirty="0"/>
           </a:p>
         </p:txBody>
       </p:sp>
@@ -18956,7 +18956,7 @@
           <p:cNvPr id="3" name="Content Placeholder 2">
             <a:extLst>
               <a:ext uri="{FF2B5EF4-FFF2-40B4-BE49-F238E27FC236}">
-                <a16:creationId xmlns:a16="http://schemas.microsoft.com/office/drawing/2014/main" xmlns="" id="{0ABBDF99-126F-45F1-1B6D-68AFC81C3A38}"/>
+                <a16:creationId xmlns:a16="http://schemas.microsoft.com/office/drawing/2014/main" id="{0ABBDF99-126F-45F1-1B6D-68AFC81C3A38}"/>
               </a:ext>
             </a:extLst>
           </p:cNvPr>
@@ -19138,7 +19138,7 @@
           <p:cNvPr id="2" name="Title 1">
             <a:extLst>
               <a:ext uri="{FF2B5EF4-FFF2-40B4-BE49-F238E27FC236}">
-                <a16:creationId xmlns:a16="http://schemas.microsoft.com/office/drawing/2014/main" xmlns="" id="{E4AB32E9-E17E-F748-FB8C-7256F34C1C6C}"/>
+                <a16:creationId xmlns:a16="http://schemas.microsoft.com/office/drawing/2014/main" id="{E4AB32E9-E17E-F748-FB8C-7256F34C1C6C}"/>
               </a:ext>
             </a:extLst>
           </p:cNvPr>
@@ -19168,7 +19168,7 @@
           <p:cNvPr id="3" name="Content Placeholder 2">
             <a:extLst>
               <a:ext uri="{FF2B5EF4-FFF2-40B4-BE49-F238E27FC236}">
-                <a16:creationId xmlns:a16="http://schemas.microsoft.com/office/drawing/2014/main" xmlns="" id="{49EE88EE-3E34-EA96-B10A-456A34DC0CE7}"/>
+                <a16:creationId xmlns:a16="http://schemas.microsoft.com/office/drawing/2014/main" id="{49EE88EE-3E34-EA96-B10A-456A34DC0CE7}"/>
               </a:ext>
             </a:extLst>
           </p:cNvPr>
@@ -19290,7 +19290,7 @@
           <p:cNvPr id="2" name="Title 1">
             <a:extLst>
               <a:ext uri="{FF2B5EF4-FFF2-40B4-BE49-F238E27FC236}">
-                <a16:creationId xmlns:a16="http://schemas.microsoft.com/office/drawing/2014/main" xmlns="" id="{F97DCD71-9F98-E149-5574-8E3241DF44B5}"/>
+                <a16:creationId xmlns:a16="http://schemas.microsoft.com/office/drawing/2014/main" id="{F97DCD71-9F98-E149-5574-8E3241DF44B5}"/>
               </a:ext>
             </a:extLst>
           </p:cNvPr>
@@ -19318,7 +19318,7 @@
           <p:cNvPr id="3" name="Content Placeholder 2">
             <a:extLst>
               <a:ext uri="{FF2B5EF4-FFF2-40B4-BE49-F238E27FC236}">
-                <a16:creationId xmlns:a16="http://schemas.microsoft.com/office/drawing/2014/main" xmlns="" id="{2BFB41DA-2C49-2427-F903-C9FF11CD1FDB}"/>
+                <a16:creationId xmlns:a16="http://schemas.microsoft.com/office/drawing/2014/main" id="{2BFB41DA-2C49-2427-F903-C9FF11CD1FDB}"/>
               </a:ext>
             </a:extLst>
           </p:cNvPr>
@@ -19337,66 +19337,66 @@
           <a:lstStyle/>
           <a:p>
             <a:r>
-              <a:rPr lang="en-AU"/>
+              <a:rPr lang="en-AU" dirty="0"/>
               <a:t>Add a column </a:t>
             </a:r>
             <a:r>
-              <a:rPr lang="en-AU" err="1"/>
+              <a:rPr lang="en-AU" dirty="0" err="1"/>
               <a:t>Amounttobepaid</a:t>
             </a:r>
             <a:r>
-              <a:rPr lang="en-AU"/>
+              <a:rPr lang="en-AU" dirty="0"/>
               <a:t> with float data type</a:t>
             </a:r>
           </a:p>
           <a:p>
             <a:r>
-              <a:rPr lang="en-AU"/>
+              <a:rPr lang="en-AU" dirty="0"/>
               <a:t>Set different values for </a:t>
             </a:r>
             <a:r>
-              <a:rPr lang="en-AU" err="1"/>
+              <a:rPr lang="en-AU" dirty="0" err="1"/>
               <a:t>Amounttobepaid</a:t>
             </a:r>
             <a:r>
-              <a:rPr lang="en-AU"/>
+              <a:rPr lang="en-AU" dirty="0"/>
               <a:t> using Update and set Commands</a:t>
             </a:r>
           </a:p>
           <a:p>
             <a:r>
-              <a:rPr lang="en-AU"/>
+              <a:rPr lang="en-AU" dirty="0"/>
               <a:t>Add a column Discount with float data type in the table customers</a:t>
             </a:r>
           </a:p>
           <a:p>
             <a:r>
-              <a:rPr lang="en-AU"/>
+              <a:rPr lang="en-AU" dirty="0"/>
               <a:t>Set  different values of Discount into each record using Update &amp; set command</a:t>
             </a:r>
           </a:p>
           <a:p>
             <a:r>
-              <a:rPr lang="en-AU"/>
+              <a:rPr lang="en-AU" dirty="0"/>
               <a:t>Add a column </a:t>
             </a:r>
             <a:r>
-              <a:rPr lang="en-AU" err="1"/>
+              <a:rPr lang="en-AU" dirty="0" err="1"/>
               <a:t>Paid_Amount</a:t>
             </a:r>
-            <a:endParaRPr lang="en-AU"/>
-          </a:p>
-          <a:p>
-            <a:r>
-              <a:rPr lang="en-AU"/>
+            <a:endParaRPr lang="en-AU" dirty="0"/>
+          </a:p>
+          <a:p>
+            <a:r>
+              <a:rPr lang="en-AU" dirty="0"/>
               <a:t>Subtract as Discount from </a:t>
             </a:r>
             <a:r>
-              <a:rPr lang="en-AU" err="1"/>
+              <a:rPr lang="en-AU" dirty="0" err="1"/>
               <a:t>Amounttobepaid</a:t>
             </a:r>
             <a:r>
-              <a:rPr lang="en-AU"/>
+              <a:rPr lang="en-AU" dirty="0"/>
               <a:t> using update and  set command </a:t>
             </a:r>
           </a:p>
@@ -20786,7 +20786,7 @@
           <p:cNvPr id="2" name="Title 1">
             <a:extLst>
               <a:ext uri="{FF2B5EF4-FFF2-40B4-BE49-F238E27FC236}">
-                <a16:creationId xmlns:a16="http://schemas.microsoft.com/office/drawing/2014/main" xmlns="" id="{E0197DAE-2794-2A48-B881-72AD9F2E19E6}"/>
+                <a16:creationId xmlns:a16="http://schemas.microsoft.com/office/drawing/2014/main" id="{E0197DAE-2794-2A48-B881-72AD9F2E19E6}"/>
               </a:ext>
             </a:extLst>
           </p:cNvPr>
@@ -20814,7 +20814,7 @@
           <p:cNvPr id="3" name="Content Placeholder 2">
             <a:extLst>
               <a:ext uri="{FF2B5EF4-FFF2-40B4-BE49-F238E27FC236}">
-                <a16:creationId xmlns:a16="http://schemas.microsoft.com/office/drawing/2014/main" xmlns="" id="{47654F44-B3B5-5746-93E9-8536EF5C9CF8}"/>
+                <a16:creationId xmlns:a16="http://schemas.microsoft.com/office/drawing/2014/main" id="{47654F44-B3B5-5746-93E9-8536EF5C9CF8}"/>
               </a:ext>
             </a:extLst>
           </p:cNvPr>
@@ -21046,7 +21046,7 @@
           <p:cNvPr id="2" name="Title 1">
             <a:extLst>
               <a:ext uri="{FF2B5EF4-FFF2-40B4-BE49-F238E27FC236}">
-                <a16:creationId xmlns:a16="http://schemas.microsoft.com/office/drawing/2014/main" xmlns="" id="{E0197DAE-2794-2A48-B881-72AD9F2E19E6}"/>
+                <a16:creationId xmlns:a16="http://schemas.microsoft.com/office/drawing/2014/main" id="{E0197DAE-2794-2A48-B881-72AD9F2E19E6}"/>
               </a:ext>
             </a:extLst>
           </p:cNvPr>
@@ -21074,7 +21074,7 @@
           <p:cNvPr id="3" name="Content Placeholder 2">
             <a:extLst>
               <a:ext uri="{FF2B5EF4-FFF2-40B4-BE49-F238E27FC236}">
-                <a16:creationId xmlns:a16="http://schemas.microsoft.com/office/drawing/2014/main" xmlns="" id="{47654F44-B3B5-5746-93E9-8536EF5C9CF8}"/>
+                <a16:creationId xmlns:a16="http://schemas.microsoft.com/office/drawing/2014/main" id="{47654F44-B3B5-5746-93E9-8536EF5C9CF8}"/>
               </a:ext>
             </a:extLst>
           </p:cNvPr>
@@ -21648,7 +21648,7 @@
           <p:cNvPr id="2" name="Title 1">
             <a:extLst>
               <a:ext uri="{FF2B5EF4-FFF2-40B4-BE49-F238E27FC236}">
-                <a16:creationId xmlns:a16="http://schemas.microsoft.com/office/drawing/2014/main" xmlns="" id="{E0197DAE-2794-2A48-B881-72AD9F2E19E6}"/>
+                <a16:creationId xmlns:a16="http://schemas.microsoft.com/office/drawing/2014/main" id="{E0197DAE-2794-2A48-B881-72AD9F2E19E6}"/>
               </a:ext>
             </a:extLst>
           </p:cNvPr>
@@ -21676,7 +21676,7 @@
           <p:cNvPr id="3" name="Content Placeholder 2">
             <a:extLst>
               <a:ext uri="{FF2B5EF4-FFF2-40B4-BE49-F238E27FC236}">
-                <a16:creationId xmlns:a16="http://schemas.microsoft.com/office/drawing/2014/main" xmlns="" id="{47654F44-B3B5-5746-93E9-8536EF5C9CF8}"/>
+                <a16:creationId xmlns:a16="http://schemas.microsoft.com/office/drawing/2014/main" id="{47654F44-B3B5-5746-93E9-8536EF5C9CF8}"/>
               </a:ext>
             </a:extLst>
           </p:cNvPr>
@@ -21806,7 +21806,7 @@
           <p:cNvPr id="2" name="Title 1">
             <a:extLst>
               <a:ext uri="{FF2B5EF4-FFF2-40B4-BE49-F238E27FC236}">
-                <a16:creationId xmlns:a16="http://schemas.microsoft.com/office/drawing/2014/main" xmlns="" id="{E0197DAE-2794-2A48-B881-72AD9F2E19E6}"/>
+                <a16:creationId xmlns:a16="http://schemas.microsoft.com/office/drawing/2014/main" id="{E0197DAE-2794-2A48-B881-72AD9F2E19E6}"/>
               </a:ext>
             </a:extLst>
           </p:cNvPr>
@@ -21834,7 +21834,7 @@
           <p:cNvPr id="3" name="Content Placeholder 2">
             <a:extLst>
               <a:ext uri="{FF2B5EF4-FFF2-40B4-BE49-F238E27FC236}">
-                <a16:creationId xmlns:a16="http://schemas.microsoft.com/office/drawing/2014/main" xmlns="" id="{47654F44-B3B5-5746-93E9-8536EF5C9CF8}"/>
+                <a16:creationId xmlns:a16="http://schemas.microsoft.com/office/drawing/2014/main" id="{47654F44-B3B5-5746-93E9-8536EF5C9CF8}"/>
               </a:ext>
             </a:extLst>
           </p:cNvPr>
@@ -22000,7 +22000,7 @@
           <p:cNvPr id="2" name="Title 1">
             <a:extLst>
               <a:ext uri="{FF2B5EF4-FFF2-40B4-BE49-F238E27FC236}">
-                <a16:creationId xmlns:a16="http://schemas.microsoft.com/office/drawing/2014/main" xmlns="" id="{E0197DAE-2794-2A48-B881-72AD9F2E19E6}"/>
+                <a16:creationId xmlns:a16="http://schemas.microsoft.com/office/drawing/2014/main" id="{E0197DAE-2794-2A48-B881-72AD9F2E19E6}"/>
               </a:ext>
             </a:extLst>
           </p:cNvPr>
@@ -22028,7 +22028,7 @@
           <p:cNvPr id="3" name="Content Placeholder 2">
             <a:extLst>
               <a:ext uri="{FF2B5EF4-FFF2-40B4-BE49-F238E27FC236}">
-                <a16:creationId xmlns:a16="http://schemas.microsoft.com/office/drawing/2014/main" xmlns="" id="{47654F44-B3B5-5746-93E9-8536EF5C9CF8}"/>
+                <a16:creationId xmlns:a16="http://schemas.microsoft.com/office/drawing/2014/main" id="{47654F44-B3B5-5746-93E9-8536EF5C9CF8}"/>
               </a:ext>
             </a:extLst>
           </p:cNvPr>
@@ -22438,7 +22438,7 @@
           <p:cNvPr id="2" name="Title 1">
             <a:extLst>
               <a:ext uri="{FF2B5EF4-FFF2-40B4-BE49-F238E27FC236}">
-                <a16:creationId xmlns:a16="http://schemas.microsoft.com/office/drawing/2014/main" xmlns="" id="{E0197DAE-2794-2A48-B881-72AD9F2E19E6}"/>
+                <a16:creationId xmlns:a16="http://schemas.microsoft.com/office/drawing/2014/main" id="{E0197DAE-2794-2A48-B881-72AD9F2E19E6}"/>
               </a:ext>
             </a:extLst>
           </p:cNvPr>
@@ -22471,7 +22471,7 @@
           <p:cNvPr id="3" name="Content Placeholder 2">
             <a:extLst>
               <a:ext uri="{FF2B5EF4-FFF2-40B4-BE49-F238E27FC236}">
-                <a16:creationId xmlns:a16="http://schemas.microsoft.com/office/drawing/2014/main" xmlns="" id="{47654F44-B3B5-5746-93E9-8536EF5C9CF8}"/>
+                <a16:creationId xmlns:a16="http://schemas.microsoft.com/office/drawing/2014/main" id="{47654F44-B3B5-5746-93E9-8536EF5C9CF8}"/>
               </a:ext>
             </a:extLst>
           </p:cNvPr>
@@ -22886,7 +22886,7 @@
           <p:cNvPr id="7" name="TextBox 6">
             <a:extLst>
               <a:ext uri="{FF2B5EF4-FFF2-40B4-BE49-F238E27FC236}">
-                <a16:creationId xmlns:a16="http://schemas.microsoft.com/office/drawing/2014/main" xmlns="" id="{0DF561A9-2CEB-8D4D-BD38-A0C4054C9415}"/>
+                <a16:creationId xmlns:a16="http://schemas.microsoft.com/office/drawing/2014/main" id="{0DF561A9-2CEB-8D4D-BD38-A0C4054C9415}"/>
               </a:ext>
             </a:extLst>
           </p:cNvPr>
@@ -22999,7 +22999,7 @@
           <p:cNvPr id="2" name="Title 1">
             <a:extLst>
               <a:ext uri="{FF2B5EF4-FFF2-40B4-BE49-F238E27FC236}">
-                <a16:creationId xmlns:a16="http://schemas.microsoft.com/office/drawing/2014/main" xmlns="" id="{E0197DAE-2794-2A48-B881-72AD9F2E19E6}"/>
+                <a16:creationId xmlns:a16="http://schemas.microsoft.com/office/drawing/2014/main" id="{E0197DAE-2794-2A48-B881-72AD9F2E19E6}"/>
               </a:ext>
             </a:extLst>
           </p:cNvPr>
@@ -23032,7 +23032,7 @@
           <p:cNvPr id="3" name="Content Placeholder 2">
             <a:extLst>
               <a:ext uri="{FF2B5EF4-FFF2-40B4-BE49-F238E27FC236}">
-                <a16:creationId xmlns:a16="http://schemas.microsoft.com/office/drawing/2014/main" xmlns="" id="{47654F44-B3B5-5746-93E9-8536EF5C9CF8}"/>
+                <a16:creationId xmlns:a16="http://schemas.microsoft.com/office/drawing/2014/main" id="{47654F44-B3B5-5746-93E9-8536EF5C9CF8}"/>
               </a:ext>
             </a:extLst>
           </p:cNvPr>
@@ -23377,7 +23377,7 @@
           <p:cNvPr id="2" name="Title 1">
             <a:extLst>
               <a:ext uri="{FF2B5EF4-FFF2-40B4-BE49-F238E27FC236}">
-                <a16:creationId xmlns:a16="http://schemas.microsoft.com/office/drawing/2014/main" xmlns="" id="{E0197DAE-2794-2A48-B881-72AD9F2E19E6}"/>
+                <a16:creationId xmlns:a16="http://schemas.microsoft.com/office/drawing/2014/main" id="{E0197DAE-2794-2A48-B881-72AD9F2E19E6}"/>
               </a:ext>
             </a:extLst>
           </p:cNvPr>
@@ -23410,7 +23410,7 @@
           <p:cNvPr id="3" name="Content Placeholder 2">
             <a:extLst>
               <a:ext uri="{FF2B5EF4-FFF2-40B4-BE49-F238E27FC236}">
-                <a16:creationId xmlns:a16="http://schemas.microsoft.com/office/drawing/2014/main" xmlns="" id="{47654F44-B3B5-5746-93E9-8536EF5C9CF8}"/>
+                <a16:creationId xmlns:a16="http://schemas.microsoft.com/office/drawing/2014/main" id="{47654F44-B3B5-5746-93E9-8536EF5C9CF8}"/>
               </a:ext>
             </a:extLst>
           </p:cNvPr>
@@ -23738,7 +23738,7 @@
           <p:cNvPr id="2" name="Title 1">
             <a:extLst>
               <a:ext uri="{FF2B5EF4-FFF2-40B4-BE49-F238E27FC236}">
-                <a16:creationId xmlns:a16="http://schemas.microsoft.com/office/drawing/2014/main" xmlns="" id="{E0197DAE-2794-2A48-B881-72AD9F2E19E6}"/>
+                <a16:creationId xmlns:a16="http://schemas.microsoft.com/office/drawing/2014/main" id="{E0197DAE-2794-2A48-B881-72AD9F2E19E6}"/>
               </a:ext>
             </a:extLst>
           </p:cNvPr>
@@ -23771,7 +23771,7 @@
           <p:cNvPr id="3" name="Content Placeholder 2">
             <a:extLst>
               <a:ext uri="{FF2B5EF4-FFF2-40B4-BE49-F238E27FC236}">
-                <a16:creationId xmlns:a16="http://schemas.microsoft.com/office/drawing/2014/main" xmlns="" id="{47654F44-B3B5-5746-93E9-8536EF5C9CF8}"/>
+                <a16:creationId xmlns:a16="http://schemas.microsoft.com/office/drawing/2014/main" id="{47654F44-B3B5-5746-93E9-8536EF5C9CF8}"/>
               </a:ext>
             </a:extLst>
           </p:cNvPr>
@@ -24227,56 +24227,56 @@
                 <a:gridCol w="1781759">
                   <a:extLst>
                     <a:ext uri="{9D8B030D-6E8A-4147-A177-3AD203B41FA5}">
-                      <a16:colId xmlns:a16="http://schemas.microsoft.com/office/drawing/2014/main" xmlns="" val="4070237601"/>
+                      <a16:colId xmlns:a16="http://schemas.microsoft.com/office/drawing/2014/main" val="4070237601"/>
                     </a:ext>
                   </a:extLst>
                 </a:gridCol>
                 <a:gridCol w="1771308">
                   <a:extLst>
                     <a:ext uri="{9D8B030D-6E8A-4147-A177-3AD203B41FA5}">
-                      <a16:colId xmlns:a16="http://schemas.microsoft.com/office/drawing/2014/main" xmlns="" val="2176141039"/>
+                      <a16:colId xmlns:a16="http://schemas.microsoft.com/office/drawing/2014/main" val="2176141039"/>
                     </a:ext>
                   </a:extLst>
                 </a:gridCol>
                 <a:gridCol w="787157">
                   <a:extLst>
                     <a:ext uri="{9D8B030D-6E8A-4147-A177-3AD203B41FA5}">
-                      <a16:colId xmlns:a16="http://schemas.microsoft.com/office/drawing/2014/main" xmlns="" val="1279049190"/>
+                      <a16:colId xmlns:a16="http://schemas.microsoft.com/office/drawing/2014/main" val="1279049190"/>
                     </a:ext>
                   </a:extLst>
                 </a:gridCol>
                 <a:gridCol w="1534529">
                   <a:extLst>
                     <a:ext uri="{9D8B030D-6E8A-4147-A177-3AD203B41FA5}">
-                      <a16:colId xmlns:a16="http://schemas.microsoft.com/office/drawing/2014/main" xmlns="" val="360597995"/>
+                      <a16:colId xmlns:a16="http://schemas.microsoft.com/office/drawing/2014/main" val="360597995"/>
                     </a:ext>
                   </a:extLst>
                 </a:gridCol>
                 <a:gridCol w="758739">
                   <a:extLst>
                     <a:ext uri="{9D8B030D-6E8A-4147-A177-3AD203B41FA5}">
-                      <a16:colId xmlns:a16="http://schemas.microsoft.com/office/drawing/2014/main" xmlns="" val="3021564120"/>
+                      <a16:colId xmlns:a16="http://schemas.microsoft.com/office/drawing/2014/main" val="3021564120"/>
                     </a:ext>
                   </a:extLst>
                 </a:gridCol>
                 <a:gridCol w="1270249">
                   <a:extLst>
                     <a:ext uri="{9D8B030D-6E8A-4147-A177-3AD203B41FA5}">
-                      <a16:colId xmlns:a16="http://schemas.microsoft.com/office/drawing/2014/main" xmlns="" val="1813909588"/>
+                      <a16:colId xmlns:a16="http://schemas.microsoft.com/office/drawing/2014/main" val="1813909588"/>
                     </a:ext>
                   </a:extLst>
                 </a:gridCol>
                 <a:gridCol w="1534529">
                   <a:extLst>
                     <a:ext uri="{9D8B030D-6E8A-4147-A177-3AD203B41FA5}">
-                      <a16:colId xmlns:a16="http://schemas.microsoft.com/office/drawing/2014/main" xmlns="" val="1278746662"/>
+                      <a16:colId xmlns:a16="http://schemas.microsoft.com/office/drawing/2014/main" val="1278746662"/>
                     </a:ext>
                   </a:extLst>
                 </a:gridCol>
                 <a:gridCol w="1534529">
                   <a:extLst>
                     <a:ext uri="{9D8B030D-6E8A-4147-A177-3AD203B41FA5}">
-                      <a16:colId xmlns:a16="http://schemas.microsoft.com/office/drawing/2014/main" xmlns="" val="539335442"/>
+                      <a16:colId xmlns:a16="http://schemas.microsoft.com/office/drawing/2014/main" val="539335442"/>
                     </a:ext>
                   </a:extLst>
                 </a:gridCol>
@@ -24412,7 +24412,7 @@
                 </a:tc>
                 <a:extLst>
                   <a:ext uri="{0D108BD9-81ED-4DB2-BD59-A6C34878D82A}">
-                    <a16:rowId xmlns:a16="http://schemas.microsoft.com/office/drawing/2014/main" xmlns="" val="4204937884"/>
+                    <a16:rowId xmlns:a16="http://schemas.microsoft.com/office/drawing/2014/main" val="4204937884"/>
                   </a:ext>
                 </a:extLst>
               </a:tr>
@@ -24533,7 +24533,7 @@
                 </a:tc>
                 <a:extLst>
                   <a:ext uri="{0D108BD9-81ED-4DB2-BD59-A6C34878D82A}">
-                    <a16:rowId xmlns:a16="http://schemas.microsoft.com/office/drawing/2014/main" xmlns="" val="1664324930"/>
+                    <a16:rowId xmlns:a16="http://schemas.microsoft.com/office/drawing/2014/main" val="1664324930"/>
                   </a:ext>
                 </a:extLst>
               </a:tr>
@@ -24671,7 +24671,7 @@
                 </a:tc>
                 <a:extLst>
                   <a:ext uri="{0D108BD9-81ED-4DB2-BD59-A6C34878D82A}">
-                    <a16:rowId xmlns:a16="http://schemas.microsoft.com/office/drawing/2014/main" xmlns="" val="3442888030"/>
+                    <a16:rowId xmlns:a16="http://schemas.microsoft.com/office/drawing/2014/main" val="3442888030"/>
                   </a:ext>
                 </a:extLst>
               </a:tr>
@@ -24808,7 +24808,7 @@
                 </a:tc>
                 <a:extLst>
                   <a:ext uri="{0D108BD9-81ED-4DB2-BD59-A6C34878D82A}">
-                    <a16:rowId xmlns:a16="http://schemas.microsoft.com/office/drawing/2014/main" xmlns="" val="1067306469"/>
+                    <a16:rowId xmlns:a16="http://schemas.microsoft.com/office/drawing/2014/main" val="1067306469"/>
                   </a:ext>
                 </a:extLst>
               </a:tr>
@@ -24928,7 +24928,7 @@
                 </a:tc>
                 <a:extLst>
                   <a:ext uri="{0D108BD9-81ED-4DB2-BD59-A6C34878D82A}">
-                    <a16:rowId xmlns:a16="http://schemas.microsoft.com/office/drawing/2014/main" xmlns="" val="1144237521"/>
+                    <a16:rowId xmlns:a16="http://schemas.microsoft.com/office/drawing/2014/main" val="1144237521"/>
                   </a:ext>
                 </a:extLst>
               </a:tr>
@@ -25048,7 +25048,7 @@
                 </a:tc>
                 <a:extLst>
                   <a:ext uri="{0D108BD9-81ED-4DB2-BD59-A6C34878D82A}">
-                    <a16:rowId xmlns:a16="http://schemas.microsoft.com/office/drawing/2014/main" xmlns="" val="2763584230"/>
+                    <a16:rowId xmlns:a16="http://schemas.microsoft.com/office/drawing/2014/main" val="2763584230"/>
                   </a:ext>
                 </a:extLst>
               </a:tr>
@@ -25091,7 +25091,7 @@
           <p:cNvPr id="2" name="Title 1">
             <a:extLst>
               <a:ext uri="{FF2B5EF4-FFF2-40B4-BE49-F238E27FC236}">
-                <a16:creationId xmlns:a16="http://schemas.microsoft.com/office/drawing/2014/main" xmlns="" id="{E0197DAE-2794-2A48-B881-72AD9F2E19E6}"/>
+                <a16:creationId xmlns:a16="http://schemas.microsoft.com/office/drawing/2014/main" id="{E0197DAE-2794-2A48-B881-72AD9F2E19E6}"/>
               </a:ext>
             </a:extLst>
           </p:cNvPr>
@@ -25124,7 +25124,7 @@
           <p:cNvPr id="3" name="Content Placeholder 2">
             <a:extLst>
               <a:ext uri="{FF2B5EF4-FFF2-40B4-BE49-F238E27FC236}">
-                <a16:creationId xmlns:a16="http://schemas.microsoft.com/office/drawing/2014/main" xmlns="" id="{47654F44-B3B5-5746-93E9-8536EF5C9CF8}"/>
+                <a16:creationId xmlns:a16="http://schemas.microsoft.com/office/drawing/2014/main" id="{47654F44-B3B5-5746-93E9-8536EF5C9CF8}"/>
               </a:ext>
             </a:extLst>
           </p:cNvPr>
@@ -25425,7 +25425,7 @@
           <p:cNvPr id="2" name="Title 1">
             <a:extLst>
               <a:ext uri="{FF2B5EF4-FFF2-40B4-BE49-F238E27FC236}">
-                <a16:creationId xmlns:a16="http://schemas.microsoft.com/office/drawing/2014/main" xmlns="" id="{E0197DAE-2794-2A48-B881-72AD9F2E19E6}"/>
+                <a16:creationId xmlns:a16="http://schemas.microsoft.com/office/drawing/2014/main" id="{E0197DAE-2794-2A48-B881-72AD9F2E19E6}"/>
               </a:ext>
             </a:extLst>
           </p:cNvPr>
@@ -25458,7 +25458,7 @@
           <p:cNvPr id="3" name="Content Placeholder 2">
             <a:extLst>
               <a:ext uri="{FF2B5EF4-FFF2-40B4-BE49-F238E27FC236}">
-                <a16:creationId xmlns:a16="http://schemas.microsoft.com/office/drawing/2014/main" xmlns="" id="{47654F44-B3B5-5746-93E9-8536EF5C9CF8}"/>
+                <a16:creationId xmlns:a16="http://schemas.microsoft.com/office/drawing/2014/main" id="{47654F44-B3B5-5746-93E9-8536EF5C9CF8}"/>
               </a:ext>
             </a:extLst>
           </p:cNvPr>
@@ -25645,7 +25645,7 @@
           <p:cNvPr id="7170" name="Picture 2" descr="Ascending">
             <a:extLst>
               <a:ext uri="{FF2B5EF4-FFF2-40B4-BE49-F238E27FC236}">
-                <a16:creationId xmlns:a16="http://schemas.microsoft.com/office/drawing/2014/main" xmlns="" id="{C65215BD-5B57-4044-9931-72150E751D6E}"/>
+                <a16:creationId xmlns:a16="http://schemas.microsoft.com/office/drawing/2014/main" id="{C65215BD-5B57-4044-9931-72150E751D6E}"/>
               </a:ext>
             </a:extLst>
           </p:cNvPr>
@@ -25692,7 +25692,7 @@
           <p:cNvPr id="7171" name="Picture 3" descr="Edit">
             <a:extLst>
               <a:ext uri="{FF2B5EF4-FFF2-40B4-BE49-F238E27FC236}">
-                <a16:creationId xmlns:a16="http://schemas.microsoft.com/office/drawing/2014/main" xmlns="" id="{D5ED79AF-4A18-B345-B840-D9842E34EB87}"/>
+                <a16:creationId xmlns:a16="http://schemas.microsoft.com/office/drawing/2014/main" id="{D5ED79AF-4A18-B345-B840-D9842E34EB87}"/>
               </a:ext>
             </a:extLst>
           </p:cNvPr>
@@ -25739,7 +25739,7 @@
           <p:cNvPr id="7172" name="Picture 4" descr="Copy">
             <a:extLst>
               <a:ext uri="{FF2B5EF4-FFF2-40B4-BE49-F238E27FC236}">
-                <a16:creationId xmlns:a16="http://schemas.microsoft.com/office/drawing/2014/main" xmlns="" id="{FBA6165E-BBB3-264F-B659-7BADC52A277D}"/>
+                <a16:creationId xmlns:a16="http://schemas.microsoft.com/office/drawing/2014/main" id="{FBA6165E-BBB3-264F-B659-7BADC52A277D}"/>
               </a:ext>
             </a:extLst>
           </p:cNvPr>
@@ -25786,7 +25786,7 @@
           <p:cNvPr id="7173" name="Picture 5" descr="Delete">
             <a:extLst>
               <a:ext uri="{FF2B5EF4-FFF2-40B4-BE49-F238E27FC236}">
-                <a16:creationId xmlns:a16="http://schemas.microsoft.com/office/drawing/2014/main" xmlns="" id="{9D5E0143-2F09-FC40-9496-179295E448A3}"/>
+                <a16:creationId xmlns:a16="http://schemas.microsoft.com/office/drawing/2014/main" id="{9D5E0143-2F09-FC40-9496-179295E448A3}"/>
               </a:ext>
             </a:extLst>
           </p:cNvPr>
@@ -25833,7 +25833,7 @@
           <p:cNvPr id="7174" name="Picture 6" descr="Edit">
             <a:extLst>
               <a:ext uri="{FF2B5EF4-FFF2-40B4-BE49-F238E27FC236}">
-                <a16:creationId xmlns:a16="http://schemas.microsoft.com/office/drawing/2014/main" xmlns="" id="{3DED508C-7EC1-BB40-A157-108A6709112F}"/>
+                <a16:creationId xmlns:a16="http://schemas.microsoft.com/office/drawing/2014/main" id="{3DED508C-7EC1-BB40-A157-108A6709112F}"/>
               </a:ext>
             </a:extLst>
           </p:cNvPr>
@@ -25880,7 +25880,7 @@
           <p:cNvPr id="7175" name="Picture 7" descr="Copy">
             <a:extLst>
               <a:ext uri="{FF2B5EF4-FFF2-40B4-BE49-F238E27FC236}">
-                <a16:creationId xmlns:a16="http://schemas.microsoft.com/office/drawing/2014/main" xmlns="" id="{FC190F5E-B29D-6344-996E-E87C33A1C30A}"/>
+                <a16:creationId xmlns:a16="http://schemas.microsoft.com/office/drawing/2014/main" id="{FC190F5E-B29D-6344-996E-E87C33A1C30A}"/>
               </a:ext>
             </a:extLst>
           </p:cNvPr>
@@ -25927,7 +25927,7 @@
           <p:cNvPr id="7176" name="Picture 8" descr="Delete">
             <a:extLst>
               <a:ext uri="{FF2B5EF4-FFF2-40B4-BE49-F238E27FC236}">
-                <a16:creationId xmlns:a16="http://schemas.microsoft.com/office/drawing/2014/main" xmlns="" id="{27FD3534-0333-B04B-9A1D-C1016297D742}"/>
+                <a16:creationId xmlns:a16="http://schemas.microsoft.com/office/drawing/2014/main" id="{27FD3534-0333-B04B-9A1D-C1016297D742}"/>
               </a:ext>
             </a:extLst>
           </p:cNvPr>
@@ -25974,7 +25974,7 @@
           <p:cNvPr id="7177" name="Picture 9" descr="Edit">
             <a:extLst>
               <a:ext uri="{FF2B5EF4-FFF2-40B4-BE49-F238E27FC236}">
-                <a16:creationId xmlns:a16="http://schemas.microsoft.com/office/drawing/2014/main" xmlns="" id="{E6B3C597-A2C0-5641-8FA6-A4C08CB3D95E}"/>
+                <a16:creationId xmlns:a16="http://schemas.microsoft.com/office/drawing/2014/main" id="{E6B3C597-A2C0-5641-8FA6-A4C08CB3D95E}"/>
               </a:ext>
             </a:extLst>
           </p:cNvPr>
@@ -26021,7 +26021,7 @@
           <p:cNvPr id="7178" name="Picture 10" descr="Copy">
             <a:extLst>
               <a:ext uri="{FF2B5EF4-FFF2-40B4-BE49-F238E27FC236}">
-                <a16:creationId xmlns:a16="http://schemas.microsoft.com/office/drawing/2014/main" xmlns="" id="{2E3E32CB-7E12-0545-A423-68FACE7C7693}"/>
+                <a16:creationId xmlns:a16="http://schemas.microsoft.com/office/drawing/2014/main" id="{2E3E32CB-7E12-0545-A423-68FACE7C7693}"/>
               </a:ext>
             </a:extLst>
           </p:cNvPr>
@@ -26068,7 +26068,7 @@
           <p:cNvPr id="7179" name="Picture 11" descr="Delete">
             <a:extLst>
               <a:ext uri="{FF2B5EF4-FFF2-40B4-BE49-F238E27FC236}">
-                <a16:creationId xmlns:a16="http://schemas.microsoft.com/office/drawing/2014/main" xmlns="" id="{A3DD466D-EEBC-B349-B9B9-6FBA1FCCFA53}"/>
+                <a16:creationId xmlns:a16="http://schemas.microsoft.com/office/drawing/2014/main" id="{A3DD466D-EEBC-B349-B9B9-6FBA1FCCFA53}"/>
               </a:ext>
             </a:extLst>
           </p:cNvPr>
@@ -26115,7 +26115,7 @@
           <p:cNvPr id="7180" name="Picture 12" descr="Edit">
             <a:extLst>
               <a:ext uri="{FF2B5EF4-FFF2-40B4-BE49-F238E27FC236}">
-                <a16:creationId xmlns:a16="http://schemas.microsoft.com/office/drawing/2014/main" xmlns="" id="{74CA1543-4767-0443-99BD-551F5E25CA15}"/>
+                <a16:creationId xmlns:a16="http://schemas.microsoft.com/office/drawing/2014/main" id="{74CA1543-4767-0443-99BD-551F5E25CA15}"/>
               </a:ext>
             </a:extLst>
           </p:cNvPr>
@@ -26162,7 +26162,7 @@
           <p:cNvPr id="7181" name="Picture 13" descr="Copy">
             <a:extLst>
               <a:ext uri="{FF2B5EF4-FFF2-40B4-BE49-F238E27FC236}">
-                <a16:creationId xmlns:a16="http://schemas.microsoft.com/office/drawing/2014/main" xmlns="" id="{349B3A53-E673-E148-B870-02F442734CE7}"/>
+                <a16:creationId xmlns:a16="http://schemas.microsoft.com/office/drawing/2014/main" id="{349B3A53-E673-E148-B870-02F442734CE7}"/>
               </a:ext>
             </a:extLst>
           </p:cNvPr>
@@ -26209,7 +26209,7 @@
           <p:cNvPr id="7182" name="Picture 14" descr="Delete">
             <a:extLst>
               <a:ext uri="{FF2B5EF4-FFF2-40B4-BE49-F238E27FC236}">
-                <a16:creationId xmlns:a16="http://schemas.microsoft.com/office/drawing/2014/main" xmlns="" id="{D306A5A9-DCC8-4549-8C94-2F85523CE0E4}"/>
+                <a16:creationId xmlns:a16="http://schemas.microsoft.com/office/drawing/2014/main" id="{D306A5A9-DCC8-4549-8C94-2F85523CE0E4}"/>
               </a:ext>
             </a:extLst>
           </p:cNvPr>
@@ -26256,7 +26256,7 @@
           <p:cNvPr id="7183" name="Picture 15" descr="Edit">
             <a:extLst>
               <a:ext uri="{FF2B5EF4-FFF2-40B4-BE49-F238E27FC236}">
-                <a16:creationId xmlns:a16="http://schemas.microsoft.com/office/drawing/2014/main" xmlns="" id="{21E5A904-E74A-6B46-AE2E-F5BCC53BCDBB}"/>
+                <a16:creationId xmlns:a16="http://schemas.microsoft.com/office/drawing/2014/main" id="{21E5A904-E74A-6B46-AE2E-F5BCC53BCDBB}"/>
               </a:ext>
             </a:extLst>
           </p:cNvPr>
@@ -26303,7 +26303,7 @@
           <p:cNvPr id="7184" name="Picture 16" descr="Copy">
             <a:extLst>
               <a:ext uri="{FF2B5EF4-FFF2-40B4-BE49-F238E27FC236}">
-                <a16:creationId xmlns:a16="http://schemas.microsoft.com/office/drawing/2014/main" xmlns="" id="{90E2174F-801A-484F-9F9D-0F68A3E71E32}"/>
+                <a16:creationId xmlns:a16="http://schemas.microsoft.com/office/drawing/2014/main" id="{90E2174F-801A-484F-9F9D-0F68A3E71E32}"/>
               </a:ext>
             </a:extLst>
           </p:cNvPr>
@@ -26350,7 +26350,7 @@
           <p:cNvPr id="7185" name="Picture 17" descr="Delete">
             <a:extLst>
               <a:ext uri="{FF2B5EF4-FFF2-40B4-BE49-F238E27FC236}">
-                <a16:creationId xmlns:a16="http://schemas.microsoft.com/office/drawing/2014/main" xmlns="" id="{94133C48-B1C7-AA49-92AC-8F9331F19398}"/>
+                <a16:creationId xmlns:a16="http://schemas.microsoft.com/office/drawing/2014/main" id="{94133C48-B1C7-AA49-92AC-8F9331F19398}"/>
               </a:ext>
             </a:extLst>
           </p:cNvPr>
@@ -26397,7 +26397,7 @@
           <p:cNvPr id="7186" name="Picture 18" descr="Edit">
             <a:extLst>
               <a:ext uri="{FF2B5EF4-FFF2-40B4-BE49-F238E27FC236}">
-                <a16:creationId xmlns:a16="http://schemas.microsoft.com/office/drawing/2014/main" xmlns="" id="{2E1311ED-F149-084C-A8F4-E6397E967C51}"/>
+                <a16:creationId xmlns:a16="http://schemas.microsoft.com/office/drawing/2014/main" id="{2E1311ED-F149-084C-A8F4-E6397E967C51}"/>
               </a:ext>
             </a:extLst>
           </p:cNvPr>
@@ -26444,7 +26444,7 @@
           <p:cNvPr id="7187" name="Picture 19" descr="Copy">
             <a:extLst>
               <a:ext uri="{FF2B5EF4-FFF2-40B4-BE49-F238E27FC236}">
-                <a16:creationId xmlns:a16="http://schemas.microsoft.com/office/drawing/2014/main" xmlns="" id="{C030EA95-28E1-3A4E-9286-06ED81A83917}"/>
+                <a16:creationId xmlns:a16="http://schemas.microsoft.com/office/drawing/2014/main" id="{C030EA95-28E1-3A4E-9286-06ED81A83917}"/>
               </a:ext>
             </a:extLst>
           </p:cNvPr>
@@ -26491,7 +26491,7 @@
           <p:cNvPr id="7188" name="Picture 20" descr="Delete">
             <a:extLst>
               <a:ext uri="{FF2B5EF4-FFF2-40B4-BE49-F238E27FC236}">
-                <a16:creationId xmlns:a16="http://schemas.microsoft.com/office/drawing/2014/main" xmlns="" id="{7760BD29-0768-7740-AE93-754B4A8E9EC7}"/>
+                <a16:creationId xmlns:a16="http://schemas.microsoft.com/office/drawing/2014/main" id="{7760BD29-0768-7740-AE93-754B4A8E9EC7}"/>
               </a:ext>
             </a:extLst>
           </p:cNvPr>
@@ -26538,7 +26538,7 @@
           <p:cNvPr id="7189" name="Picture 21" descr="Edit">
             <a:extLst>
               <a:ext uri="{FF2B5EF4-FFF2-40B4-BE49-F238E27FC236}">
-                <a16:creationId xmlns:a16="http://schemas.microsoft.com/office/drawing/2014/main" xmlns="" id="{86EE7E1D-B3BB-B34A-A34A-821AF5F8742A}"/>
+                <a16:creationId xmlns:a16="http://schemas.microsoft.com/office/drawing/2014/main" id="{86EE7E1D-B3BB-B34A-A34A-821AF5F8742A}"/>
               </a:ext>
             </a:extLst>
           </p:cNvPr>
@@ -26585,7 +26585,7 @@
           <p:cNvPr id="7190" name="Picture 22" descr="Copy">
             <a:extLst>
               <a:ext uri="{FF2B5EF4-FFF2-40B4-BE49-F238E27FC236}">
-                <a16:creationId xmlns:a16="http://schemas.microsoft.com/office/drawing/2014/main" xmlns="" id="{862F129A-C396-C448-8B35-9E5ECB71A3FC}"/>
+                <a16:creationId xmlns:a16="http://schemas.microsoft.com/office/drawing/2014/main" id="{862F129A-C396-C448-8B35-9E5ECB71A3FC}"/>
               </a:ext>
             </a:extLst>
           </p:cNvPr>
@@ -26632,7 +26632,7 @@
           <p:cNvPr id="7191" name="Picture 23" descr="Delete">
             <a:extLst>
               <a:ext uri="{FF2B5EF4-FFF2-40B4-BE49-F238E27FC236}">
-                <a16:creationId xmlns:a16="http://schemas.microsoft.com/office/drawing/2014/main" xmlns="" id="{E533F4DC-FC7E-B84C-8A4A-72573BFF7813}"/>
+                <a16:creationId xmlns:a16="http://schemas.microsoft.com/office/drawing/2014/main" id="{E533F4DC-FC7E-B84C-8A4A-72573BFF7813}"/>
               </a:ext>
             </a:extLst>
           </p:cNvPr>
@@ -26679,7 +26679,7 @@
           <p:cNvPr id="7192" name="Picture 24" descr="Edit">
             <a:extLst>
               <a:ext uri="{FF2B5EF4-FFF2-40B4-BE49-F238E27FC236}">
-                <a16:creationId xmlns:a16="http://schemas.microsoft.com/office/drawing/2014/main" xmlns="" id="{305AC1A0-001A-B24C-AC0C-ED44BB393A92}"/>
+                <a16:creationId xmlns:a16="http://schemas.microsoft.com/office/drawing/2014/main" id="{305AC1A0-001A-B24C-AC0C-ED44BB393A92}"/>
               </a:ext>
             </a:extLst>
           </p:cNvPr>
@@ -26726,7 +26726,7 @@
           <p:cNvPr id="7193" name="Picture 25" descr="Copy">
             <a:extLst>
               <a:ext uri="{FF2B5EF4-FFF2-40B4-BE49-F238E27FC236}">
-                <a16:creationId xmlns:a16="http://schemas.microsoft.com/office/drawing/2014/main" xmlns="" id="{81A9DE29-9C1E-774E-826F-E08F62769A62}"/>
+                <a16:creationId xmlns:a16="http://schemas.microsoft.com/office/drawing/2014/main" id="{81A9DE29-9C1E-774E-826F-E08F62769A62}"/>
               </a:ext>
             </a:extLst>
           </p:cNvPr>
@@ -26773,7 +26773,7 @@
           <p:cNvPr id="7194" name="Picture 26" descr="Delete">
             <a:extLst>
               <a:ext uri="{FF2B5EF4-FFF2-40B4-BE49-F238E27FC236}">
-                <a16:creationId xmlns:a16="http://schemas.microsoft.com/office/drawing/2014/main" xmlns="" id="{28F49F1F-10C7-5245-93C9-55935E0A7997}"/>
+                <a16:creationId xmlns:a16="http://schemas.microsoft.com/office/drawing/2014/main" id="{28F49F1F-10C7-5245-93C9-55935E0A7997}"/>
               </a:ext>
             </a:extLst>
           </p:cNvPr>
@@ -26820,7 +26820,7 @@
           <p:cNvPr id="7195" name="Picture 27" descr="Edit">
             <a:extLst>
               <a:ext uri="{FF2B5EF4-FFF2-40B4-BE49-F238E27FC236}">
-                <a16:creationId xmlns:a16="http://schemas.microsoft.com/office/drawing/2014/main" xmlns="" id="{8F192FC9-44DB-C243-A214-73178E222CCE}"/>
+                <a16:creationId xmlns:a16="http://schemas.microsoft.com/office/drawing/2014/main" id="{8F192FC9-44DB-C243-A214-73178E222CCE}"/>
               </a:ext>
             </a:extLst>
           </p:cNvPr>
@@ -26867,7 +26867,7 @@
           <p:cNvPr id="7196" name="Picture 28" descr="Copy">
             <a:extLst>
               <a:ext uri="{FF2B5EF4-FFF2-40B4-BE49-F238E27FC236}">
-                <a16:creationId xmlns:a16="http://schemas.microsoft.com/office/drawing/2014/main" xmlns="" id="{C5548135-F3BC-1744-AB44-4104A61009EF}"/>
+                <a16:creationId xmlns:a16="http://schemas.microsoft.com/office/drawing/2014/main" id="{C5548135-F3BC-1744-AB44-4104A61009EF}"/>
               </a:ext>
             </a:extLst>
           </p:cNvPr>
@@ -26914,7 +26914,7 @@
           <p:cNvPr id="7197" name="Picture 29" descr="Delete">
             <a:extLst>
               <a:ext uri="{FF2B5EF4-FFF2-40B4-BE49-F238E27FC236}">
-                <a16:creationId xmlns:a16="http://schemas.microsoft.com/office/drawing/2014/main" xmlns="" id="{7361ED48-0603-A84B-BC4A-3B378B4536EA}"/>
+                <a16:creationId xmlns:a16="http://schemas.microsoft.com/office/drawing/2014/main" id="{7361ED48-0603-A84B-BC4A-3B378B4536EA}"/>
               </a:ext>
             </a:extLst>
           </p:cNvPr>
@@ -26961,7 +26961,7 @@
           <p:cNvPr id="7198" name="Picture 30" descr="Edit">
             <a:extLst>
               <a:ext uri="{FF2B5EF4-FFF2-40B4-BE49-F238E27FC236}">
-                <a16:creationId xmlns:a16="http://schemas.microsoft.com/office/drawing/2014/main" xmlns="" id="{6F1966E0-4F34-0B47-8CF1-2CB129A2B5BD}"/>
+                <a16:creationId xmlns:a16="http://schemas.microsoft.com/office/drawing/2014/main" id="{6F1966E0-4F34-0B47-8CF1-2CB129A2B5BD}"/>
               </a:ext>
             </a:extLst>
           </p:cNvPr>
@@ -27008,7 +27008,7 @@
           <p:cNvPr id="7199" name="Picture 31" descr="Copy">
             <a:extLst>
               <a:ext uri="{FF2B5EF4-FFF2-40B4-BE49-F238E27FC236}">
-                <a16:creationId xmlns:a16="http://schemas.microsoft.com/office/drawing/2014/main" xmlns="" id="{4DD913C6-C486-094C-B6FB-5BDE7C23E5A0}"/>
+                <a16:creationId xmlns:a16="http://schemas.microsoft.com/office/drawing/2014/main" id="{4DD913C6-C486-094C-B6FB-5BDE7C23E5A0}"/>
               </a:ext>
             </a:extLst>
           </p:cNvPr>
@@ -27055,7 +27055,7 @@
           <p:cNvPr id="7200" name="Picture 32" descr="Delete">
             <a:extLst>
               <a:ext uri="{FF2B5EF4-FFF2-40B4-BE49-F238E27FC236}">
-                <a16:creationId xmlns:a16="http://schemas.microsoft.com/office/drawing/2014/main" xmlns="" id="{8D269F99-DE51-0044-8E70-B70960F75153}"/>
+                <a16:creationId xmlns:a16="http://schemas.microsoft.com/office/drawing/2014/main" id="{8D269F99-DE51-0044-8E70-B70960F75153}"/>
               </a:ext>
             </a:extLst>
           </p:cNvPr>
@@ -27102,7 +27102,7 @@
           <p:cNvPr id="7201" name="Picture 33" descr="Edit">
             <a:extLst>
               <a:ext uri="{FF2B5EF4-FFF2-40B4-BE49-F238E27FC236}">
-                <a16:creationId xmlns:a16="http://schemas.microsoft.com/office/drawing/2014/main" xmlns="" id="{8EEEB258-DD9F-4743-BF68-7D1DDAB51A1B}"/>
+                <a16:creationId xmlns:a16="http://schemas.microsoft.com/office/drawing/2014/main" id="{8EEEB258-DD9F-4743-BF68-7D1DDAB51A1B}"/>
               </a:ext>
             </a:extLst>
           </p:cNvPr>
@@ -27149,7 +27149,7 @@
           <p:cNvPr id="7202" name="Picture 34" descr="Copy">
             <a:extLst>
               <a:ext uri="{FF2B5EF4-FFF2-40B4-BE49-F238E27FC236}">
-                <a16:creationId xmlns:a16="http://schemas.microsoft.com/office/drawing/2014/main" xmlns="" id="{2247A77E-80FB-904D-9E00-F839C754418F}"/>
+                <a16:creationId xmlns:a16="http://schemas.microsoft.com/office/drawing/2014/main" id="{2247A77E-80FB-904D-9E00-F839C754418F}"/>
               </a:ext>
             </a:extLst>
           </p:cNvPr>
@@ -27196,7 +27196,7 @@
           <p:cNvPr id="7203" name="Picture 35" descr="Delete">
             <a:extLst>
               <a:ext uri="{FF2B5EF4-FFF2-40B4-BE49-F238E27FC236}">
-                <a16:creationId xmlns:a16="http://schemas.microsoft.com/office/drawing/2014/main" xmlns="" id="{639CC710-9294-0641-BAEA-37C6FDB55D65}"/>
+                <a16:creationId xmlns:a16="http://schemas.microsoft.com/office/drawing/2014/main" id="{639CC710-9294-0641-BAEA-37C6FDB55D65}"/>
               </a:ext>
             </a:extLst>
           </p:cNvPr>
@@ -27243,7 +27243,7 @@
           <p:cNvPr id="7204" name="Picture 36" descr="Edit">
             <a:extLst>
               <a:ext uri="{FF2B5EF4-FFF2-40B4-BE49-F238E27FC236}">
-                <a16:creationId xmlns:a16="http://schemas.microsoft.com/office/drawing/2014/main" xmlns="" id="{C1E6C482-4681-3940-94B4-6EFA7CC30FFC}"/>
+                <a16:creationId xmlns:a16="http://schemas.microsoft.com/office/drawing/2014/main" id="{C1E6C482-4681-3940-94B4-6EFA7CC30FFC}"/>
               </a:ext>
             </a:extLst>
           </p:cNvPr>
@@ -27290,7 +27290,7 @@
           <p:cNvPr id="7205" name="Picture 37" descr="Copy">
             <a:extLst>
               <a:ext uri="{FF2B5EF4-FFF2-40B4-BE49-F238E27FC236}">
-                <a16:creationId xmlns:a16="http://schemas.microsoft.com/office/drawing/2014/main" xmlns="" id="{159A1B20-2B46-C040-A4CA-DFE0FE13E26B}"/>
+                <a16:creationId xmlns:a16="http://schemas.microsoft.com/office/drawing/2014/main" id="{159A1B20-2B46-C040-A4CA-DFE0FE13E26B}"/>
               </a:ext>
             </a:extLst>
           </p:cNvPr>
@@ -27337,7 +27337,7 @@
           <p:cNvPr id="7206" name="Picture 38" descr="Delete">
             <a:extLst>
               <a:ext uri="{FF2B5EF4-FFF2-40B4-BE49-F238E27FC236}">
-                <a16:creationId xmlns:a16="http://schemas.microsoft.com/office/drawing/2014/main" xmlns="" id="{0A8381CA-320A-7249-8C48-147A19F96E41}"/>
+                <a16:creationId xmlns:a16="http://schemas.microsoft.com/office/drawing/2014/main" id="{0A8381CA-320A-7249-8C48-147A19F96E41}"/>
               </a:ext>
             </a:extLst>
           </p:cNvPr>
@@ -27384,7 +27384,7 @@
           <p:cNvPr id="7207" name="Picture 39" descr="Edit">
             <a:extLst>
               <a:ext uri="{FF2B5EF4-FFF2-40B4-BE49-F238E27FC236}">
-                <a16:creationId xmlns:a16="http://schemas.microsoft.com/office/drawing/2014/main" xmlns="" id="{23299FDB-6800-2147-B702-26AE4D8942F7}"/>
+                <a16:creationId xmlns:a16="http://schemas.microsoft.com/office/drawing/2014/main" id="{23299FDB-6800-2147-B702-26AE4D8942F7}"/>
               </a:ext>
             </a:extLst>
           </p:cNvPr>
@@ -27431,7 +27431,7 @@
           <p:cNvPr id="7208" name="Picture 40" descr="Copy">
             <a:extLst>
               <a:ext uri="{FF2B5EF4-FFF2-40B4-BE49-F238E27FC236}">
-                <a16:creationId xmlns:a16="http://schemas.microsoft.com/office/drawing/2014/main" xmlns="" id="{C9D2DC4D-C2FC-B34F-90D2-67FD46CFF270}"/>
+                <a16:creationId xmlns:a16="http://schemas.microsoft.com/office/drawing/2014/main" id="{C9D2DC4D-C2FC-B34F-90D2-67FD46CFF270}"/>
               </a:ext>
             </a:extLst>
           </p:cNvPr>
@@ -27478,7 +27478,7 @@
           <p:cNvPr id="7209" name="Picture 41" descr="Delete">
             <a:extLst>
               <a:ext uri="{FF2B5EF4-FFF2-40B4-BE49-F238E27FC236}">
-                <a16:creationId xmlns:a16="http://schemas.microsoft.com/office/drawing/2014/main" xmlns="" id="{6BBFB826-B21C-B24E-8ADD-4D6D4A2FFBC8}"/>
+                <a16:creationId xmlns:a16="http://schemas.microsoft.com/office/drawing/2014/main" id="{6BBFB826-B21C-B24E-8ADD-4D6D4A2FFBC8}"/>
               </a:ext>
             </a:extLst>
           </p:cNvPr>
@@ -27525,7 +27525,7 @@
           <p:cNvPr id="7210" name="Picture 42" descr="Edit">
             <a:extLst>
               <a:ext uri="{FF2B5EF4-FFF2-40B4-BE49-F238E27FC236}">
-                <a16:creationId xmlns:a16="http://schemas.microsoft.com/office/drawing/2014/main" xmlns="" id="{350D84E9-2CD7-394A-B4A7-2774D96F5043}"/>
+                <a16:creationId xmlns:a16="http://schemas.microsoft.com/office/drawing/2014/main" id="{350D84E9-2CD7-394A-B4A7-2774D96F5043}"/>
               </a:ext>
             </a:extLst>
           </p:cNvPr>
@@ -27572,7 +27572,7 @@
           <p:cNvPr id="7211" name="Picture 43" descr="Copy">
             <a:extLst>
               <a:ext uri="{FF2B5EF4-FFF2-40B4-BE49-F238E27FC236}">
-                <a16:creationId xmlns:a16="http://schemas.microsoft.com/office/drawing/2014/main" xmlns="" id="{F82C45A0-60D7-FE44-9E82-6C92B334058A}"/>
+                <a16:creationId xmlns:a16="http://schemas.microsoft.com/office/drawing/2014/main" id="{F82C45A0-60D7-FE44-9E82-6C92B334058A}"/>
               </a:ext>
             </a:extLst>
           </p:cNvPr>
@@ -27619,7 +27619,7 @@
           <p:cNvPr id="7212" name="Picture 44" descr="Delete">
             <a:extLst>
               <a:ext uri="{FF2B5EF4-FFF2-40B4-BE49-F238E27FC236}">
-                <a16:creationId xmlns:a16="http://schemas.microsoft.com/office/drawing/2014/main" xmlns="" id="{C180F2FA-07ED-3249-9093-DAED3656D9B0}"/>
+                <a16:creationId xmlns:a16="http://schemas.microsoft.com/office/drawing/2014/main" id="{C180F2FA-07ED-3249-9093-DAED3656D9B0}"/>
               </a:ext>
             </a:extLst>
           </p:cNvPr>
@@ -27666,7 +27666,7 @@
           <p:cNvPr id="7213" name="Picture 45" descr="Edit">
             <a:extLst>
               <a:ext uri="{FF2B5EF4-FFF2-40B4-BE49-F238E27FC236}">
-                <a16:creationId xmlns:a16="http://schemas.microsoft.com/office/drawing/2014/main" xmlns="" id="{00A1D60C-8C08-7848-93FE-C05E424E788D}"/>
+                <a16:creationId xmlns:a16="http://schemas.microsoft.com/office/drawing/2014/main" id="{00A1D60C-8C08-7848-93FE-C05E424E788D}"/>
               </a:ext>
             </a:extLst>
           </p:cNvPr>
@@ -27713,7 +27713,7 @@
           <p:cNvPr id="7214" name="Picture 46" descr="Copy">
             <a:extLst>
               <a:ext uri="{FF2B5EF4-FFF2-40B4-BE49-F238E27FC236}">
-                <a16:creationId xmlns:a16="http://schemas.microsoft.com/office/drawing/2014/main" xmlns="" id="{F8A7F605-378A-4D4D-802C-FB3A2E832619}"/>
+                <a16:creationId xmlns:a16="http://schemas.microsoft.com/office/drawing/2014/main" id="{F8A7F605-378A-4D4D-802C-FB3A2E832619}"/>
               </a:ext>
             </a:extLst>
           </p:cNvPr>
@@ -27760,7 +27760,7 @@
           <p:cNvPr id="7215" name="Picture 47" descr="Delete">
             <a:extLst>
               <a:ext uri="{FF2B5EF4-FFF2-40B4-BE49-F238E27FC236}">
-                <a16:creationId xmlns:a16="http://schemas.microsoft.com/office/drawing/2014/main" xmlns="" id="{8B9117B3-CD16-074F-82A3-D5096A4DFD68}"/>
+                <a16:creationId xmlns:a16="http://schemas.microsoft.com/office/drawing/2014/main" id="{8B9117B3-CD16-074F-82A3-D5096A4DFD68}"/>
               </a:ext>
             </a:extLst>
           </p:cNvPr>
@@ -27807,7 +27807,7 @@
           <p:cNvPr id="7216" name="Picture 48" descr="Edit">
             <a:extLst>
               <a:ext uri="{FF2B5EF4-FFF2-40B4-BE49-F238E27FC236}">
-                <a16:creationId xmlns:a16="http://schemas.microsoft.com/office/drawing/2014/main" xmlns="" id="{2FE84A72-AA0D-334A-B03A-7E066B4DEEB3}"/>
+                <a16:creationId xmlns:a16="http://schemas.microsoft.com/office/drawing/2014/main" id="{2FE84A72-AA0D-334A-B03A-7E066B4DEEB3}"/>
               </a:ext>
             </a:extLst>
           </p:cNvPr>
@@ -27854,7 +27854,7 @@
           <p:cNvPr id="7217" name="Picture 49" descr="Copy">
             <a:extLst>
               <a:ext uri="{FF2B5EF4-FFF2-40B4-BE49-F238E27FC236}">
-                <a16:creationId xmlns:a16="http://schemas.microsoft.com/office/drawing/2014/main" xmlns="" id="{E845E9CE-1525-1E40-890D-A51A605EE695}"/>
+                <a16:creationId xmlns:a16="http://schemas.microsoft.com/office/drawing/2014/main" id="{E845E9CE-1525-1E40-890D-A51A605EE695}"/>
               </a:ext>
             </a:extLst>
           </p:cNvPr>
@@ -27901,7 +27901,7 @@
           <p:cNvPr id="7218" name="Picture 50" descr="Delete">
             <a:extLst>
               <a:ext uri="{FF2B5EF4-FFF2-40B4-BE49-F238E27FC236}">
-                <a16:creationId xmlns:a16="http://schemas.microsoft.com/office/drawing/2014/main" xmlns="" id="{0FE3432E-477B-C74E-80BC-C209526F002F}"/>
+                <a16:creationId xmlns:a16="http://schemas.microsoft.com/office/drawing/2014/main" id="{0FE3432E-477B-C74E-80BC-C209526F002F}"/>
               </a:ext>
             </a:extLst>
           </p:cNvPr>
@@ -27948,7 +27948,7 @@
           <p:cNvPr id="7219" name="Picture 51" descr="Edit">
             <a:extLst>
               <a:ext uri="{FF2B5EF4-FFF2-40B4-BE49-F238E27FC236}">
-                <a16:creationId xmlns:a16="http://schemas.microsoft.com/office/drawing/2014/main" xmlns="" id="{DA98ACB1-2101-FE40-9A55-836B005D6002}"/>
+                <a16:creationId xmlns:a16="http://schemas.microsoft.com/office/drawing/2014/main" id="{DA98ACB1-2101-FE40-9A55-836B005D6002}"/>
               </a:ext>
             </a:extLst>
           </p:cNvPr>
@@ -27995,7 +27995,7 @@
           <p:cNvPr id="7220" name="Picture 52" descr="Copy">
             <a:extLst>
               <a:ext uri="{FF2B5EF4-FFF2-40B4-BE49-F238E27FC236}">
-                <a16:creationId xmlns:a16="http://schemas.microsoft.com/office/drawing/2014/main" xmlns="" id="{230D71F9-D01D-FF42-B758-EF61F22C12E6}"/>
+                <a16:creationId xmlns:a16="http://schemas.microsoft.com/office/drawing/2014/main" id="{230D71F9-D01D-FF42-B758-EF61F22C12E6}"/>
               </a:ext>
             </a:extLst>
           </p:cNvPr>
@@ -28042,7 +28042,7 @@
           <p:cNvPr id="7221" name="Picture 53" descr="Delete">
             <a:extLst>
               <a:ext uri="{FF2B5EF4-FFF2-40B4-BE49-F238E27FC236}">
-                <a16:creationId xmlns:a16="http://schemas.microsoft.com/office/drawing/2014/main" xmlns="" id="{073FE7BA-5FC2-3645-9766-0FB9DFAB6C34}"/>
+                <a16:creationId xmlns:a16="http://schemas.microsoft.com/office/drawing/2014/main" id="{073FE7BA-5FC2-3645-9766-0FB9DFAB6C34}"/>
               </a:ext>
             </a:extLst>
           </p:cNvPr>
@@ -28089,7 +28089,7 @@
           <p:cNvPr id="7222" name="Picture 54" descr="Edit">
             <a:extLst>
               <a:ext uri="{FF2B5EF4-FFF2-40B4-BE49-F238E27FC236}">
-                <a16:creationId xmlns:a16="http://schemas.microsoft.com/office/drawing/2014/main" xmlns="" id="{D9AFD85A-CE4B-484A-A5B8-BAEABB586A99}"/>
+                <a16:creationId xmlns:a16="http://schemas.microsoft.com/office/drawing/2014/main" id="{D9AFD85A-CE4B-484A-A5B8-BAEABB586A99}"/>
               </a:ext>
             </a:extLst>
           </p:cNvPr>
@@ -28136,7 +28136,7 @@
           <p:cNvPr id="7223" name="Picture 55" descr="Copy">
             <a:extLst>
               <a:ext uri="{FF2B5EF4-FFF2-40B4-BE49-F238E27FC236}">
-                <a16:creationId xmlns:a16="http://schemas.microsoft.com/office/drawing/2014/main" xmlns="" id="{A44154A1-1786-3F4C-9953-8101DE25013C}"/>
+                <a16:creationId xmlns:a16="http://schemas.microsoft.com/office/drawing/2014/main" id="{A44154A1-1786-3F4C-9953-8101DE25013C}"/>
               </a:ext>
             </a:extLst>
           </p:cNvPr>
@@ -28183,7 +28183,7 @@
           <p:cNvPr id="7224" name="Picture 56" descr="Delete">
             <a:extLst>
               <a:ext uri="{FF2B5EF4-FFF2-40B4-BE49-F238E27FC236}">
-                <a16:creationId xmlns:a16="http://schemas.microsoft.com/office/drawing/2014/main" xmlns="" id="{CDB26216-F520-9D43-9F03-CC6078D11A7C}"/>
+                <a16:creationId xmlns:a16="http://schemas.microsoft.com/office/drawing/2014/main" id="{CDB26216-F520-9D43-9F03-CC6078D11A7C}"/>
               </a:ext>
             </a:extLst>
           </p:cNvPr>
@@ -28230,7 +28230,7 @@
           <p:cNvPr id="7225" name="Picture 57" descr="Edit">
             <a:extLst>
               <a:ext uri="{FF2B5EF4-FFF2-40B4-BE49-F238E27FC236}">
-                <a16:creationId xmlns:a16="http://schemas.microsoft.com/office/drawing/2014/main" xmlns="" id="{10F1DB99-8A42-A348-AA03-2A064895E56E}"/>
+                <a16:creationId xmlns:a16="http://schemas.microsoft.com/office/drawing/2014/main" id="{10F1DB99-8A42-A348-AA03-2A064895E56E}"/>
               </a:ext>
             </a:extLst>
           </p:cNvPr>
@@ -28277,7 +28277,7 @@
           <p:cNvPr id="7226" name="Picture 58" descr="Copy">
             <a:extLst>
               <a:ext uri="{FF2B5EF4-FFF2-40B4-BE49-F238E27FC236}">
-                <a16:creationId xmlns:a16="http://schemas.microsoft.com/office/drawing/2014/main" xmlns="" id="{313C5482-C410-FE44-9B67-CFA917740410}"/>
+                <a16:creationId xmlns:a16="http://schemas.microsoft.com/office/drawing/2014/main" id="{313C5482-C410-FE44-9B67-CFA917740410}"/>
               </a:ext>
             </a:extLst>
           </p:cNvPr>
@@ -28324,7 +28324,7 @@
           <p:cNvPr id="7227" name="Picture 59" descr="Delete">
             <a:extLst>
               <a:ext uri="{FF2B5EF4-FFF2-40B4-BE49-F238E27FC236}">
-                <a16:creationId xmlns:a16="http://schemas.microsoft.com/office/drawing/2014/main" xmlns="" id="{C5120BAF-0DD1-3B4A-8782-ADEE7BB95F62}"/>
+                <a16:creationId xmlns:a16="http://schemas.microsoft.com/office/drawing/2014/main" id="{C5120BAF-0DD1-3B4A-8782-ADEE7BB95F62}"/>
               </a:ext>
             </a:extLst>
           </p:cNvPr>
@@ -28371,7 +28371,7 @@
           <p:cNvPr id="7228" name="Picture 60" descr="Edit">
             <a:extLst>
               <a:ext uri="{FF2B5EF4-FFF2-40B4-BE49-F238E27FC236}">
-                <a16:creationId xmlns:a16="http://schemas.microsoft.com/office/drawing/2014/main" xmlns="" id="{5D659988-94E0-AD4F-9466-4B46A9CCA9AC}"/>
+                <a16:creationId xmlns:a16="http://schemas.microsoft.com/office/drawing/2014/main" id="{5D659988-94E0-AD4F-9466-4B46A9CCA9AC}"/>
               </a:ext>
             </a:extLst>
           </p:cNvPr>
@@ -28418,7 +28418,7 @@
           <p:cNvPr id="7229" name="Picture 61" descr="Copy">
             <a:extLst>
               <a:ext uri="{FF2B5EF4-FFF2-40B4-BE49-F238E27FC236}">
-                <a16:creationId xmlns:a16="http://schemas.microsoft.com/office/drawing/2014/main" xmlns="" id="{9AA81DD6-A2AC-D749-A4FE-F82626FFFA96}"/>
+                <a16:creationId xmlns:a16="http://schemas.microsoft.com/office/drawing/2014/main" id="{9AA81DD6-A2AC-D749-A4FE-F82626FFFA96}"/>
               </a:ext>
             </a:extLst>
           </p:cNvPr>
@@ -28465,7 +28465,7 @@
           <p:cNvPr id="7230" name="Picture 62" descr="Delete">
             <a:extLst>
               <a:ext uri="{FF2B5EF4-FFF2-40B4-BE49-F238E27FC236}">
-                <a16:creationId xmlns:a16="http://schemas.microsoft.com/office/drawing/2014/main" xmlns="" id="{EAD8EBD8-D30D-1544-AA88-0A043D10F320}"/>
+                <a16:creationId xmlns:a16="http://schemas.microsoft.com/office/drawing/2014/main" id="{EAD8EBD8-D30D-1544-AA88-0A043D10F320}"/>
               </a:ext>
             </a:extLst>
           </p:cNvPr>
@@ -28512,7 +28512,7 @@
           <p:cNvPr id="7231" name="Picture 63" descr="Edit">
             <a:extLst>
               <a:ext uri="{FF2B5EF4-FFF2-40B4-BE49-F238E27FC236}">
-                <a16:creationId xmlns:a16="http://schemas.microsoft.com/office/drawing/2014/main" xmlns="" id="{FA619B7B-F6B9-A24C-A391-BAB5A4C5DE99}"/>
+                <a16:creationId xmlns:a16="http://schemas.microsoft.com/office/drawing/2014/main" id="{FA619B7B-F6B9-A24C-A391-BAB5A4C5DE99}"/>
               </a:ext>
             </a:extLst>
           </p:cNvPr>
@@ -28559,7 +28559,7 @@
           <p:cNvPr id="7232" name="Picture 64" descr="Copy">
             <a:extLst>
               <a:ext uri="{FF2B5EF4-FFF2-40B4-BE49-F238E27FC236}">
-                <a16:creationId xmlns:a16="http://schemas.microsoft.com/office/drawing/2014/main" xmlns="" id="{2BFEEB2A-F10B-134C-957A-FC9FE673E0C1}"/>
+                <a16:creationId xmlns:a16="http://schemas.microsoft.com/office/drawing/2014/main" id="{2BFEEB2A-F10B-134C-957A-FC9FE673E0C1}"/>
               </a:ext>
             </a:extLst>
           </p:cNvPr>
@@ -28606,7 +28606,7 @@
           <p:cNvPr id="7233" name="Picture 65" descr="Delete">
             <a:extLst>
               <a:ext uri="{FF2B5EF4-FFF2-40B4-BE49-F238E27FC236}">
-                <a16:creationId xmlns:a16="http://schemas.microsoft.com/office/drawing/2014/main" xmlns="" id="{0D6CCC79-17D3-FF4B-9F32-D2EEBAADE4F0}"/>
+                <a16:creationId xmlns:a16="http://schemas.microsoft.com/office/drawing/2014/main" id="{0D6CCC79-17D3-FF4B-9F32-D2EEBAADE4F0}"/>
               </a:ext>
             </a:extLst>
           </p:cNvPr>
@@ -28653,7 +28653,7 @@
           <p:cNvPr id="7234" name="Picture 66" descr="Edit">
             <a:extLst>
               <a:ext uri="{FF2B5EF4-FFF2-40B4-BE49-F238E27FC236}">
-                <a16:creationId xmlns:a16="http://schemas.microsoft.com/office/drawing/2014/main" xmlns="" id="{B624129D-5217-2646-912D-1D1CB3349484}"/>
+                <a16:creationId xmlns:a16="http://schemas.microsoft.com/office/drawing/2014/main" id="{B624129D-5217-2646-912D-1D1CB3349484}"/>
               </a:ext>
             </a:extLst>
           </p:cNvPr>
@@ -28700,7 +28700,7 @@
           <p:cNvPr id="7235" name="Picture 67" descr="Copy">
             <a:extLst>
               <a:ext uri="{FF2B5EF4-FFF2-40B4-BE49-F238E27FC236}">
-                <a16:creationId xmlns:a16="http://schemas.microsoft.com/office/drawing/2014/main" xmlns="" id="{7522B05C-C3CC-3E45-A00A-168789630799}"/>
+                <a16:creationId xmlns:a16="http://schemas.microsoft.com/office/drawing/2014/main" id="{7522B05C-C3CC-3E45-A00A-168789630799}"/>
               </a:ext>
             </a:extLst>
           </p:cNvPr>
@@ -28747,7 +28747,7 @@
           <p:cNvPr id="7236" name="Picture 68" descr="Delete">
             <a:extLst>
               <a:ext uri="{FF2B5EF4-FFF2-40B4-BE49-F238E27FC236}">
-                <a16:creationId xmlns:a16="http://schemas.microsoft.com/office/drawing/2014/main" xmlns="" id="{0D38D860-0474-D14A-80E9-5351D3DCF75D}"/>
+                <a16:creationId xmlns:a16="http://schemas.microsoft.com/office/drawing/2014/main" id="{0D38D860-0474-D14A-80E9-5351D3DCF75D}"/>
               </a:ext>
             </a:extLst>
           </p:cNvPr>
@@ -28794,7 +28794,7 @@
           <p:cNvPr id="7237" name="Picture 69" descr="Edit">
             <a:extLst>
               <a:ext uri="{FF2B5EF4-FFF2-40B4-BE49-F238E27FC236}">
-                <a16:creationId xmlns:a16="http://schemas.microsoft.com/office/drawing/2014/main" xmlns="" id="{80A8FC36-88B1-5B47-A6B8-0EC244CDC4B1}"/>
+                <a16:creationId xmlns:a16="http://schemas.microsoft.com/office/drawing/2014/main" id="{80A8FC36-88B1-5B47-A6B8-0EC244CDC4B1}"/>
               </a:ext>
             </a:extLst>
           </p:cNvPr>
@@ -28841,7 +28841,7 @@
           <p:cNvPr id="7238" name="Picture 70" descr="Copy">
             <a:extLst>
               <a:ext uri="{FF2B5EF4-FFF2-40B4-BE49-F238E27FC236}">
-                <a16:creationId xmlns:a16="http://schemas.microsoft.com/office/drawing/2014/main" xmlns="" id="{2408ED3D-3FD3-1548-8A24-7583A66CEBD8}"/>
+                <a16:creationId xmlns:a16="http://schemas.microsoft.com/office/drawing/2014/main" id="{2408ED3D-3FD3-1548-8A24-7583A66CEBD8}"/>
               </a:ext>
             </a:extLst>
           </p:cNvPr>
@@ -28888,7 +28888,7 @@
           <p:cNvPr id="7239" name="Picture 71" descr="Delete">
             <a:extLst>
               <a:ext uri="{FF2B5EF4-FFF2-40B4-BE49-F238E27FC236}">
-                <a16:creationId xmlns:a16="http://schemas.microsoft.com/office/drawing/2014/main" xmlns="" id="{1B749367-0541-4C44-82A9-F1B7CB19D67D}"/>
+                <a16:creationId xmlns:a16="http://schemas.microsoft.com/office/drawing/2014/main" id="{1B749367-0541-4C44-82A9-F1B7CB19D67D}"/>
               </a:ext>
             </a:extLst>
           </p:cNvPr>
@@ -28935,7 +28935,7 @@
           <p:cNvPr id="7240" name="Picture 72" descr="Edit">
             <a:extLst>
               <a:ext uri="{FF2B5EF4-FFF2-40B4-BE49-F238E27FC236}">
-                <a16:creationId xmlns:a16="http://schemas.microsoft.com/office/drawing/2014/main" xmlns="" id="{24E149B0-2433-244D-B804-9F3558AB623A}"/>
+                <a16:creationId xmlns:a16="http://schemas.microsoft.com/office/drawing/2014/main" id="{24E149B0-2433-244D-B804-9F3558AB623A}"/>
               </a:ext>
             </a:extLst>
           </p:cNvPr>
@@ -28982,7 +28982,7 @@
           <p:cNvPr id="7241" name="Picture 73" descr="Copy">
             <a:extLst>
               <a:ext uri="{FF2B5EF4-FFF2-40B4-BE49-F238E27FC236}">
-                <a16:creationId xmlns:a16="http://schemas.microsoft.com/office/drawing/2014/main" xmlns="" id="{6B9CC010-A54E-4A43-9900-1713427C5389}"/>
+                <a16:creationId xmlns:a16="http://schemas.microsoft.com/office/drawing/2014/main" id="{6B9CC010-A54E-4A43-9900-1713427C5389}"/>
               </a:ext>
             </a:extLst>
           </p:cNvPr>
@@ -29029,7 +29029,7 @@
           <p:cNvPr id="7242" name="Picture 74" descr="Delete">
             <a:extLst>
               <a:ext uri="{FF2B5EF4-FFF2-40B4-BE49-F238E27FC236}">
-                <a16:creationId xmlns:a16="http://schemas.microsoft.com/office/drawing/2014/main" xmlns="" id="{63EED20F-110F-2E44-90C7-BA8FF3CA3B43}"/>
+                <a16:creationId xmlns:a16="http://schemas.microsoft.com/office/drawing/2014/main" id="{63EED20F-110F-2E44-90C7-BA8FF3CA3B43}"/>
               </a:ext>
             </a:extLst>
           </p:cNvPr>
@@ -29076,7 +29076,7 @@
           <p:cNvPr id="7243" name="Picture 75" descr="Edit">
             <a:extLst>
               <a:ext uri="{FF2B5EF4-FFF2-40B4-BE49-F238E27FC236}">
-                <a16:creationId xmlns:a16="http://schemas.microsoft.com/office/drawing/2014/main" xmlns="" id="{6CB6A258-CCF8-814C-8CF2-21999AF3E979}"/>
+                <a16:creationId xmlns:a16="http://schemas.microsoft.com/office/drawing/2014/main" id="{6CB6A258-CCF8-814C-8CF2-21999AF3E979}"/>
               </a:ext>
             </a:extLst>
           </p:cNvPr>
@@ -29123,7 +29123,7 @@
           <p:cNvPr id="7244" name="Picture 76" descr="Copy">
             <a:extLst>
               <a:ext uri="{FF2B5EF4-FFF2-40B4-BE49-F238E27FC236}">
-                <a16:creationId xmlns:a16="http://schemas.microsoft.com/office/drawing/2014/main" xmlns="" id="{C3214E57-8123-4545-B340-CB76673E8314}"/>
+                <a16:creationId xmlns:a16="http://schemas.microsoft.com/office/drawing/2014/main" id="{C3214E57-8123-4545-B340-CB76673E8314}"/>
               </a:ext>
             </a:extLst>
           </p:cNvPr>
@@ -29170,7 +29170,7 @@
           <p:cNvPr id="7245" name="Picture 77" descr="Delete">
             <a:extLst>
               <a:ext uri="{FF2B5EF4-FFF2-40B4-BE49-F238E27FC236}">
-                <a16:creationId xmlns:a16="http://schemas.microsoft.com/office/drawing/2014/main" xmlns="" id="{080BFB43-39E9-794C-9627-DDD29B4864E3}"/>
+                <a16:creationId xmlns:a16="http://schemas.microsoft.com/office/drawing/2014/main" id="{080BFB43-39E9-794C-9627-DDD29B4864E3}"/>
               </a:ext>
             </a:extLst>
           </p:cNvPr>
@@ -29217,7 +29217,7 @@
           <p:cNvPr id="7246" name="Picture 78" descr="Edit">
             <a:extLst>
               <a:ext uri="{FF2B5EF4-FFF2-40B4-BE49-F238E27FC236}">
-                <a16:creationId xmlns:a16="http://schemas.microsoft.com/office/drawing/2014/main" xmlns="" id="{C76DB593-26D0-E546-8BDF-F53B764FC1DE}"/>
+                <a16:creationId xmlns:a16="http://schemas.microsoft.com/office/drawing/2014/main" id="{C76DB593-26D0-E546-8BDF-F53B764FC1DE}"/>
               </a:ext>
             </a:extLst>
           </p:cNvPr>
@@ -29264,7 +29264,7 @@
           <p:cNvPr id="7247" name="Picture 79" descr="Copy">
             <a:extLst>
               <a:ext uri="{FF2B5EF4-FFF2-40B4-BE49-F238E27FC236}">
-                <a16:creationId xmlns:a16="http://schemas.microsoft.com/office/drawing/2014/main" xmlns="" id="{7F2B36A3-2DE8-4640-A9C9-59972A5534DA}"/>
+                <a16:creationId xmlns:a16="http://schemas.microsoft.com/office/drawing/2014/main" id="{7F2B36A3-2DE8-4640-A9C9-59972A5534DA}"/>
               </a:ext>
             </a:extLst>
           </p:cNvPr>
@@ -29311,7 +29311,7 @@
           <p:cNvPr id="7248" name="Picture 80" descr="Delete">
             <a:extLst>
               <a:ext uri="{FF2B5EF4-FFF2-40B4-BE49-F238E27FC236}">
-                <a16:creationId xmlns:a16="http://schemas.microsoft.com/office/drawing/2014/main" xmlns="" id="{E7DACCCE-1B2F-DE48-856A-87DE97669EA0}"/>
+                <a16:creationId xmlns:a16="http://schemas.microsoft.com/office/drawing/2014/main" id="{E7DACCCE-1B2F-DE48-856A-87DE97669EA0}"/>
               </a:ext>
             </a:extLst>
           </p:cNvPr>
@@ -29358,7 +29358,7 @@
           <p:cNvPr id="7249" name="Picture 81" descr="Edit">
             <a:extLst>
               <a:ext uri="{FF2B5EF4-FFF2-40B4-BE49-F238E27FC236}">
-                <a16:creationId xmlns:a16="http://schemas.microsoft.com/office/drawing/2014/main" xmlns="" id="{9638018F-7630-CE4A-9355-CE11B3FC8154}"/>
+                <a16:creationId xmlns:a16="http://schemas.microsoft.com/office/drawing/2014/main" id="{9638018F-7630-CE4A-9355-CE11B3FC8154}"/>
               </a:ext>
             </a:extLst>
           </p:cNvPr>
@@ -29405,7 +29405,7 @@
           <p:cNvPr id="7250" name="Picture 82" descr="Copy">
             <a:extLst>
               <a:ext uri="{FF2B5EF4-FFF2-40B4-BE49-F238E27FC236}">
-                <a16:creationId xmlns:a16="http://schemas.microsoft.com/office/drawing/2014/main" xmlns="" id="{50905964-6153-3940-8581-4E33AE5F6ED0}"/>
+                <a16:creationId xmlns:a16="http://schemas.microsoft.com/office/drawing/2014/main" id="{50905964-6153-3940-8581-4E33AE5F6ED0}"/>
               </a:ext>
             </a:extLst>
           </p:cNvPr>
@@ -29452,7 +29452,7 @@
           <p:cNvPr id="7251" name="Picture 83" descr="Delete">
             <a:extLst>
               <a:ext uri="{FF2B5EF4-FFF2-40B4-BE49-F238E27FC236}">
-                <a16:creationId xmlns:a16="http://schemas.microsoft.com/office/drawing/2014/main" xmlns="" id="{D90C0E12-E72B-8C41-91FA-7DF163990621}"/>
+                <a16:creationId xmlns:a16="http://schemas.microsoft.com/office/drawing/2014/main" id="{D90C0E12-E72B-8C41-91FA-7DF163990621}"/>
               </a:ext>
             </a:extLst>
           </p:cNvPr>
@@ -29499,7 +29499,7 @@
           <p:cNvPr id="7252" name="Picture 84" descr="Edit">
             <a:extLst>
               <a:ext uri="{FF2B5EF4-FFF2-40B4-BE49-F238E27FC236}">
-                <a16:creationId xmlns:a16="http://schemas.microsoft.com/office/drawing/2014/main" xmlns="" id="{30F2445D-97CB-F446-BBD3-81BDB7D577EF}"/>
+                <a16:creationId xmlns:a16="http://schemas.microsoft.com/office/drawing/2014/main" id="{30F2445D-97CB-F446-BBD3-81BDB7D577EF}"/>
               </a:ext>
             </a:extLst>
           </p:cNvPr>
@@ -29546,7 +29546,7 @@
           <p:cNvPr id="7253" name="Picture 85" descr="Copy">
             <a:extLst>
               <a:ext uri="{FF2B5EF4-FFF2-40B4-BE49-F238E27FC236}">
-                <a16:creationId xmlns:a16="http://schemas.microsoft.com/office/drawing/2014/main" xmlns="" id="{DDA7856D-5189-AF45-BD0B-651D084E9898}"/>
+                <a16:creationId xmlns:a16="http://schemas.microsoft.com/office/drawing/2014/main" id="{DDA7856D-5189-AF45-BD0B-651D084E9898}"/>
               </a:ext>
             </a:extLst>
           </p:cNvPr>
@@ -29593,7 +29593,7 @@
           <p:cNvPr id="7254" name="Picture 86" descr="Delete">
             <a:extLst>
               <a:ext uri="{FF2B5EF4-FFF2-40B4-BE49-F238E27FC236}">
-                <a16:creationId xmlns:a16="http://schemas.microsoft.com/office/drawing/2014/main" xmlns="" id="{A7D85B9A-C557-D74F-922A-932BAC48CAA2}"/>
+                <a16:creationId xmlns:a16="http://schemas.microsoft.com/office/drawing/2014/main" id="{A7D85B9A-C557-D74F-922A-932BAC48CAA2}"/>
               </a:ext>
             </a:extLst>
           </p:cNvPr>
@@ -29640,7 +29640,7 @@
           <p:cNvPr id="7255" name="Picture 87" descr="Edit">
             <a:extLst>
               <a:ext uri="{FF2B5EF4-FFF2-40B4-BE49-F238E27FC236}">
-                <a16:creationId xmlns:a16="http://schemas.microsoft.com/office/drawing/2014/main" xmlns="" id="{DFB52E64-6476-7944-90C6-78AE57050C7F}"/>
+                <a16:creationId xmlns:a16="http://schemas.microsoft.com/office/drawing/2014/main" id="{DFB52E64-6476-7944-90C6-78AE57050C7F}"/>
               </a:ext>
             </a:extLst>
           </p:cNvPr>
@@ -29687,7 +29687,7 @@
           <p:cNvPr id="7256" name="Picture 88" descr="Copy">
             <a:extLst>
               <a:ext uri="{FF2B5EF4-FFF2-40B4-BE49-F238E27FC236}">
-                <a16:creationId xmlns:a16="http://schemas.microsoft.com/office/drawing/2014/main" xmlns="" id="{B3F011E5-D843-6544-AD01-1FD7E3440534}"/>
+                <a16:creationId xmlns:a16="http://schemas.microsoft.com/office/drawing/2014/main" id="{B3F011E5-D843-6544-AD01-1FD7E3440534}"/>
               </a:ext>
             </a:extLst>
           </p:cNvPr>
@@ -29734,7 +29734,7 @@
           <p:cNvPr id="7257" name="Picture 89" descr="Delete">
             <a:extLst>
               <a:ext uri="{FF2B5EF4-FFF2-40B4-BE49-F238E27FC236}">
-                <a16:creationId xmlns:a16="http://schemas.microsoft.com/office/drawing/2014/main" xmlns="" id="{49753787-A49F-444B-850C-1D303F93BDE0}"/>
+                <a16:creationId xmlns:a16="http://schemas.microsoft.com/office/drawing/2014/main" id="{49753787-A49F-444B-850C-1D303F93BDE0}"/>
               </a:ext>
             </a:extLst>
           </p:cNvPr>
@@ -29781,7 +29781,7 @@
           <p:cNvPr id="7258" name="Picture 90" descr="Edit">
             <a:extLst>
               <a:ext uri="{FF2B5EF4-FFF2-40B4-BE49-F238E27FC236}">
-                <a16:creationId xmlns:a16="http://schemas.microsoft.com/office/drawing/2014/main" xmlns="" id="{A2F0A34A-E701-D941-A355-5E02B70A6833}"/>
+                <a16:creationId xmlns:a16="http://schemas.microsoft.com/office/drawing/2014/main" id="{A2F0A34A-E701-D941-A355-5E02B70A6833}"/>
               </a:ext>
             </a:extLst>
           </p:cNvPr>
@@ -29828,7 +29828,7 @@
           <p:cNvPr id="7259" name="Picture 91" descr="Copy">
             <a:extLst>
               <a:ext uri="{FF2B5EF4-FFF2-40B4-BE49-F238E27FC236}">
-                <a16:creationId xmlns:a16="http://schemas.microsoft.com/office/drawing/2014/main" xmlns="" id="{F8EAB2C0-102B-FF43-BE7C-6D36924E0F0D}"/>
+                <a16:creationId xmlns:a16="http://schemas.microsoft.com/office/drawing/2014/main" id="{F8EAB2C0-102B-FF43-BE7C-6D36924E0F0D}"/>
               </a:ext>
             </a:extLst>
           </p:cNvPr>
@@ -29875,7 +29875,7 @@
           <p:cNvPr id="7260" name="Picture 92" descr="Delete">
             <a:extLst>
               <a:ext uri="{FF2B5EF4-FFF2-40B4-BE49-F238E27FC236}">
-                <a16:creationId xmlns:a16="http://schemas.microsoft.com/office/drawing/2014/main" xmlns="" id="{A6194C9D-95F5-3D41-94AA-75EF90B754E3}"/>
+                <a16:creationId xmlns:a16="http://schemas.microsoft.com/office/drawing/2014/main" id="{A6194C9D-95F5-3D41-94AA-75EF90B754E3}"/>
               </a:ext>
             </a:extLst>
           </p:cNvPr>
@@ -29922,7 +29922,7 @@
           <p:cNvPr id="7261" name="Picture 93" descr="Edit">
             <a:extLst>
               <a:ext uri="{FF2B5EF4-FFF2-40B4-BE49-F238E27FC236}">
-                <a16:creationId xmlns:a16="http://schemas.microsoft.com/office/drawing/2014/main" xmlns="" id="{11FD369F-C6F5-7F48-8A4B-6A0971EC7A1A}"/>
+                <a16:creationId xmlns:a16="http://schemas.microsoft.com/office/drawing/2014/main" id="{11FD369F-C6F5-7F48-8A4B-6A0971EC7A1A}"/>
               </a:ext>
             </a:extLst>
           </p:cNvPr>
@@ -29969,7 +29969,7 @@
           <p:cNvPr id="7262" name="Picture 94" descr="Copy">
             <a:extLst>
               <a:ext uri="{FF2B5EF4-FFF2-40B4-BE49-F238E27FC236}">
-                <a16:creationId xmlns:a16="http://schemas.microsoft.com/office/drawing/2014/main" xmlns="" id="{C9DC0687-5FE1-034F-8A4A-9C58ABD5DBF0}"/>
+                <a16:creationId xmlns:a16="http://schemas.microsoft.com/office/drawing/2014/main" id="{C9DC0687-5FE1-034F-8A4A-9C58ABD5DBF0}"/>
               </a:ext>
             </a:extLst>
           </p:cNvPr>
@@ -30016,7 +30016,7 @@
           <p:cNvPr id="7263" name="Picture 95" descr="Delete">
             <a:extLst>
               <a:ext uri="{FF2B5EF4-FFF2-40B4-BE49-F238E27FC236}">
-                <a16:creationId xmlns:a16="http://schemas.microsoft.com/office/drawing/2014/main" xmlns="" id="{2AD73EEB-6ABD-9B44-A756-C32352F27449}"/>
+                <a16:creationId xmlns:a16="http://schemas.microsoft.com/office/drawing/2014/main" id="{2AD73EEB-6ABD-9B44-A756-C32352F27449}"/>
               </a:ext>
             </a:extLst>
           </p:cNvPr>
@@ -30063,7 +30063,7 @@
           <p:cNvPr id="7264" name="Picture 96" descr="Edit">
             <a:extLst>
               <a:ext uri="{FF2B5EF4-FFF2-40B4-BE49-F238E27FC236}">
-                <a16:creationId xmlns:a16="http://schemas.microsoft.com/office/drawing/2014/main" xmlns="" id="{10B34E61-15B9-2E49-87B9-73B2D7CA68DA}"/>
+                <a16:creationId xmlns:a16="http://schemas.microsoft.com/office/drawing/2014/main" id="{10B34E61-15B9-2E49-87B9-73B2D7CA68DA}"/>
               </a:ext>
             </a:extLst>
           </p:cNvPr>
@@ -30110,7 +30110,7 @@
           <p:cNvPr id="7265" name="Picture 97" descr="Copy">
             <a:extLst>
               <a:ext uri="{FF2B5EF4-FFF2-40B4-BE49-F238E27FC236}">
-                <a16:creationId xmlns:a16="http://schemas.microsoft.com/office/drawing/2014/main" xmlns="" id="{DD2D3E0B-9847-AB49-B1D3-F4D1036F531D}"/>
+                <a16:creationId xmlns:a16="http://schemas.microsoft.com/office/drawing/2014/main" id="{DD2D3E0B-9847-AB49-B1D3-F4D1036F531D}"/>
               </a:ext>
             </a:extLst>
           </p:cNvPr>
@@ -30157,7 +30157,7 @@
           <p:cNvPr id="7266" name="Picture 98" descr="Delete">
             <a:extLst>
               <a:ext uri="{FF2B5EF4-FFF2-40B4-BE49-F238E27FC236}">
-                <a16:creationId xmlns:a16="http://schemas.microsoft.com/office/drawing/2014/main" xmlns="" id="{2E6B4D75-18BB-A144-816D-F2B4619AF434}"/>
+                <a16:creationId xmlns:a16="http://schemas.microsoft.com/office/drawing/2014/main" id="{2E6B4D75-18BB-A144-816D-F2B4619AF434}"/>
               </a:ext>
             </a:extLst>
           </p:cNvPr>
@@ -30204,7 +30204,7 @@
           <p:cNvPr id="7267" name="Picture 99" descr="Edit">
             <a:extLst>
               <a:ext uri="{FF2B5EF4-FFF2-40B4-BE49-F238E27FC236}">
-                <a16:creationId xmlns:a16="http://schemas.microsoft.com/office/drawing/2014/main" xmlns="" id="{FD1EDE04-2CAE-0944-85C6-942CAF846D65}"/>
+                <a16:creationId xmlns:a16="http://schemas.microsoft.com/office/drawing/2014/main" id="{FD1EDE04-2CAE-0944-85C6-942CAF846D65}"/>
               </a:ext>
             </a:extLst>
           </p:cNvPr>
@@ -30251,7 +30251,7 @@
           <p:cNvPr id="7268" name="Picture 100" descr="Copy">
             <a:extLst>
               <a:ext uri="{FF2B5EF4-FFF2-40B4-BE49-F238E27FC236}">
-                <a16:creationId xmlns:a16="http://schemas.microsoft.com/office/drawing/2014/main" xmlns="" id="{0311F970-C813-0046-B959-F2B02CFB0C75}"/>
+                <a16:creationId xmlns:a16="http://schemas.microsoft.com/office/drawing/2014/main" id="{0311F970-C813-0046-B959-F2B02CFB0C75}"/>
               </a:ext>
             </a:extLst>
           </p:cNvPr>
@@ -30298,7 +30298,7 @@
           <p:cNvPr id="7269" name="Picture 101" descr="Delete">
             <a:extLst>
               <a:ext uri="{FF2B5EF4-FFF2-40B4-BE49-F238E27FC236}">
-                <a16:creationId xmlns:a16="http://schemas.microsoft.com/office/drawing/2014/main" xmlns="" id="{A29F9472-4262-2E49-AB07-394AEC0363F4}"/>
+                <a16:creationId xmlns:a16="http://schemas.microsoft.com/office/drawing/2014/main" id="{A29F9472-4262-2E49-AB07-394AEC0363F4}"/>
               </a:ext>
             </a:extLst>
           </p:cNvPr>
@@ -30345,7 +30345,7 @@
           <p:cNvPr id="7270" name="Picture 102" descr="Edit">
             <a:extLst>
               <a:ext uri="{FF2B5EF4-FFF2-40B4-BE49-F238E27FC236}">
-                <a16:creationId xmlns:a16="http://schemas.microsoft.com/office/drawing/2014/main" xmlns="" id="{388DB9D5-6E65-7643-A25E-3D38446B6373}"/>
+                <a16:creationId xmlns:a16="http://schemas.microsoft.com/office/drawing/2014/main" id="{388DB9D5-6E65-7643-A25E-3D38446B6373}"/>
               </a:ext>
             </a:extLst>
           </p:cNvPr>
@@ -30392,7 +30392,7 @@
           <p:cNvPr id="7271" name="Picture 103" descr="Copy">
             <a:extLst>
               <a:ext uri="{FF2B5EF4-FFF2-40B4-BE49-F238E27FC236}">
-                <a16:creationId xmlns:a16="http://schemas.microsoft.com/office/drawing/2014/main" xmlns="" id="{E1D696C6-1DB6-C149-BB26-B53BCEAF2704}"/>
+                <a16:creationId xmlns:a16="http://schemas.microsoft.com/office/drawing/2014/main" id="{E1D696C6-1DB6-C149-BB26-B53BCEAF2704}"/>
               </a:ext>
             </a:extLst>
           </p:cNvPr>
@@ -30439,7 +30439,7 @@
           <p:cNvPr id="7272" name="Picture 104" descr="Delete">
             <a:extLst>
               <a:ext uri="{FF2B5EF4-FFF2-40B4-BE49-F238E27FC236}">
-                <a16:creationId xmlns:a16="http://schemas.microsoft.com/office/drawing/2014/main" xmlns="" id="{2BF06DD9-3B1A-D34C-9A63-B55958FEB6F4}"/>
+                <a16:creationId xmlns:a16="http://schemas.microsoft.com/office/drawing/2014/main" id="{2BF06DD9-3B1A-D34C-9A63-B55958FEB6F4}"/>
               </a:ext>
             </a:extLst>
           </p:cNvPr>
@@ -30486,7 +30486,7 @@
           <p:cNvPr id="7273" name="Picture 105" descr="Edit">
             <a:extLst>
               <a:ext uri="{FF2B5EF4-FFF2-40B4-BE49-F238E27FC236}">
-                <a16:creationId xmlns:a16="http://schemas.microsoft.com/office/drawing/2014/main" xmlns="" id="{F779866C-856E-6145-9265-3FC104F23607}"/>
+                <a16:creationId xmlns:a16="http://schemas.microsoft.com/office/drawing/2014/main" id="{F779866C-856E-6145-9265-3FC104F23607}"/>
               </a:ext>
             </a:extLst>
           </p:cNvPr>
@@ -30533,7 +30533,7 @@
           <p:cNvPr id="7274" name="Picture 106" descr="Copy">
             <a:extLst>
               <a:ext uri="{FF2B5EF4-FFF2-40B4-BE49-F238E27FC236}">
-                <a16:creationId xmlns:a16="http://schemas.microsoft.com/office/drawing/2014/main" xmlns="" id="{70D9D364-C44A-0144-80C8-EF4A1A6A6CA3}"/>
+                <a16:creationId xmlns:a16="http://schemas.microsoft.com/office/drawing/2014/main" id="{70D9D364-C44A-0144-80C8-EF4A1A6A6CA3}"/>
               </a:ext>
             </a:extLst>
           </p:cNvPr>
@@ -30580,7 +30580,7 @@
           <p:cNvPr id="7275" name="Picture 107" descr="Delete">
             <a:extLst>
               <a:ext uri="{FF2B5EF4-FFF2-40B4-BE49-F238E27FC236}">
-                <a16:creationId xmlns:a16="http://schemas.microsoft.com/office/drawing/2014/main" xmlns="" id="{3C3379C6-BD39-4B4A-8BE6-AA5F77C4966E}"/>
+                <a16:creationId xmlns:a16="http://schemas.microsoft.com/office/drawing/2014/main" id="{3C3379C6-BD39-4B4A-8BE6-AA5F77C4966E}"/>
               </a:ext>
             </a:extLst>
           </p:cNvPr>
@@ -30627,7 +30627,7 @@
           <p:cNvPr id="7276" name="Picture 108" descr="Edit">
             <a:extLst>
               <a:ext uri="{FF2B5EF4-FFF2-40B4-BE49-F238E27FC236}">
-                <a16:creationId xmlns:a16="http://schemas.microsoft.com/office/drawing/2014/main" xmlns="" id="{3FE1382E-5F62-5649-BC20-91DE8CB6801E}"/>
+                <a16:creationId xmlns:a16="http://schemas.microsoft.com/office/drawing/2014/main" id="{3FE1382E-5F62-5649-BC20-91DE8CB6801E}"/>
               </a:ext>
             </a:extLst>
           </p:cNvPr>
@@ -30674,7 +30674,7 @@
           <p:cNvPr id="7277" name="Picture 109" descr="Copy">
             <a:extLst>
               <a:ext uri="{FF2B5EF4-FFF2-40B4-BE49-F238E27FC236}">
-                <a16:creationId xmlns:a16="http://schemas.microsoft.com/office/drawing/2014/main" xmlns="" id="{739E4073-C04F-E843-82FD-4DE1266AE603}"/>
+                <a16:creationId xmlns:a16="http://schemas.microsoft.com/office/drawing/2014/main" id="{739E4073-C04F-E843-82FD-4DE1266AE603}"/>
               </a:ext>
             </a:extLst>
           </p:cNvPr>
@@ -30721,7 +30721,7 @@
           <p:cNvPr id="7278" name="Picture 110" descr="Delete">
             <a:extLst>
               <a:ext uri="{FF2B5EF4-FFF2-40B4-BE49-F238E27FC236}">
-                <a16:creationId xmlns:a16="http://schemas.microsoft.com/office/drawing/2014/main" xmlns="" id="{C66F04BA-9996-1348-9DF2-1AB3D889B199}"/>
+                <a16:creationId xmlns:a16="http://schemas.microsoft.com/office/drawing/2014/main" id="{C66F04BA-9996-1348-9DF2-1AB3D889B199}"/>
               </a:ext>
             </a:extLst>
           </p:cNvPr>
@@ -30768,7 +30768,7 @@
           <p:cNvPr id="5" name="Table 4">
             <a:extLst>
               <a:ext uri="{FF2B5EF4-FFF2-40B4-BE49-F238E27FC236}">
-                <a16:creationId xmlns:a16="http://schemas.microsoft.com/office/drawing/2014/main" xmlns="" id="{E53D7A9E-6A4C-E144-B500-84AF61A1A0CE}"/>
+                <a16:creationId xmlns:a16="http://schemas.microsoft.com/office/drawing/2014/main" id="{E53D7A9E-6A4C-E144-B500-84AF61A1A0CE}"/>
               </a:ext>
             </a:extLst>
           </p:cNvPr>
@@ -30797,28 +30797,28 @@
                 <a:gridCol w="2194560">
                   <a:extLst>
                     <a:ext uri="{9D8B030D-6E8A-4147-A177-3AD203B41FA5}">
-                      <a16:colId xmlns:a16="http://schemas.microsoft.com/office/drawing/2014/main" xmlns="" val="3251206747"/>
+                      <a16:colId xmlns:a16="http://schemas.microsoft.com/office/drawing/2014/main" val="3251206747"/>
                     </a:ext>
                   </a:extLst>
                 </a:gridCol>
                 <a:gridCol w="2194560">
                   <a:extLst>
                     <a:ext uri="{9D8B030D-6E8A-4147-A177-3AD203B41FA5}">
-                      <a16:colId xmlns:a16="http://schemas.microsoft.com/office/drawing/2014/main" xmlns="" val="1510229148"/>
+                      <a16:colId xmlns:a16="http://schemas.microsoft.com/office/drawing/2014/main" val="1510229148"/>
                     </a:ext>
                   </a:extLst>
                 </a:gridCol>
                 <a:gridCol w="2194560">
                   <a:extLst>
                     <a:ext uri="{9D8B030D-6E8A-4147-A177-3AD203B41FA5}">
-                      <a16:colId xmlns:a16="http://schemas.microsoft.com/office/drawing/2014/main" xmlns="" val="3881510931"/>
+                      <a16:colId xmlns:a16="http://schemas.microsoft.com/office/drawing/2014/main" val="3881510931"/>
                     </a:ext>
                   </a:extLst>
                 </a:gridCol>
                 <a:gridCol w="2194560">
                   <a:extLst>
                     <a:ext uri="{9D8B030D-6E8A-4147-A177-3AD203B41FA5}">
-                      <a16:colId xmlns:a16="http://schemas.microsoft.com/office/drawing/2014/main" xmlns="" val="3703355104"/>
+                      <a16:colId xmlns:a16="http://schemas.microsoft.com/office/drawing/2014/main" val="3703355104"/>
                     </a:ext>
                   </a:extLst>
                 </a:gridCol>
@@ -30902,7 +30902,7 @@
                 </a:tc>
                 <a:extLst>
                   <a:ext uri="{0D108BD9-81ED-4DB2-BD59-A6C34878D82A}">
-                    <a16:rowId xmlns:a16="http://schemas.microsoft.com/office/drawing/2014/main" xmlns="" val="1396598636"/>
+                    <a16:rowId xmlns:a16="http://schemas.microsoft.com/office/drawing/2014/main" val="1396598636"/>
                   </a:ext>
                 </a:extLst>
               </a:tr>
@@ -30973,7 +30973,7 @@
                 </a:tc>
                 <a:extLst>
                   <a:ext uri="{0D108BD9-81ED-4DB2-BD59-A6C34878D82A}">
-                    <a16:rowId xmlns:a16="http://schemas.microsoft.com/office/drawing/2014/main" xmlns="" val="982407830"/>
+                    <a16:rowId xmlns:a16="http://schemas.microsoft.com/office/drawing/2014/main" val="982407830"/>
                   </a:ext>
                 </a:extLst>
               </a:tr>
@@ -31016,7 +31016,7 @@
           <p:cNvPr id="2" name="Title 1">
             <a:extLst>
               <a:ext uri="{FF2B5EF4-FFF2-40B4-BE49-F238E27FC236}">
-                <a16:creationId xmlns:a16="http://schemas.microsoft.com/office/drawing/2014/main" xmlns="" id="{E0197DAE-2794-2A48-B881-72AD9F2E19E6}"/>
+                <a16:creationId xmlns:a16="http://schemas.microsoft.com/office/drawing/2014/main" id="{E0197DAE-2794-2A48-B881-72AD9F2E19E6}"/>
               </a:ext>
             </a:extLst>
           </p:cNvPr>
@@ -31049,7 +31049,7 @@
           <p:cNvPr id="3" name="Content Placeholder 2">
             <a:extLst>
               <a:ext uri="{FF2B5EF4-FFF2-40B4-BE49-F238E27FC236}">
-                <a16:creationId xmlns:a16="http://schemas.microsoft.com/office/drawing/2014/main" xmlns="" id="{47654F44-B3B5-5746-93E9-8536EF5C9CF8}"/>
+                <a16:creationId xmlns:a16="http://schemas.microsoft.com/office/drawing/2014/main" id="{47654F44-B3B5-5746-93E9-8536EF5C9CF8}"/>
               </a:ext>
             </a:extLst>
           </p:cNvPr>
@@ -31247,7 +31247,7 @@
           <p:cNvPr id="2" name="Title 1">
             <a:extLst>
               <a:ext uri="{FF2B5EF4-FFF2-40B4-BE49-F238E27FC236}">
-                <a16:creationId xmlns:a16="http://schemas.microsoft.com/office/drawing/2014/main" xmlns="" id="{E0197DAE-2794-2A48-B881-72AD9F2E19E6}"/>
+                <a16:creationId xmlns:a16="http://schemas.microsoft.com/office/drawing/2014/main" id="{E0197DAE-2794-2A48-B881-72AD9F2E19E6}"/>
               </a:ext>
             </a:extLst>
           </p:cNvPr>
@@ -31280,7 +31280,7 @@
           <p:cNvPr id="3" name="Content Placeholder 2">
             <a:extLst>
               <a:ext uri="{FF2B5EF4-FFF2-40B4-BE49-F238E27FC236}">
-                <a16:creationId xmlns:a16="http://schemas.microsoft.com/office/drawing/2014/main" xmlns="" id="{47654F44-B3B5-5746-93E9-8536EF5C9CF8}"/>
+                <a16:creationId xmlns:a16="http://schemas.microsoft.com/office/drawing/2014/main" id="{47654F44-B3B5-5746-93E9-8536EF5C9CF8}"/>
               </a:ext>
             </a:extLst>
           </p:cNvPr>
@@ -31365,7 +31365,7 @@
           <p:cNvPr id="2" name="Title 1">
             <a:extLst>
               <a:ext uri="{FF2B5EF4-FFF2-40B4-BE49-F238E27FC236}">
-                <a16:creationId xmlns:a16="http://schemas.microsoft.com/office/drawing/2014/main" xmlns="" id="{E0197DAE-2794-2A48-B881-72AD9F2E19E6}"/>
+                <a16:creationId xmlns:a16="http://schemas.microsoft.com/office/drawing/2014/main" id="{E0197DAE-2794-2A48-B881-72AD9F2E19E6}"/>
               </a:ext>
             </a:extLst>
           </p:cNvPr>
@@ -31398,7 +31398,7 @@
           <p:cNvPr id="3" name="Content Placeholder 2">
             <a:extLst>
               <a:ext uri="{FF2B5EF4-FFF2-40B4-BE49-F238E27FC236}">
-                <a16:creationId xmlns:a16="http://schemas.microsoft.com/office/drawing/2014/main" xmlns="" id="{47654F44-B3B5-5746-93E9-8536EF5C9CF8}"/>
+                <a16:creationId xmlns:a16="http://schemas.microsoft.com/office/drawing/2014/main" id="{47654F44-B3B5-5746-93E9-8536EF5C9CF8}"/>
               </a:ext>
             </a:extLst>
           </p:cNvPr>
@@ -31517,7 +31517,7 @@
           <p:cNvPr id="5" name="Table 4">
             <a:extLst>
               <a:ext uri="{FF2B5EF4-FFF2-40B4-BE49-F238E27FC236}">
-                <a16:creationId xmlns:a16="http://schemas.microsoft.com/office/drawing/2014/main" xmlns="" id="{B0D2FADF-27CD-6F4A-93AA-FCB3AC9A0245}"/>
+                <a16:creationId xmlns:a16="http://schemas.microsoft.com/office/drawing/2014/main" id="{B0D2FADF-27CD-6F4A-93AA-FCB3AC9A0245}"/>
               </a:ext>
             </a:extLst>
           </p:cNvPr>
@@ -31546,7 +31546,7 @@
                 <a:gridCol w="1850296">
                   <a:extLst>
                     <a:ext uri="{9D8B030D-6E8A-4147-A177-3AD203B41FA5}">
-                      <a16:colId xmlns:a16="http://schemas.microsoft.com/office/drawing/2014/main" xmlns="" val="1108994356"/>
+                      <a16:colId xmlns:a16="http://schemas.microsoft.com/office/drawing/2014/main" val="1108994356"/>
                     </a:ext>
                   </a:extLst>
                 </a:gridCol>
@@ -31579,7 +31579,7 @@
                 </a:tc>
                 <a:extLst>
                   <a:ext uri="{0D108BD9-81ED-4DB2-BD59-A6C34878D82A}">
-                    <a16:rowId xmlns:a16="http://schemas.microsoft.com/office/drawing/2014/main" xmlns="" val="3153752157"/>
+                    <a16:rowId xmlns:a16="http://schemas.microsoft.com/office/drawing/2014/main" val="3153752157"/>
                   </a:ext>
                 </a:extLst>
               </a:tr>
@@ -31602,7 +31602,7 @@
                 </a:tc>
                 <a:extLst>
                   <a:ext uri="{0D108BD9-81ED-4DB2-BD59-A6C34878D82A}">
-                    <a16:rowId xmlns:a16="http://schemas.microsoft.com/office/drawing/2014/main" xmlns="" val="3870812737"/>
+                    <a16:rowId xmlns:a16="http://schemas.microsoft.com/office/drawing/2014/main" val="3870812737"/>
                   </a:ext>
                 </a:extLst>
               </a:tr>
@@ -31625,7 +31625,7 @@
                 </a:tc>
                 <a:extLst>
                   <a:ext uri="{0D108BD9-81ED-4DB2-BD59-A6C34878D82A}">
-                    <a16:rowId xmlns:a16="http://schemas.microsoft.com/office/drawing/2014/main" xmlns="" val="3731511276"/>
+                    <a16:rowId xmlns:a16="http://schemas.microsoft.com/office/drawing/2014/main" val="3731511276"/>
                   </a:ext>
                 </a:extLst>
               </a:tr>
@@ -31648,7 +31648,7 @@
                 </a:tc>
                 <a:extLst>
                   <a:ext uri="{0D108BD9-81ED-4DB2-BD59-A6C34878D82A}">
-                    <a16:rowId xmlns:a16="http://schemas.microsoft.com/office/drawing/2014/main" xmlns="" val="3338405749"/>
+                    <a16:rowId xmlns:a16="http://schemas.microsoft.com/office/drawing/2014/main" val="3338405749"/>
                   </a:ext>
                 </a:extLst>
               </a:tr>
@@ -31671,7 +31671,7 @@
                 </a:tc>
                 <a:extLst>
                   <a:ext uri="{0D108BD9-81ED-4DB2-BD59-A6C34878D82A}">
-                    <a16:rowId xmlns:a16="http://schemas.microsoft.com/office/drawing/2014/main" xmlns="" val="1672582602"/>
+                    <a16:rowId xmlns:a16="http://schemas.microsoft.com/office/drawing/2014/main" val="1672582602"/>
                   </a:ext>
                 </a:extLst>
               </a:tr>
@@ -31694,7 +31694,7 @@
                 </a:tc>
                 <a:extLst>
                   <a:ext uri="{0D108BD9-81ED-4DB2-BD59-A6C34878D82A}">
-                    <a16:rowId xmlns:a16="http://schemas.microsoft.com/office/drawing/2014/main" xmlns="" val="2043958400"/>
+                    <a16:rowId xmlns:a16="http://schemas.microsoft.com/office/drawing/2014/main" val="2043958400"/>
                   </a:ext>
                 </a:extLst>
               </a:tr>
@@ -31717,7 +31717,7 @@
                 </a:tc>
                 <a:extLst>
                   <a:ext uri="{0D108BD9-81ED-4DB2-BD59-A6C34878D82A}">
-                    <a16:rowId xmlns:a16="http://schemas.microsoft.com/office/drawing/2014/main" xmlns="" val="144169271"/>
+                    <a16:rowId xmlns:a16="http://schemas.microsoft.com/office/drawing/2014/main" val="144169271"/>
                   </a:ext>
                 </a:extLst>
               </a:tr>
@@ -31740,7 +31740,7 @@
                 </a:tc>
                 <a:extLst>
                   <a:ext uri="{0D108BD9-81ED-4DB2-BD59-A6C34878D82A}">
-                    <a16:rowId xmlns:a16="http://schemas.microsoft.com/office/drawing/2014/main" xmlns="" val="3909491505"/>
+                    <a16:rowId xmlns:a16="http://schemas.microsoft.com/office/drawing/2014/main" val="3909491505"/>
                   </a:ext>
                 </a:extLst>
               </a:tr>
@@ -31763,7 +31763,7 @@
                 </a:tc>
                 <a:extLst>
                   <a:ext uri="{0D108BD9-81ED-4DB2-BD59-A6C34878D82A}">
-                    <a16:rowId xmlns:a16="http://schemas.microsoft.com/office/drawing/2014/main" xmlns="" val="1956265902"/>
+                    <a16:rowId xmlns:a16="http://schemas.microsoft.com/office/drawing/2014/main" val="1956265902"/>
                   </a:ext>
                 </a:extLst>
               </a:tr>
@@ -31786,7 +31786,7 @@
                 </a:tc>
                 <a:extLst>
                   <a:ext uri="{0D108BD9-81ED-4DB2-BD59-A6C34878D82A}">
-                    <a16:rowId xmlns:a16="http://schemas.microsoft.com/office/drawing/2014/main" xmlns="" val="352094459"/>
+                    <a16:rowId xmlns:a16="http://schemas.microsoft.com/office/drawing/2014/main" val="352094459"/>
                   </a:ext>
                 </a:extLst>
               </a:tr>
@@ -31809,7 +31809,7 @@
                 </a:tc>
                 <a:extLst>
                   <a:ext uri="{0D108BD9-81ED-4DB2-BD59-A6C34878D82A}">
-                    <a16:rowId xmlns:a16="http://schemas.microsoft.com/office/drawing/2014/main" xmlns="" val="1952654966"/>
+                    <a16:rowId xmlns:a16="http://schemas.microsoft.com/office/drawing/2014/main" val="1952654966"/>
                   </a:ext>
                 </a:extLst>
               </a:tr>
@@ -31832,7 +31832,7 @@
                 </a:tc>
                 <a:extLst>
                   <a:ext uri="{0D108BD9-81ED-4DB2-BD59-A6C34878D82A}">
-                    <a16:rowId xmlns:a16="http://schemas.microsoft.com/office/drawing/2014/main" xmlns="" val="1283753116"/>
+                    <a16:rowId xmlns:a16="http://schemas.microsoft.com/office/drawing/2014/main" val="1283753116"/>
                   </a:ext>
                 </a:extLst>
               </a:tr>
@@ -31855,7 +31855,7 @@
                 </a:tc>
                 <a:extLst>
                   <a:ext uri="{0D108BD9-81ED-4DB2-BD59-A6C34878D82A}">
-                    <a16:rowId xmlns:a16="http://schemas.microsoft.com/office/drawing/2014/main" xmlns="" val="1039270904"/>
+                    <a16:rowId xmlns:a16="http://schemas.microsoft.com/office/drawing/2014/main" val="1039270904"/>
                   </a:ext>
                 </a:extLst>
               </a:tr>
@@ -31878,7 +31878,7 @@
                 </a:tc>
                 <a:extLst>
                   <a:ext uri="{0D108BD9-81ED-4DB2-BD59-A6C34878D82A}">
-                    <a16:rowId xmlns:a16="http://schemas.microsoft.com/office/drawing/2014/main" xmlns="" val="2511834660"/>
+                    <a16:rowId xmlns:a16="http://schemas.microsoft.com/office/drawing/2014/main" val="2511834660"/>
                   </a:ext>
                 </a:extLst>
               </a:tr>
@@ -31901,7 +31901,7 @@
                 </a:tc>
                 <a:extLst>
                   <a:ext uri="{0D108BD9-81ED-4DB2-BD59-A6C34878D82A}">
-                    <a16:rowId xmlns:a16="http://schemas.microsoft.com/office/drawing/2014/main" xmlns="" val="3774795093"/>
+                    <a16:rowId xmlns:a16="http://schemas.microsoft.com/office/drawing/2014/main" val="3774795093"/>
                   </a:ext>
                 </a:extLst>
               </a:tr>
@@ -31924,7 +31924,7 @@
                 </a:tc>
                 <a:extLst>
                   <a:ext uri="{0D108BD9-81ED-4DB2-BD59-A6C34878D82A}">
-                    <a16:rowId xmlns:a16="http://schemas.microsoft.com/office/drawing/2014/main" xmlns="" val="4119133809"/>
+                    <a16:rowId xmlns:a16="http://schemas.microsoft.com/office/drawing/2014/main" val="4119133809"/>
                   </a:ext>
                 </a:extLst>
               </a:tr>
@@ -31947,7 +31947,7 @@
                 </a:tc>
                 <a:extLst>
                   <a:ext uri="{0D108BD9-81ED-4DB2-BD59-A6C34878D82A}">
-                    <a16:rowId xmlns:a16="http://schemas.microsoft.com/office/drawing/2014/main" xmlns="" val="154103292"/>
+                    <a16:rowId xmlns:a16="http://schemas.microsoft.com/office/drawing/2014/main" val="154103292"/>
                   </a:ext>
                 </a:extLst>
               </a:tr>
@@ -31970,7 +31970,7 @@
                 </a:tc>
                 <a:extLst>
                   <a:ext uri="{0D108BD9-81ED-4DB2-BD59-A6C34878D82A}">
-                    <a16:rowId xmlns:a16="http://schemas.microsoft.com/office/drawing/2014/main" xmlns="" val="2813035612"/>
+                    <a16:rowId xmlns:a16="http://schemas.microsoft.com/office/drawing/2014/main" val="2813035612"/>
                   </a:ext>
                 </a:extLst>
               </a:tr>
@@ -31993,7 +31993,7 @@
                 </a:tc>
                 <a:extLst>
                   <a:ext uri="{0D108BD9-81ED-4DB2-BD59-A6C34878D82A}">
-                    <a16:rowId xmlns:a16="http://schemas.microsoft.com/office/drawing/2014/main" xmlns="" val="1853704323"/>
+                    <a16:rowId xmlns:a16="http://schemas.microsoft.com/office/drawing/2014/main" val="1853704323"/>
                   </a:ext>
                 </a:extLst>
               </a:tr>
@@ -32016,7 +32016,7 @@
                 </a:tc>
                 <a:extLst>
                   <a:ext uri="{0D108BD9-81ED-4DB2-BD59-A6C34878D82A}">
-                    <a16:rowId xmlns:a16="http://schemas.microsoft.com/office/drawing/2014/main" xmlns="" val="3319432670"/>
+                    <a16:rowId xmlns:a16="http://schemas.microsoft.com/office/drawing/2014/main" val="3319432670"/>
                   </a:ext>
                 </a:extLst>
               </a:tr>
@@ -32039,7 +32039,7 @@
                 </a:tc>
                 <a:extLst>
                   <a:ext uri="{0D108BD9-81ED-4DB2-BD59-A6C34878D82A}">
-                    <a16:rowId xmlns:a16="http://schemas.microsoft.com/office/drawing/2014/main" xmlns="" val="1337279020"/>
+                    <a16:rowId xmlns:a16="http://schemas.microsoft.com/office/drawing/2014/main" val="1337279020"/>
                   </a:ext>
                 </a:extLst>
               </a:tr>
@@ -32062,7 +32062,7 @@
                 </a:tc>
                 <a:extLst>
                   <a:ext uri="{0D108BD9-81ED-4DB2-BD59-A6C34878D82A}">
-                    <a16:rowId xmlns:a16="http://schemas.microsoft.com/office/drawing/2014/main" xmlns="" val="2126460440"/>
+                    <a16:rowId xmlns:a16="http://schemas.microsoft.com/office/drawing/2014/main" val="2126460440"/>
                   </a:ext>
                 </a:extLst>
               </a:tr>
@@ -32085,7 +32085,7 @@
                 </a:tc>
                 <a:extLst>
                   <a:ext uri="{0D108BD9-81ED-4DB2-BD59-A6C34878D82A}">
-                    <a16:rowId xmlns:a16="http://schemas.microsoft.com/office/drawing/2014/main" xmlns="" val="1643618435"/>
+                    <a16:rowId xmlns:a16="http://schemas.microsoft.com/office/drawing/2014/main" val="1643618435"/>
                   </a:ext>
                 </a:extLst>
               </a:tr>
@@ -32108,7 +32108,7 @@
                 </a:tc>
                 <a:extLst>
                   <a:ext uri="{0D108BD9-81ED-4DB2-BD59-A6C34878D82A}">
-                    <a16:rowId xmlns:a16="http://schemas.microsoft.com/office/drawing/2014/main" xmlns="" val="2617717824"/>
+                    <a16:rowId xmlns:a16="http://schemas.microsoft.com/office/drawing/2014/main" val="2617717824"/>
                   </a:ext>
                 </a:extLst>
               </a:tr>
@@ -32131,7 +32131,7 @@
                 </a:tc>
                 <a:extLst>
                   <a:ext uri="{0D108BD9-81ED-4DB2-BD59-A6C34878D82A}">
-                    <a16:rowId xmlns:a16="http://schemas.microsoft.com/office/drawing/2014/main" xmlns="" val="647369420"/>
+                    <a16:rowId xmlns:a16="http://schemas.microsoft.com/office/drawing/2014/main" val="647369420"/>
                   </a:ext>
                 </a:extLst>
               </a:tr>
@@ -32154,7 +32154,7 @@
                 </a:tc>
                 <a:extLst>
                   <a:ext uri="{0D108BD9-81ED-4DB2-BD59-A6C34878D82A}">
-                    <a16:rowId xmlns:a16="http://schemas.microsoft.com/office/drawing/2014/main" xmlns="" val="2306175132"/>
+                    <a16:rowId xmlns:a16="http://schemas.microsoft.com/office/drawing/2014/main" val="2306175132"/>
                   </a:ext>
                 </a:extLst>
               </a:tr>
@@ -32177,7 +32177,7 @@
                 </a:tc>
                 <a:extLst>
                   <a:ext uri="{0D108BD9-81ED-4DB2-BD59-A6C34878D82A}">
-                    <a16:rowId xmlns:a16="http://schemas.microsoft.com/office/drawing/2014/main" xmlns="" val="2867153811"/>
+                    <a16:rowId xmlns:a16="http://schemas.microsoft.com/office/drawing/2014/main" val="2867153811"/>
                   </a:ext>
                 </a:extLst>
               </a:tr>
@@ -32200,7 +32200,7 @@
                 </a:tc>
                 <a:extLst>
                   <a:ext uri="{0D108BD9-81ED-4DB2-BD59-A6C34878D82A}">
-                    <a16:rowId xmlns:a16="http://schemas.microsoft.com/office/drawing/2014/main" xmlns="" val="2075452739"/>
+                    <a16:rowId xmlns:a16="http://schemas.microsoft.com/office/drawing/2014/main" val="2075452739"/>
                   </a:ext>
                 </a:extLst>
               </a:tr>
@@ -32223,7 +32223,7 @@
                 </a:tc>
                 <a:extLst>
                   <a:ext uri="{0D108BD9-81ED-4DB2-BD59-A6C34878D82A}">
-                    <a16:rowId xmlns:a16="http://schemas.microsoft.com/office/drawing/2014/main" xmlns="" val="1471213409"/>
+                    <a16:rowId xmlns:a16="http://schemas.microsoft.com/office/drawing/2014/main" val="1471213409"/>
                   </a:ext>
                 </a:extLst>
               </a:tr>
@@ -32246,7 +32246,7 @@
                 </a:tc>
                 <a:extLst>
                   <a:ext uri="{0D108BD9-81ED-4DB2-BD59-A6C34878D82A}">
-                    <a16:rowId xmlns:a16="http://schemas.microsoft.com/office/drawing/2014/main" xmlns="" val="4080016621"/>
+                    <a16:rowId xmlns:a16="http://schemas.microsoft.com/office/drawing/2014/main" val="4080016621"/>
                   </a:ext>
                 </a:extLst>
               </a:tr>
@@ -32269,7 +32269,7 @@
                 </a:tc>
                 <a:extLst>
                   <a:ext uri="{0D108BD9-81ED-4DB2-BD59-A6C34878D82A}">
-                    <a16:rowId xmlns:a16="http://schemas.microsoft.com/office/drawing/2014/main" xmlns="" val="1401972641"/>
+                    <a16:rowId xmlns:a16="http://schemas.microsoft.com/office/drawing/2014/main" val="1401972641"/>
                   </a:ext>
                 </a:extLst>
               </a:tr>
@@ -32292,7 +32292,7 @@
                 </a:tc>
                 <a:extLst>
                   <a:ext uri="{0D108BD9-81ED-4DB2-BD59-A6C34878D82A}">
-                    <a16:rowId xmlns:a16="http://schemas.microsoft.com/office/drawing/2014/main" xmlns="" val="2898875911"/>
+                    <a16:rowId xmlns:a16="http://schemas.microsoft.com/office/drawing/2014/main" val="2898875911"/>
                   </a:ext>
                 </a:extLst>
               </a:tr>
@@ -32315,7 +32315,7 @@
                 </a:tc>
                 <a:extLst>
                   <a:ext uri="{0D108BD9-81ED-4DB2-BD59-A6C34878D82A}">
-                    <a16:rowId xmlns:a16="http://schemas.microsoft.com/office/drawing/2014/main" xmlns="" val="1722320939"/>
+                    <a16:rowId xmlns:a16="http://schemas.microsoft.com/office/drawing/2014/main" val="1722320939"/>
                   </a:ext>
                 </a:extLst>
               </a:tr>
@@ -32338,7 +32338,7 @@
                 </a:tc>
                 <a:extLst>
                   <a:ext uri="{0D108BD9-81ED-4DB2-BD59-A6C34878D82A}">
-                    <a16:rowId xmlns:a16="http://schemas.microsoft.com/office/drawing/2014/main" xmlns="" val="1666207608"/>
+                    <a16:rowId xmlns:a16="http://schemas.microsoft.com/office/drawing/2014/main" val="1666207608"/>
                   </a:ext>
                 </a:extLst>
               </a:tr>
@@ -32361,7 +32361,7 @@
                 </a:tc>
                 <a:extLst>
                   <a:ext uri="{0D108BD9-81ED-4DB2-BD59-A6C34878D82A}">
-                    <a16:rowId xmlns:a16="http://schemas.microsoft.com/office/drawing/2014/main" xmlns="" val="520934005"/>
+                    <a16:rowId xmlns:a16="http://schemas.microsoft.com/office/drawing/2014/main" val="520934005"/>
                   </a:ext>
                 </a:extLst>
               </a:tr>
@@ -32384,7 +32384,7 @@
                 </a:tc>
                 <a:extLst>
                   <a:ext uri="{0D108BD9-81ED-4DB2-BD59-A6C34878D82A}">
-                    <a16:rowId xmlns:a16="http://schemas.microsoft.com/office/drawing/2014/main" xmlns="" val="3601387971"/>
+                    <a16:rowId xmlns:a16="http://schemas.microsoft.com/office/drawing/2014/main" val="3601387971"/>
                   </a:ext>
                 </a:extLst>
               </a:tr>
@@ -32407,7 +32407,7 @@
                 </a:tc>
                 <a:extLst>
                   <a:ext uri="{0D108BD9-81ED-4DB2-BD59-A6C34878D82A}">
-                    <a16:rowId xmlns:a16="http://schemas.microsoft.com/office/drawing/2014/main" xmlns="" val="4115061347"/>
+                    <a16:rowId xmlns:a16="http://schemas.microsoft.com/office/drawing/2014/main" val="4115061347"/>
                   </a:ext>
                 </a:extLst>
               </a:tr>
@@ -32450,7 +32450,7 @@
           <p:cNvPr id="2" name="Title 1">
             <a:extLst>
               <a:ext uri="{FF2B5EF4-FFF2-40B4-BE49-F238E27FC236}">
-                <a16:creationId xmlns:a16="http://schemas.microsoft.com/office/drawing/2014/main" xmlns="" id="{E0197DAE-2794-2A48-B881-72AD9F2E19E6}"/>
+                <a16:creationId xmlns:a16="http://schemas.microsoft.com/office/drawing/2014/main" id="{E0197DAE-2794-2A48-B881-72AD9F2E19E6}"/>
               </a:ext>
             </a:extLst>
           </p:cNvPr>
@@ -32483,7 +32483,7 @@
           <p:cNvPr id="3" name="Content Placeholder 2">
             <a:extLst>
               <a:ext uri="{FF2B5EF4-FFF2-40B4-BE49-F238E27FC236}">
-                <a16:creationId xmlns:a16="http://schemas.microsoft.com/office/drawing/2014/main" xmlns="" id="{47654F44-B3B5-5746-93E9-8536EF5C9CF8}"/>
+                <a16:creationId xmlns:a16="http://schemas.microsoft.com/office/drawing/2014/main" id="{47654F44-B3B5-5746-93E9-8536EF5C9CF8}"/>
               </a:ext>
             </a:extLst>
           </p:cNvPr>
@@ -32661,7 +32661,7 @@
           <p:cNvPr id="4" name="Table 3">
             <a:extLst>
               <a:ext uri="{FF2B5EF4-FFF2-40B4-BE49-F238E27FC236}">
-                <a16:creationId xmlns:a16="http://schemas.microsoft.com/office/drawing/2014/main" xmlns="" id="{17D1F908-8272-7A4F-BBA0-03ADA69459A5}"/>
+                <a16:creationId xmlns:a16="http://schemas.microsoft.com/office/drawing/2014/main" id="{17D1F908-8272-7A4F-BBA0-03ADA69459A5}"/>
               </a:ext>
             </a:extLst>
           </p:cNvPr>
@@ -32690,14 +32690,14 @@
                 <a:gridCol w="1325227">
                   <a:extLst>
                     <a:ext uri="{9D8B030D-6E8A-4147-A177-3AD203B41FA5}">
-                      <a16:colId xmlns:a16="http://schemas.microsoft.com/office/drawing/2014/main" xmlns="" val="654743821"/>
+                      <a16:colId xmlns:a16="http://schemas.microsoft.com/office/drawing/2014/main" val="654743821"/>
                     </a:ext>
                   </a:extLst>
                 </a:gridCol>
                 <a:gridCol w="1325227">
                   <a:extLst>
                     <a:ext uri="{9D8B030D-6E8A-4147-A177-3AD203B41FA5}">
-                      <a16:colId xmlns:a16="http://schemas.microsoft.com/office/drawing/2014/main" xmlns="" val="1437562885"/>
+                      <a16:colId xmlns:a16="http://schemas.microsoft.com/office/drawing/2014/main" val="1437562885"/>
                     </a:ext>
                   </a:extLst>
                 </a:gridCol>
@@ -32755,7 +32755,7 @@
                 </a:tc>
                 <a:extLst>
                   <a:ext uri="{0D108BD9-81ED-4DB2-BD59-A6C34878D82A}">
-                    <a16:rowId xmlns:a16="http://schemas.microsoft.com/office/drawing/2014/main" xmlns="" val="76563770"/>
+                    <a16:rowId xmlns:a16="http://schemas.microsoft.com/office/drawing/2014/main" val="76563770"/>
                   </a:ext>
                 </a:extLst>
               </a:tr>
@@ -32794,7 +32794,7 @@
                 </a:tc>
                 <a:extLst>
                   <a:ext uri="{0D108BD9-81ED-4DB2-BD59-A6C34878D82A}">
-                    <a16:rowId xmlns:a16="http://schemas.microsoft.com/office/drawing/2014/main" xmlns="" val="4028476854"/>
+                    <a16:rowId xmlns:a16="http://schemas.microsoft.com/office/drawing/2014/main" val="4028476854"/>
                   </a:ext>
                 </a:extLst>
               </a:tr>
@@ -32833,7 +32833,7 @@
                 </a:tc>
                 <a:extLst>
                   <a:ext uri="{0D108BD9-81ED-4DB2-BD59-A6C34878D82A}">
-                    <a16:rowId xmlns:a16="http://schemas.microsoft.com/office/drawing/2014/main" xmlns="" val="36198652"/>
+                    <a16:rowId xmlns:a16="http://schemas.microsoft.com/office/drawing/2014/main" val="36198652"/>
                   </a:ext>
                 </a:extLst>
               </a:tr>
@@ -32872,7 +32872,7 @@
                 </a:tc>
                 <a:extLst>
                   <a:ext uri="{0D108BD9-81ED-4DB2-BD59-A6C34878D82A}">
-                    <a16:rowId xmlns:a16="http://schemas.microsoft.com/office/drawing/2014/main" xmlns="" val="518198380"/>
+                    <a16:rowId xmlns:a16="http://schemas.microsoft.com/office/drawing/2014/main" val="518198380"/>
                   </a:ext>
                 </a:extLst>
               </a:tr>
@@ -32911,7 +32911,7 @@
                 </a:tc>
                 <a:extLst>
                   <a:ext uri="{0D108BD9-81ED-4DB2-BD59-A6C34878D82A}">
-                    <a16:rowId xmlns:a16="http://schemas.microsoft.com/office/drawing/2014/main" xmlns="" val="1596131197"/>
+                    <a16:rowId xmlns:a16="http://schemas.microsoft.com/office/drawing/2014/main" val="1596131197"/>
                   </a:ext>
                 </a:extLst>
               </a:tr>
@@ -32950,7 +32950,7 @@
                 </a:tc>
                 <a:extLst>
                   <a:ext uri="{0D108BD9-81ED-4DB2-BD59-A6C34878D82A}">
-                    <a16:rowId xmlns:a16="http://schemas.microsoft.com/office/drawing/2014/main" xmlns="" val="1949277381"/>
+                    <a16:rowId xmlns:a16="http://schemas.microsoft.com/office/drawing/2014/main" val="1949277381"/>
                   </a:ext>
                 </a:extLst>
               </a:tr>
@@ -32989,7 +32989,7 @@
                 </a:tc>
                 <a:extLst>
                   <a:ext uri="{0D108BD9-81ED-4DB2-BD59-A6C34878D82A}">
-                    <a16:rowId xmlns:a16="http://schemas.microsoft.com/office/drawing/2014/main" xmlns="" val="1089018870"/>
+                    <a16:rowId xmlns:a16="http://schemas.microsoft.com/office/drawing/2014/main" val="1089018870"/>
                   </a:ext>
                 </a:extLst>
               </a:tr>
@@ -33028,7 +33028,7 @@
                 </a:tc>
                 <a:extLst>
                   <a:ext uri="{0D108BD9-81ED-4DB2-BD59-A6C34878D82A}">
-                    <a16:rowId xmlns:a16="http://schemas.microsoft.com/office/drawing/2014/main" xmlns="" val="4230602284"/>
+                    <a16:rowId xmlns:a16="http://schemas.microsoft.com/office/drawing/2014/main" val="4230602284"/>
                   </a:ext>
                 </a:extLst>
               </a:tr>
@@ -33067,7 +33067,7 @@
                 </a:tc>
                 <a:extLst>
                   <a:ext uri="{0D108BD9-81ED-4DB2-BD59-A6C34878D82A}">
-                    <a16:rowId xmlns:a16="http://schemas.microsoft.com/office/drawing/2014/main" xmlns="" val="2410941217"/>
+                    <a16:rowId xmlns:a16="http://schemas.microsoft.com/office/drawing/2014/main" val="2410941217"/>
                   </a:ext>
                 </a:extLst>
               </a:tr>
@@ -33106,7 +33106,7 @@
                 </a:tc>
                 <a:extLst>
                   <a:ext uri="{0D108BD9-81ED-4DB2-BD59-A6C34878D82A}">
-                    <a16:rowId xmlns:a16="http://schemas.microsoft.com/office/drawing/2014/main" xmlns="" val="743341524"/>
+                    <a16:rowId xmlns:a16="http://schemas.microsoft.com/office/drawing/2014/main" val="743341524"/>
                   </a:ext>
                 </a:extLst>
               </a:tr>
@@ -33145,7 +33145,7 @@
                 </a:tc>
                 <a:extLst>
                   <a:ext uri="{0D108BD9-81ED-4DB2-BD59-A6C34878D82A}">
-                    <a16:rowId xmlns:a16="http://schemas.microsoft.com/office/drawing/2014/main" xmlns="" val="207825087"/>
+                    <a16:rowId xmlns:a16="http://schemas.microsoft.com/office/drawing/2014/main" val="207825087"/>
                   </a:ext>
                 </a:extLst>
               </a:tr>
@@ -33184,7 +33184,7 @@
                 </a:tc>
                 <a:extLst>
                   <a:ext uri="{0D108BD9-81ED-4DB2-BD59-A6C34878D82A}">
-                    <a16:rowId xmlns:a16="http://schemas.microsoft.com/office/drawing/2014/main" xmlns="" val="3528274256"/>
+                    <a16:rowId xmlns:a16="http://schemas.microsoft.com/office/drawing/2014/main" val="3528274256"/>
                   </a:ext>
                 </a:extLst>
               </a:tr>
@@ -33223,7 +33223,7 @@
                 </a:tc>
                 <a:extLst>
                   <a:ext uri="{0D108BD9-81ED-4DB2-BD59-A6C34878D82A}">
-                    <a16:rowId xmlns:a16="http://schemas.microsoft.com/office/drawing/2014/main" xmlns="" val="1317245510"/>
+                    <a16:rowId xmlns:a16="http://schemas.microsoft.com/office/drawing/2014/main" val="1317245510"/>
                   </a:ext>
                 </a:extLst>
               </a:tr>
@@ -33262,7 +33262,7 @@
                 </a:tc>
                 <a:extLst>
                   <a:ext uri="{0D108BD9-81ED-4DB2-BD59-A6C34878D82A}">
-                    <a16:rowId xmlns:a16="http://schemas.microsoft.com/office/drawing/2014/main" xmlns="" val="256888822"/>
+                    <a16:rowId xmlns:a16="http://schemas.microsoft.com/office/drawing/2014/main" val="256888822"/>
                   </a:ext>
                 </a:extLst>
               </a:tr>
@@ -33301,7 +33301,7 @@
                 </a:tc>
                 <a:extLst>
                   <a:ext uri="{0D108BD9-81ED-4DB2-BD59-A6C34878D82A}">
-                    <a16:rowId xmlns:a16="http://schemas.microsoft.com/office/drawing/2014/main" xmlns="" val="4140233810"/>
+                    <a16:rowId xmlns:a16="http://schemas.microsoft.com/office/drawing/2014/main" val="4140233810"/>
                   </a:ext>
                 </a:extLst>
               </a:tr>
@@ -33340,7 +33340,7 @@
                 </a:tc>
                 <a:extLst>
                   <a:ext uri="{0D108BD9-81ED-4DB2-BD59-A6C34878D82A}">
-                    <a16:rowId xmlns:a16="http://schemas.microsoft.com/office/drawing/2014/main" xmlns="" val="724742887"/>
+                    <a16:rowId xmlns:a16="http://schemas.microsoft.com/office/drawing/2014/main" val="724742887"/>
                   </a:ext>
                 </a:extLst>
               </a:tr>
@@ -33379,7 +33379,7 @@
                 </a:tc>
                 <a:extLst>
                   <a:ext uri="{0D108BD9-81ED-4DB2-BD59-A6C34878D82A}">
-                    <a16:rowId xmlns:a16="http://schemas.microsoft.com/office/drawing/2014/main" xmlns="" val="2647922977"/>
+                    <a16:rowId xmlns:a16="http://schemas.microsoft.com/office/drawing/2014/main" val="2647922977"/>
                   </a:ext>
                 </a:extLst>
               </a:tr>
@@ -33418,7 +33418,7 @@
                 </a:tc>
                 <a:extLst>
                   <a:ext uri="{0D108BD9-81ED-4DB2-BD59-A6C34878D82A}">
-                    <a16:rowId xmlns:a16="http://schemas.microsoft.com/office/drawing/2014/main" xmlns="" val="1898158794"/>
+                    <a16:rowId xmlns:a16="http://schemas.microsoft.com/office/drawing/2014/main" val="1898158794"/>
                   </a:ext>
                 </a:extLst>
               </a:tr>
@@ -33457,7 +33457,7 @@
                 </a:tc>
                 <a:extLst>
                   <a:ext uri="{0D108BD9-81ED-4DB2-BD59-A6C34878D82A}">
-                    <a16:rowId xmlns:a16="http://schemas.microsoft.com/office/drawing/2014/main" xmlns="" val="1689841284"/>
+                    <a16:rowId xmlns:a16="http://schemas.microsoft.com/office/drawing/2014/main" val="1689841284"/>
                   </a:ext>
                 </a:extLst>
               </a:tr>
@@ -33496,7 +33496,7 @@
                 </a:tc>
                 <a:extLst>
                   <a:ext uri="{0D108BD9-81ED-4DB2-BD59-A6C34878D82A}">
-                    <a16:rowId xmlns:a16="http://schemas.microsoft.com/office/drawing/2014/main" xmlns="" val="1767802242"/>
+                    <a16:rowId xmlns:a16="http://schemas.microsoft.com/office/drawing/2014/main" val="1767802242"/>
                   </a:ext>
                 </a:extLst>
               </a:tr>
@@ -33535,7 +33535,7 @@
                 </a:tc>
                 <a:extLst>
                   <a:ext uri="{0D108BD9-81ED-4DB2-BD59-A6C34878D82A}">
-                    <a16:rowId xmlns:a16="http://schemas.microsoft.com/office/drawing/2014/main" xmlns="" val="1852074147"/>
+                    <a16:rowId xmlns:a16="http://schemas.microsoft.com/office/drawing/2014/main" val="1852074147"/>
                   </a:ext>
                 </a:extLst>
               </a:tr>
@@ -33574,7 +33574,7 @@
                 </a:tc>
                 <a:extLst>
                   <a:ext uri="{0D108BD9-81ED-4DB2-BD59-A6C34878D82A}">
-                    <a16:rowId xmlns:a16="http://schemas.microsoft.com/office/drawing/2014/main" xmlns="" val="3568181341"/>
+                    <a16:rowId xmlns:a16="http://schemas.microsoft.com/office/drawing/2014/main" val="3568181341"/>
                   </a:ext>
                 </a:extLst>
               </a:tr>
@@ -33613,7 +33613,7 @@
                 </a:tc>
                 <a:extLst>
                   <a:ext uri="{0D108BD9-81ED-4DB2-BD59-A6C34878D82A}">
-                    <a16:rowId xmlns:a16="http://schemas.microsoft.com/office/drawing/2014/main" xmlns="" val="1777119769"/>
+                    <a16:rowId xmlns:a16="http://schemas.microsoft.com/office/drawing/2014/main" val="1777119769"/>
                   </a:ext>
                 </a:extLst>
               </a:tr>
@@ -33652,7 +33652,7 @@
                 </a:tc>
                 <a:extLst>
                   <a:ext uri="{0D108BD9-81ED-4DB2-BD59-A6C34878D82A}">
-                    <a16:rowId xmlns:a16="http://schemas.microsoft.com/office/drawing/2014/main" xmlns="" val="2087451240"/>
+                    <a16:rowId xmlns:a16="http://schemas.microsoft.com/office/drawing/2014/main" val="2087451240"/>
                   </a:ext>
                 </a:extLst>
               </a:tr>
@@ -33691,7 +33691,7 @@
                 </a:tc>
                 <a:extLst>
                   <a:ext uri="{0D108BD9-81ED-4DB2-BD59-A6C34878D82A}">
-                    <a16:rowId xmlns:a16="http://schemas.microsoft.com/office/drawing/2014/main" xmlns="" val="4078804759"/>
+                    <a16:rowId xmlns:a16="http://schemas.microsoft.com/office/drawing/2014/main" val="4078804759"/>
                   </a:ext>
                 </a:extLst>
               </a:tr>
@@ -33730,7 +33730,7 @@
                 </a:tc>
                 <a:extLst>
                   <a:ext uri="{0D108BD9-81ED-4DB2-BD59-A6C34878D82A}">
-                    <a16:rowId xmlns:a16="http://schemas.microsoft.com/office/drawing/2014/main" xmlns="" val="3019012992"/>
+                    <a16:rowId xmlns:a16="http://schemas.microsoft.com/office/drawing/2014/main" val="3019012992"/>
                   </a:ext>
                 </a:extLst>
               </a:tr>
@@ -33769,7 +33769,7 @@
                 </a:tc>
                 <a:extLst>
                   <a:ext uri="{0D108BD9-81ED-4DB2-BD59-A6C34878D82A}">
-                    <a16:rowId xmlns:a16="http://schemas.microsoft.com/office/drawing/2014/main" xmlns="" val="3720510972"/>
+                    <a16:rowId xmlns:a16="http://schemas.microsoft.com/office/drawing/2014/main" val="3720510972"/>
                   </a:ext>
                 </a:extLst>
               </a:tr>
@@ -33808,7 +33808,7 @@
                 </a:tc>
                 <a:extLst>
                   <a:ext uri="{0D108BD9-81ED-4DB2-BD59-A6C34878D82A}">
-                    <a16:rowId xmlns:a16="http://schemas.microsoft.com/office/drawing/2014/main" xmlns="" val="4063771090"/>
+                    <a16:rowId xmlns:a16="http://schemas.microsoft.com/office/drawing/2014/main" val="4063771090"/>
                   </a:ext>
                 </a:extLst>
               </a:tr>
@@ -33847,7 +33847,7 @@
                 </a:tc>
                 <a:extLst>
                   <a:ext uri="{0D108BD9-81ED-4DB2-BD59-A6C34878D82A}">
-                    <a16:rowId xmlns:a16="http://schemas.microsoft.com/office/drawing/2014/main" xmlns="" val="168004404"/>
+                    <a16:rowId xmlns:a16="http://schemas.microsoft.com/office/drawing/2014/main" val="168004404"/>
                   </a:ext>
                 </a:extLst>
               </a:tr>
@@ -33886,7 +33886,7 @@
                 </a:tc>
                 <a:extLst>
                   <a:ext uri="{0D108BD9-81ED-4DB2-BD59-A6C34878D82A}">
-                    <a16:rowId xmlns:a16="http://schemas.microsoft.com/office/drawing/2014/main" xmlns="" val="2867273400"/>
+                    <a16:rowId xmlns:a16="http://schemas.microsoft.com/office/drawing/2014/main" val="2867273400"/>
                   </a:ext>
                 </a:extLst>
               </a:tr>
@@ -33925,7 +33925,7 @@
                 </a:tc>
                 <a:extLst>
                   <a:ext uri="{0D108BD9-81ED-4DB2-BD59-A6C34878D82A}">
-                    <a16:rowId xmlns:a16="http://schemas.microsoft.com/office/drawing/2014/main" xmlns="" val="4151030484"/>
+                    <a16:rowId xmlns:a16="http://schemas.microsoft.com/office/drawing/2014/main" val="4151030484"/>
                   </a:ext>
                 </a:extLst>
               </a:tr>
@@ -33964,7 +33964,7 @@
                 </a:tc>
                 <a:extLst>
                   <a:ext uri="{0D108BD9-81ED-4DB2-BD59-A6C34878D82A}">
-                    <a16:rowId xmlns:a16="http://schemas.microsoft.com/office/drawing/2014/main" xmlns="" val="18278905"/>
+                    <a16:rowId xmlns:a16="http://schemas.microsoft.com/office/drawing/2014/main" val="18278905"/>
                   </a:ext>
                 </a:extLst>
               </a:tr>
@@ -34003,7 +34003,7 @@
                 </a:tc>
                 <a:extLst>
                   <a:ext uri="{0D108BD9-81ED-4DB2-BD59-A6C34878D82A}">
-                    <a16:rowId xmlns:a16="http://schemas.microsoft.com/office/drawing/2014/main" xmlns="" val="2832135727"/>
+                    <a16:rowId xmlns:a16="http://schemas.microsoft.com/office/drawing/2014/main" val="2832135727"/>
                   </a:ext>
                 </a:extLst>
               </a:tr>
@@ -34042,7 +34042,7 @@
                 </a:tc>
                 <a:extLst>
                   <a:ext uri="{0D108BD9-81ED-4DB2-BD59-A6C34878D82A}">
-                    <a16:rowId xmlns:a16="http://schemas.microsoft.com/office/drawing/2014/main" xmlns="" val="3069198054"/>
+                    <a16:rowId xmlns:a16="http://schemas.microsoft.com/office/drawing/2014/main" val="3069198054"/>
                   </a:ext>
                 </a:extLst>
               </a:tr>
@@ -34081,7 +34081,7 @@
                 </a:tc>
                 <a:extLst>
                   <a:ext uri="{0D108BD9-81ED-4DB2-BD59-A6C34878D82A}">
-                    <a16:rowId xmlns:a16="http://schemas.microsoft.com/office/drawing/2014/main" xmlns="" val="2829272782"/>
+                    <a16:rowId xmlns:a16="http://schemas.microsoft.com/office/drawing/2014/main" val="2829272782"/>
                   </a:ext>
                 </a:extLst>
               </a:tr>
@@ -34120,7 +34120,7 @@
                 </a:tc>
                 <a:extLst>
                   <a:ext uri="{0D108BD9-81ED-4DB2-BD59-A6C34878D82A}">
-                    <a16:rowId xmlns:a16="http://schemas.microsoft.com/office/drawing/2014/main" xmlns="" val="3051141318"/>
+                    <a16:rowId xmlns:a16="http://schemas.microsoft.com/office/drawing/2014/main" val="3051141318"/>
                   </a:ext>
                 </a:extLst>
               </a:tr>
@@ -34159,7 +34159,7 @@
                 </a:tc>
                 <a:extLst>
                   <a:ext uri="{0D108BD9-81ED-4DB2-BD59-A6C34878D82A}">
-                    <a16:rowId xmlns:a16="http://schemas.microsoft.com/office/drawing/2014/main" xmlns="" val="888693155"/>
+                    <a16:rowId xmlns:a16="http://schemas.microsoft.com/office/drawing/2014/main" val="888693155"/>
                   </a:ext>
                 </a:extLst>
               </a:tr>
@@ -34172,7 +34172,7 @@
           <p:cNvPr id="7170" name="Picture 2" descr="Ascending">
             <a:extLst>
               <a:ext uri="{FF2B5EF4-FFF2-40B4-BE49-F238E27FC236}">
-                <a16:creationId xmlns:a16="http://schemas.microsoft.com/office/drawing/2014/main" xmlns="" id="{C65215BD-5B57-4044-9931-72150E751D6E}"/>
+                <a16:creationId xmlns:a16="http://schemas.microsoft.com/office/drawing/2014/main" id="{C65215BD-5B57-4044-9931-72150E751D6E}"/>
               </a:ext>
             </a:extLst>
           </p:cNvPr>
@@ -34219,7 +34219,7 @@
           <p:cNvPr id="7171" name="Picture 3" descr="Edit">
             <a:extLst>
               <a:ext uri="{FF2B5EF4-FFF2-40B4-BE49-F238E27FC236}">
-                <a16:creationId xmlns:a16="http://schemas.microsoft.com/office/drawing/2014/main" xmlns="" id="{D5ED79AF-4A18-B345-B840-D9842E34EB87}"/>
+                <a16:creationId xmlns:a16="http://schemas.microsoft.com/office/drawing/2014/main" id="{D5ED79AF-4A18-B345-B840-D9842E34EB87}"/>
               </a:ext>
             </a:extLst>
           </p:cNvPr>
@@ -34266,7 +34266,7 @@
           <p:cNvPr id="7172" name="Picture 4" descr="Copy">
             <a:extLst>
               <a:ext uri="{FF2B5EF4-FFF2-40B4-BE49-F238E27FC236}">
-                <a16:creationId xmlns:a16="http://schemas.microsoft.com/office/drawing/2014/main" xmlns="" id="{FBA6165E-BBB3-264F-B659-7BADC52A277D}"/>
+                <a16:creationId xmlns:a16="http://schemas.microsoft.com/office/drawing/2014/main" id="{FBA6165E-BBB3-264F-B659-7BADC52A277D}"/>
               </a:ext>
             </a:extLst>
           </p:cNvPr>
@@ -34313,7 +34313,7 @@
           <p:cNvPr id="7173" name="Picture 5" descr="Delete">
             <a:extLst>
               <a:ext uri="{FF2B5EF4-FFF2-40B4-BE49-F238E27FC236}">
-                <a16:creationId xmlns:a16="http://schemas.microsoft.com/office/drawing/2014/main" xmlns="" id="{9D5E0143-2F09-FC40-9496-179295E448A3}"/>
+                <a16:creationId xmlns:a16="http://schemas.microsoft.com/office/drawing/2014/main" id="{9D5E0143-2F09-FC40-9496-179295E448A3}"/>
               </a:ext>
             </a:extLst>
           </p:cNvPr>
@@ -34360,7 +34360,7 @@
           <p:cNvPr id="7174" name="Picture 6" descr="Edit">
             <a:extLst>
               <a:ext uri="{FF2B5EF4-FFF2-40B4-BE49-F238E27FC236}">
-                <a16:creationId xmlns:a16="http://schemas.microsoft.com/office/drawing/2014/main" xmlns="" id="{3DED508C-7EC1-BB40-A157-108A6709112F}"/>
+                <a16:creationId xmlns:a16="http://schemas.microsoft.com/office/drawing/2014/main" id="{3DED508C-7EC1-BB40-A157-108A6709112F}"/>
               </a:ext>
             </a:extLst>
           </p:cNvPr>
@@ -34407,7 +34407,7 @@
           <p:cNvPr id="7175" name="Picture 7" descr="Copy">
             <a:extLst>
               <a:ext uri="{FF2B5EF4-FFF2-40B4-BE49-F238E27FC236}">
-                <a16:creationId xmlns:a16="http://schemas.microsoft.com/office/drawing/2014/main" xmlns="" id="{FC190F5E-B29D-6344-996E-E87C33A1C30A}"/>
+                <a16:creationId xmlns:a16="http://schemas.microsoft.com/office/drawing/2014/main" id="{FC190F5E-B29D-6344-996E-E87C33A1C30A}"/>
               </a:ext>
             </a:extLst>
           </p:cNvPr>
@@ -34454,7 +34454,7 @@
           <p:cNvPr id="7176" name="Picture 8" descr="Delete">
             <a:extLst>
               <a:ext uri="{FF2B5EF4-FFF2-40B4-BE49-F238E27FC236}">
-                <a16:creationId xmlns:a16="http://schemas.microsoft.com/office/drawing/2014/main" xmlns="" id="{27FD3534-0333-B04B-9A1D-C1016297D742}"/>
+                <a16:creationId xmlns:a16="http://schemas.microsoft.com/office/drawing/2014/main" id="{27FD3534-0333-B04B-9A1D-C1016297D742}"/>
               </a:ext>
             </a:extLst>
           </p:cNvPr>
@@ -34501,7 +34501,7 @@
           <p:cNvPr id="7177" name="Picture 9" descr="Edit">
             <a:extLst>
               <a:ext uri="{FF2B5EF4-FFF2-40B4-BE49-F238E27FC236}">
-                <a16:creationId xmlns:a16="http://schemas.microsoft.com/office/drawing/2014/main" xmlns="" id="{E6B3C597-A2C0-5641-8FA6-A4C08CB3D95E}"/>
+                <a16:creationId xmlns:a16="http://schemas.microsoft.com/office/drawing/2014/main" id="{E6B3C597-A2C0-5641-8FA6-A4C08CB3D95E}"/>
               </a:ext>
             </a:extLst>
           </p:cNvPr>
@@ -34548,7 +34548,7 @@
           <p:cNvPr id="7178" name="Picture 10" descr="Copy">
             <a:extLst>
               <a:ext uri="{FF2B5EF4-FFF2-40B4-BE49-F238E27FC236}">
-                <a16:creationId xmlns:a16="http://schemas.microsoft.com/office/drawing/2014/main" xmlns="" id="{2E3E32CB-7E12-0545-A423-68FACE7C7693}"/>
+                <a16:creationId xmlns:a16="http://schemas.microsoft.com/office/drawing/2014/main" id="{2E3E32CB-7E12-0545-A423-68FACE7C7693}"/>
               </a:ext>
             </a:extLst>
           </p:cNvPr>
@@ -34595,7 +34595,7 @@
           <p:cNvPr id="7179" name="Picture 11" descr="Delete">
             <a:extLst>
               <a:ext uri="{FF2B5EF4-FFF2-40B4-BE49-F238E27FC236}">
-                <a16:creationId xmlns:a16="http://schemas.microsoft.com/office/drawing/2014/main" xmlns="" id="{A3DD466D-EEBC-B349-B9B9-6FBA1FCCFA53}"/>
+                <a16:creationId xmlns:a16="http://schemas.microsoft.com/office/drawing/2014/main" id="{A3DD466D-EEBC-B349-B9B9-6FBA1FCCFA53}"/>
               </a:ext>
             </a:extLst>
           </p:cNvPr>
@@ -34642,7 +34642,7 @@
           <p:cNvPr id="7180" name="Picture 12" descr="Edit">
             <a:extLst>
               <a:ext uri="{FF2B5EF4-FFF2-40B4-BE49-F238E27FC236}">
-                <a16:creationId xmlns:a16="http://schemas.microsoft.com/office/drawing/2014/main" xmlns="" id="{74CA1543-4767-0443-99BD-551F5E25CA15}"/>
+                <a16:creationId xmlns:a16="http://schemas.microsoft.com/office/drawing/2014/main" id="{74CA1543-4767-0443-99BD-551F5E25CA15}"/>
               </a:ext>
             </a:extLst>
           </p:cNvPr>
@@ -34689,7 +34689,7 @@
           <p:cNvPr id="7181" name="Picture 13" descr="Copy">
             <a:extLst>
               <a:ext uri="{FF2B5EF4-FFF2-40B4-BE49-F238E27FC236}">
-                <a16:creationId xmlns:a16="http://schemas.microsoft.com/office/drawing/2014/main" xmlns="" id="{349B3A53-E673-E148-B870-02F442734CE7}"/>
+                <a16:creationId xmlns:a16="http://schemas.microsoft.com/office/drawing/2014/main" id="{349B3A53-E673-E148-B870-02F442734CE7}"/>
               </a:ext>
             </a:extLst>
           </p:cNvPr>
@@ -34736,7 +34736,7 @@
           <p:cNvPr id="7182" name="Picture 14" descr="Delete">
             <a:extLst>
               <a:ext uri="{FF2B5EF4-FFF2-40B4-BE49-F238E27FC236}">
-                <a16:creationId xmlns:a16="http://schemas.microsoft.com/office/drawing/2014/main" xmlns="" id="{D306A5A9-DCC8-4549-8C94-2F85523CE0E4}"/>
+                <a16:creationId xmlns:a16="http://schemas.microsoft.com/office/drawing/2014/main" id="{D306A5A9-DCC8-4549-8C94-2F85523CE0E4}"/>
               </a:ext>
             </a:extLst>
           </p:cNvPr>
@@ -34783,7 +34783,7 @@
           <p:cNvPr id="7183" name="Picture 15" descr="Edit">
             <a:extLst>
               <a:ext uri="{FF2B5EF4-FFF2-40B4-BE49-F238E27FC236}">
-                <a16:creationId xmlns:a16="http://schemas.microsoft.com/office/drawing/2014/main" xmlns="" id="{21E5A904-E74A-6B46-AE2E-F5BCC53BCDBB}"/>
+                <a16:creationId xmlns:a16="http://schemas.microsoft.com/office/drawing/2014/main" id="{21E5A904-E74A-6B46-AE2E-F5BCC53BCDBB}"/>
               </a:ext>
             </a:extLst>
           </p:cNvPr>
@@ -34830,7 +34830,7 @@
           <p:cNvPr id="7184" name="Picture 16" descr="Copy">
             <a:extLst>
               <a:ext uri="{FF2B5EF4-FFF2-40B4-BE49-F238E27FC236}">
-                <a16:creationId xmlns:a16="http://schemas.microsoft.com/office/drawing/2014/main" xmlns="" id="{90E2174F-801A-484F-9F9D-0F68A3E71E32}"/>
+                <a16:creationId xmlns:a16="http://schemas.microsoft.com/office/drawing/2014/main" id="{90E2174F-801A-484F-9F9D-0F68A3E71E32}"/>
               </a:ext>
             </a:extLst>
           </p:cNvPr>
@@ -34877,7 +34877,7 @@
           <p:cNvPr id="7185" name="Picture 17" descr="Delete">
             <a:extLst>
               <a:ext uri="{FF2B5EF4-FFF2-40B4-BE49-F238E27FC236}">
-                <a16:creationId xmlns:a16="http://schemas.microsoft.com/office/drawing/2014/main" xmlns="" id="{94133C48-B1C7-AA49-92AC-8F9331F19398}"/>
+                <a16:creationId xmlns:a16="http://schemas.microsoft.com/office/drawing/2014/main" id="{94133C48-B1C7-AA49-92AC-8F9331F19398}"/>
               </a:ext>
             </a:extLst>
           </p:cNvPr>
@@ -34924,7 +34924,7 @@
           <p:cNvPr id="7186" name="Picture 18" descr="Edit">
             <a:extLst>
               <a:ext uri="{FF2B5EF4-FFF2-40B4-BE49-F238E27FC236}">
-                <a16:creationId xmlns:a16="http://schemas.microsoft.com/office/drawing/2014/main" xmlns="" id="{2E1311ED-F149-084C-A8F4-E6397E967C51}"/>
+                <a16:creationId xmlns:a16="http://schemas.microsoft.com/office/drawing/2014/main" id="{2E1311ED-F149-084C-A8F4-E6397E967C51}"/>
               </a:ext>
             </a:extLst>
           </p:cNvPr>
@@ -34971,7 +34971,7 @@
           <p:cNvPr id="7187" name="Picture 19" descr="Copy">
             <a:extLst>
               <a:ext uri="{FF2B5EF4-FFF2-40B4-BE49-F238E27FC236}">
-                <a16:creationId xmlns:a16="http://schemas.microsoft.com/office/drawing/2014/main" xmlns="" id="{C030EA95-28E1-3A4E-9286-06ED81A83917}"/>
+                <a16:creationId xmlns:a16="http://schemas.microsoft.com/office/drawing/2014/main" id="{C030EA95-28E1-3A4E-9286-06ED81A83917}"/>
               </a:ext>
             </a:extLst>
           </p:cNvPr>
@@ -35018,7 +35018,7 @@
           <p:cNvPr id="7188" name="Picture 20" descr="Delete">
             <a:extLst>
               <a:ext uri="{FF2B5EF4-FFF2-40B4-BE49-F238E27FC236}">
-                <a16:creationId xmlns:a16="http://schemas.microsoft.com/office/drawing/2014/main" xmlns="" id="{7760BD29-0768-7740-AE93-754B4A8E9EC7}"/>
+                <a16:creationId xmlns:a16="http://schemas.microsoft.com/office/drawing/2014/main" id="{7760BD29-0768-7740-AE93-754B4A8E9EC7}"/>
               </a:ext>
             </a:extLst>
           </p:cNvPr>
@@ -35065,7 +35065,7 @@
           <p:cNvPr id="7189" name="Picture 21" descr="Edit">
             <a:extLst>
               <a:ext uri="{FF2B5EF4-FFF2-40B4-BE49-F238E27FC236}">
-                <a16:creationId xmlns:a16="http://schemas.microsoft.com/office/drawing/2014/main" xmlns="" id="{86EE7E1D-B3BB-B34A-A34A-821AF5F8742A}"/>
+                <a16:creationId xmlns:a16="http://schemas.microsoft.com/office/drawing/2014/main" id="{86EE7E1D-B3BB-B34A-A34A-821AF5F8742A}"/>
               </a:ext>
             </a:extLst>
           </p:cNvPr>
@@ -35112,7 +35112,7 @@
           <p:cNvPr id="7190" name="Picture 22" descr="Copy">
             <a:extLst>
               <a:ext uri="{FF2B5EF4-FFF2-40B4-BE49-F238E27FC236}">
-                <a16:creationId xmlns:a16="http://schemas.microsoft.com/office/drawing/2014/main" xmlns="" id="{862F129A-C396-C448-8B35-9E5ECB71A3FC}"/>
+                <a16:creationId xmlns:a16="http://schemas.microsoft.com/office/drawing/2014/main" id="{862F129A-C396-C448-8B35-9E5ECB71A3FC}"/>
               </a:ext>
             </a:extLst>
           </p:cNvPr>
@@ -35159,7 +35159,7 @@
           <p:cNvPr id="7191" name="Picture 23" descr="Delete">
             <a:extLst>
               <a:ext uri="{FF2B5EF4-FFF2-40B4-BE49-F238E27FC236}">
-                <a16:creationId xmlns:a16="http://schemas.microsoft.com/office/drawing/2014/main" xmlns="" id="{E533F4DC-FC7E-B84C-8A4A-72573BFF7813}"/>
+                <a16:creationId xmlns:a16="http://schemas.microsoft.com/office/drawing/2014/main" id="{E533F4DC-FC7E-B84C-8A4A-72573BFF7813}"/>
               </a:ext>
             </a:extLst>
           </p:cNvPr>
@@ -35206,7 +35206,7 @@
           <p:cNvPr id="7192" name="Picture 24" descr="Edit">
             <a:extLst>
               <a:ext uri="{FF2B5EF4-FFF2-40B4-BE49-F238E27FC236}">
-                <a16:creationId xmlns:a16="http://schemas.microsoft.com/office/drawing/2014/main" xmlns="" id="{305AC1A0-001A-B24C-AC0C-ED44BB393A92}"/>
+                <a16:creationId xmlns:a16="http://schemas.microsoft.com/office/drawing/2014/main" id="{305AC1A0-001A-B24C-AC0C-ED44BB393A92}"/>
               </a:ext>
             </a:extLst>
           </p:cNvPr>
@@ -35253,7 +35253,7 @@
           <p:cNvPr id="7193" name="Picture 25" descr="Copy">
             <a:extLst>
               <a:ext uri="{FF2B5EF4-FFF2-40B4-BE49-F238E27FC236}">
-                <a16:creationId xmlns:a16="http://schemas.microsoft.com/office/drawing/2014/main" xmlns="" id="{81A9DE29-9C1E-774E-826F-E08F62769A62}"/>
+                <a16:creationId xmlns:a16="http://schemas.microsoft.com/office/drawing/2014/main" id="{81A9DE29-9C1E-774E-826F-E08F62769A62}"/>
               </a:ext>
             </a:extLst>
           </p:cNvPr>
@@ -35300,7 +35300,7 @@
           <p:cNvPr id="7194" name="Picture 26" descr="Delete">
             <a:extLst>
               <a:ext uri="{FF2B5EF4-FFF2-40B4-BE49-F238E27FC236}">
-                <a16:creationId xmlns:a16="http://schemas.microsoft.com/office/drawing/2014/main" xmlns="" id="{28F49F1F-10C7-5245-93C9-55935E0A7997}"/>
+                <a16:creationId xmlns:a16="http://schemas.microsoft.com/office/drawing/2014/main" id="{28F49F1F-10C7-5245-93C9-55935E0A7997}"/>
               </a:ext>
             </a:extLst>
           </p:cNvPr>
@@ -35347,7 +35347,7 @@
           <p:cNvPr id="7195" name="Picture 27" descr="Edit">
             <a:extLst>
               <a:ext uri="{FF2B5EF4-FFF2-40B4-BE49-F238E27FC236}">
-                <a16:creationId xmlns:a16="http://schemas.microsoft.com/office/drawing/2014/main" xmlns="" id="{8F192FC9-44DB-C243-A214-73178E222CCE}"/>
+                <a16:creationId xmlns:a16="http://schemas.microsoft.com/office/drawing/2014/main" id="{8F192FC9-44DB-C243-A214-73178E222CCE}"/>
               </a:ext>
             </a:extLst>
           </p:cNvPr>
@@ -35394,7 +35394,7 @@
           <p:cNvPr id="7196" name="Picture 28" descr="Copy">
             <a:extLst>
               <a:ext uri="{FF2B5EF4-FFF2-40B4-BE49-F238E27FC236}">
-                <a16:creationId xmlns:a16="http://schemas.microsoft.com/office/drawing/2014/main" xmlns="" id="{C5548135-F3BC-1744-AB44-4104A61009EF}"/>
+                <a16:creationId xmlns:a16="http://schemas.microsoft.com/office/drawing/2014/main" id="{C5548135-F3BC-1744-AB44-4104A61009EF}"/>
               </a:ext>
             </a:extLst>
           </p:cNvPr>
@@ -35441,7 +35441,7 @@
           <p:cNvPr id="7197" name="Picture 29" descr="Delete">
             <a:extLst>
               <a:ext uri="{FF2B5EF4-FFF2-40B4-BE49-F238E27FC236}">
-                <a16:creationId xmlns:a16="http://schemas.microsoft.com/office/drawing/2014/main" xmlns="" id="{7361ED48-0603-A84B-BC4A-3B378B4536EA}"/>
+                <a16:creationId xmlns:a16="http://schemas.microsoft.com/office/drawing/2014/main" id="{7361ED48-0603-A84B-BC4A-3B378B4536EA}"/>
               </a:ext>
             </a:extLst>
           </p:cNvPr>
@@ -35488,7 +35488,7 @@
           <p:cNvPr id="7198" name="Picture 30" descr="Edit">
             <a:extLst>
               <a:ext uri="{FF2B5EF4-FFF2-40B4-BE49-F238E27FC236}">
-                <a16:creationId xmlns:a16="http://schemas.microsoft.com/office/drawing/2014/main" xmlns="" id="{6F1966E0-4F34-0B47-8CF1-2CB129A2B5BD}"/>
+                <a16:creationId xmlns:a16="http://schemas.microsoft.com/office/drawing/2014/main" id="{6F1966E0-4F34-0B47-8CF1-2CB129A2B5BD}"/>
               </a:ext>
             </a:extLst>
           </p:cNvPr>
@@ -35535,7 +35535,7 @@
           <p:cNvPr id="7199" name="Picture 31" descr="Copy">
             <a:extLst>
               <a:ext uri="{FF2B5EF4-FFF2-40B4-BE49-F238E27FC236}">
-                <a16:creationId xmlns:a16="http://schemas.microsoft.com/office/drawing/2014/main" xmlns="" id="{4DD913C6-C486-094C-B6FB-5BDE7C23E5A0}"/>
+                <a16:creationId xmlns:a16="http://schemas.microsoft.com/office/drawing/2014/main" id="{4DD913C6-C486-094C-B6FB-5BDE7C23E5A0}"/>
               </a:ext>
             </a:extLst>
           </p:cNvPr>
@@ -35582,7 +35582,7 @@
           <p:cNvPr id="7200" name="Picture 32" descr="Delete">
             <a:extLst>
               <a:ext uri="{FF2B5EF4-FFF2-40B4-BE49-F238E27FC236}">
-                <a16:creationId xmlns:a16="http://schemas.microsoft.com/office/drawing/2014/main" xmlns="" id="{8D269F99-DE51-0044-8E70-B70960F75153}"/>
+                <a16:creationId xmlns:a16="http://schemas.microsoft.com/office/drawing/2014/main" id="{8D269F99-DE51-0044-8E70-B70960F75153}"/>
               </a:ext>
             </a:extLst>
           </p:cNvPr>
@@ -35629,7 +35629,7 @@
           <p:cNvPr id="7201" name="Picture 33" descr="Edit">
             <a:extLst>
               <a:ext uri="{FF2B5EF4-FFF2-40B4-BE49-F238E27FC236}">
-                <a16:creationId xmlns:a16="http://schemas.microsoft.com/office/drawing/2014/main" xmlns="" id="{8EEEB258-DD9F-4743-BF68-7D1DDAB51A1B}"/>
+                <a16:creationId xmlns:a16="http://schemas.microsoft.com/office/drawing/2014/main" id="{8EEEB258-DD9F-4743-BF68-7D1DDAB51A1B}"/>
               </a:ext>
             </a:extLst>
           </p:cNvPr>
@@ -35676,7 +35676,7 @@
           <p:cNvPr id="7202" name="Picture 34" descr="Copy">
             <a:extLst>
               <a:ext uri="{FF2B5EF4-FFF2-40B4-BE49-F238E27FC236}">
-                <a16:creationId xmlns:a16="http://schemas.microsoft.com/office/drawing/2014/main" xmlns="" id="{2247A77E-80FB-904D-9E00-F839C754418F}"/>
+                <a16:creationId xmlns:a16="http://schemas.microsoft.com/office/drawing/2014/main" id="{2247A77E-80FB-904D-9E00-F839C754418F}"/>
               </a:ext>
             </a:extLst>
           </p:cNvPr>
@@ -35723,7 +35723,7 @@
           <p:cNvPr id="7203" name="Picture 35" descr="Delete">
             <a:extLst>
               <a:ext uri="{FF2B5EF4-FFF2-40B4-BE49-F238E27FC236}">
-                <a16:creationId xmlns:a16="http://schemas.microsoft.com/office/drawing/2014/main" xmlns="" id="{639CC710-9294-0641-BAEA-37C6FDB55D65}"/>
+                <a16:creationId xmlns:a16="http://schemas.microsoft.com/office/drawing/2014/main" id="{639CC710-9294-0641-BAEA-37C6FDB55D65}"/>
               </a:ext>
             </a:extLst>
           </p:cNvPr>
@@ -35770,7 +35770,7 @@
           <p:cNvPr id="7204" name="Picture 36" descr="Edit">
             <a:extLst>
               <a:ext uri="{FF2B5EF4-FFF2-40B4-BE49-F238E27FC236}">
-                <a16:creationId xmlns:a16="http://schemas.microsoft.com/office/drawing/2014/main" xmlns="" id="{C1E6C482-4681-3940-94B4-6EFA7CC30FFC}"/>
+                <a16:creationId xmlns:a16="http://schemas.microsoft.com/office/drawing/2014/main" id="{C1E6C482-4681-3940-94B4-6EFA7CC30FFC}"/>
               </a:ext>
             </a:extLst>
           </p:cNvPr>
@@ -35817,7 +35817,7 @@
           <p:cNvPr id="7205" name="Picture 37" descr="Copy">
             <a:extLst>
               <a:ext uri="{FF2B5EF4-FFF2-40B4-BE49-F238E27FC236}">
-                <a16:creationId xmlns:a16="http://schemas.microsoft.com/office/drawing/2014/main" xmlns="" id="{159A1B20-2B46-C040-A4CA-DFE0FE13E26B}"/>
+                <a16:creationId xmlns:a16="http://schemas.microsoft.com/office/drawing/2014/main" id="{159A1B20-2B46-C040-A4CA-DFE0FE13E26B}"/>
               </a:ext>
             </a:extLst>
           </p:cNvPr>
@@ -35864,7 +35864,7 @@
           <p:cNvPr id="7206" name="Picture 38" descr="Delete">
             <a:extLst>
               <a:ext uri="{FF2B5EF4-FFF2-40B4-BE49-F238E27FC236}">
-                <a16:creationId xmlns:a16="http://schemas.microsoft.com/office/drawing/2014/main" xmlns="" id="{0A8381CA-320A-7249-8C48-147A19F96E41}"/>
+                <a16:creationId xmlns:a16="http://schemas.microsoft.com/office/drawing/2014/main" id="{0A8381CA-320A-7249-8C48-147A19F96E41}"/>
               </a:ext>
             </a:extLst>
           </p:cNvPr>
@@ -35911,7 +35911,7 @@
           <p:cNvPr id="7207" name="Picture 39" descr="Edit">
             <a:extLst>
               <a:ext uri="{FF2B5EF4-FFF2-40B4-BE49-F238E27FC236}">
-                <a16:creationId xmlns:a16="http://schemas.microsoft.com/office/drawing/2014/main" xmlns="" id="{23299FDB-6800-2147-B702-26AE4D8942F7}"/>
+                <a16:creationId xmlns:a16="http://schemas.microsoft.com/office/drawing/2014/main" id="{23299FDB-6800-2147-B702-26AE4D8942F7}"/>
               </a:ext>
             </a:extLst>
           </p:cNvPr>
@@ -35958,7 +35958,7 @@
           <p:cNvPr id="7208" name="Picture 40" descr="Copy">
             <a:extLst>
               <a:ext uri="{FF2B5EF4-FFF2-40B4-BE49-F238E27FC236}">
-                <a16:creationId xmlns:a16="http://schemas.microsoft.com/office/drawing/2014/main" xmlns="" id="{C9D2DC4D-C2FC-B34F-90D2-67FD46CFF270}"/>
+                <a16:creationId xmlns:a16="http://schemas.microsoft.com/office/drawing/2014/main" id="{C9D2DC4D-C2FC-B34F-90D2-67FD46CFF270}"/>
               </a:ext>
             </a:extLst>
           </p:cNvPr>
@@ -36005,7 +36005,7 @@
           <p:cNvPr id="7209" name="Picture 41" descr="Delete">
             <a:extLst>
               <a:ext uri="{FF2B5EF4-FFF2-40B4-BE49-F238E27FC236}">
-                <a16:creationId xmlns:a16="http://schemas.microsoft.com/office/drawing/2014/main" xmlns="" id="{6BBFB826-B21C-B24E-8ADD-4D6D4A2FFBC8}"/>
+                <a16:creationId xmlns:a16="http://schemas.microsoft.com/office/drawing/2014/main" id="{6BBFB826-B21C-B24E-8ADD-4D6D4A2FFBC8}"/>
               </a:ext>
             </a:extLst>
           </p:cNvPr>
@@ -36052,7 +36052,7 @@
           <p:cNvPr id="7210" name="Picture 42" descr="Edit">
             <a:extLst>
               <a:ext uri="{FF2B5EF4-FFF2-40B4-BE49-F238E27FC236}">
-                <a16:creationId xmlns:a16="http://schemas.microsoft.com/office/drawing/2014/main" xmlns="" id="{350D84E9-2CD7-394A-B4A7-2774D96F5043}"/>
+                <a16:creationId xmlns:a16="http://schemas.microsoft.com/office/drawing/2014/main" id="{350D84E9-2CD7-394A-B4A7-2774D96F5043}"/>
               </a:ext>
             </a:extLst>
           </p:cNvPr>
@@ -36099,7 +36099,7 @@
           <p:cNvPr id="7211" name="Picture 43" descr="Copy">
             <a:extLst>
               <a:ext uri="{FF2B5EF4-FFF2-40B4-BE49-F238E27FC236}">
-                <a16:creationId xmlns:a16="http://schemas.microsoft.com/office/drawing/2014/main" xmlns="" id="{F82C45A0-60D7-FE44-9E82-6C92B334058A}"/>
+                <a16:creationId xmlns:a16="http://schemas.microsoft.com/office/drawing/2014/main" id="{F82C45A0-60D7-FE44-9E82-6C92B334058A}"/>
               </a:ext>
             </a:extLst>
           </p:cNvPr>
@@ -36146,7 +36146,7 @@
           <p:cNvPr id="7212" name="Picture 44" descr="Delete">
             <a:extLst>
               <a:ext uri="{FF2B5EF4-FFF2-40B4-BE49-F238E27FC236}">
-                <a16:creationId xmlns:a16="http://schemas.microsoft.com/office/drawing/2014/main" xmlns="" id="{C180F2FA-07ED-3249-9093-DAED3656D9B0}"/>
+                <a16:creationId xmlns:a16="http://schemas.microsoft.com/office/drawing/2014/main" id="{C180F2FA-07ED-3249-9093-DAED3656D9B0}"/>
               </a:ext>
             </a:extLst>
           </p:cNvPr>
@@ -36193,7 +36193,7 @@
           <p:cNvPr id="7213" name="Picture 45" descr="Edit">
             <a:extLst>
               <a:ext uri="{FF2B5EF4-FFF2-40B4-BE49-F238E27FC236}">
-                <a16:creationId xmlns:a16="http://schemas.microsoft.com/office/drawing/2014/main" xmlns="" id="{00A1D60C-8C08-7848-93FE-C05E424E788D}"/>
+                <a16:creationId xmlns:a16="http://schemas.microsoft.com/office/drawing/2014/main" id="{00A1D60C-8C08-7848-93FE-C05E424E788D}"/>
               </a:ext>
             </a:extLst>
           </p:cNvPr>
@@ -36240,7 +36240,7 @@
           <p:cNvPr id="7214" name="Picture 46" descr="Copy">
             <a:extLst>
               <a:ext uri="{FF2B5EF4-FFF2-40B4-BE49-F238E27FC236}">
-                <a16:creationId xmlns:a16="http://schemas.microsoft.com/office/drawing/2014/main" xmlns="" id="{F8A7F605-378A-4D4D-802C-FB3A2E832619}"/>
+                <a16:creationId xmlns:a16="http://schemas.microsoft.com/office/drawing/2014/main" id="{F8A7F605-378A-4D4D-802C-FB3A2E832619}"/>
               </a:ext>
             </a:extLst>
           </p:cNvPr>
@@ -36287,7 +36287,7 @@
           <p:cNvPr id="7215" name="Picture 47" descr="Delete">
             <a:extLst>
               <a:ext uri="{FF2B5EF4-FFF2-40B4-BE49-F238E27FC236}">
-                <a16:creationId xmlns:a16="http://schemas.microsoft.com/office/drawing/2014/main" xmlns="" id="{8B9117B3-CD16-074F-82A3-D5096A4DFD68}"/>
+                <a16:creationId xmlns:a16="http://schemas.microsoft.com/office/drawing/2014/main" id="{8B9117B3-CD16-074F-82A3-D5096A4DFD68}"/>
               </a:ext>
             </a:extLst>
           </p:cNvPr>
@@ -36334,7 +36334,7 @@
           <p:cNvPr id="7216" name="Picture 48" descr="Edit">
             <a:extLst>
               <a:ext uri="{FF2B5EF4-FFF2-40B4-BE49-F238E27FC236}">
-                <a16:creationId xmlns:a16="http://schemas.microsoft.com/office/drawing/2014/main" xmlns="" id="{2FE84A72-AA0D-334A-B03A-7E066B4DEEB3}"/>
+                <a16:creationId xmlns:a16="http://schemas.microsoft.com/office/drawing/2014/main" id="{2FE84A72-AA0D-334A-B03A-7E066B4DEEB3}"/>
               </a:ext>
             </a:extLst>
           </p:cNvPr>
@@ -36381,7 +36381,7 @@
           <p:cNvPr id="7217" name="Picture 49" descr="Copy">
             <a:extLst>
               <a:ext uri="{FF2B5EF4-FFF2-40B4-BE49-F238E27FC236}">
-                <a16:creationId xmlns:a16="http://schemas.microsoft.com/office/drawing/2014/main" xmlns="" id="{E845E9CE-1525-1E40-890D-A51A605EE695}"/>
+                <a16:creationId xmlns:a16="http://schemas.microsoft.com/office/drawing/2014/main" id="{E845E9CE-1525-1E40-890D-A51A605EE695}"/>
               </a:ext>
             </a:extLst>
           </p:cNvPr>
@@ -36428,7 +36428,7 @@
           <p:cNvPr id="7218" name="Picture 50" descr="Delete">
             <a:extLst>
               <a:ext uri="{FF2B5EF4-FFF2-40B4-BE49-F238E27FC236}">
-                <a16:creationId xmlns:a16="http://schemas.microsoft.com/office/drawing/2014/main" xmlns="" id="{0FE3432E-477B-C74E-80BC-C209526F002F}"/>
+                <a16:creationId xmlns:a16="http://schemas.microsoft.com/office/drawing/2014/main" id="{0FE3432E-477B-C74E-80BC-C209526F002F}"/>
               </a:ext>
             </a:extLst>
           </p:cNvPr>
@@ -36475,7 +36475,7 @@
           <p:cNvPr id="7219" name="Picture 51" descr="Edit">
             <a:extLst>
               <a:ext uri="{FF2B5EF4-FFF2-40B4-BE49-F238E27FC236}">
-                <a16:creationId xmlns:a16="http://schemas.microsoft.com/office/drawing/2014/main" xmlns="" id="{DA98ACB1-2101-FE40-9A55-836B005D6002}"/>
+                <a16:creationId xmlns:a16="http://schemas.microsoft.com/office/drawing/2014/main" id="{DA98ACB1-2101-FE40-9A55-836B005D6002}"/>
               </a:ext>
             </a:extLst>
           </p:cNvPr>
@@ -36522,7 +36522,7 @@
           <p:cNvPr id="7220" name="Picture 52" descr="Copy">
             <a:extLst>
               <a:ext uri="{FF2B5EF4-FFF2-40B4-BE49-F238E27FC236}">
-                <a16:creationId xmlns:a16="http://schemas.microsoft.com/office/drawing/2014/main" xmlns="" id="{230D71F9-D01D-FF42-B758-EF61F22C12E6}"/>
+                <a16:creationId xmlns:a16="http://schemas.microsoft.com/office/drawing/2014/main" id="{230D71F9-D01D-FF42-B758-EF61F22C12E6}"/>
               </a:ext>
             </a:extLst>
           </p:cNvPr>
@@ -36569,7 +36569,7 @@
           <p:cNvPr id="7221" name="Picture 53" descr="Delete">
             <a:extLst>
               <a:ext uri="{FF2B5EF4-FFF2-40B4-BE49-F238E27FC236}">
-                <a16:creationId xmlns:a16="http://schemas.microsoft.com/office/drawing/2014/main" xmlns="" id="{073FE7BA-5FC2-3645-9766-0FB9DFAB6C34}"/>
+                <a16:creationId xmlns:a16="http://schemas.microsoft.com/office/drawing/2014/main" id="{073FE7BA-5FC2-3645-9766-0FB9DFAB6C34}"/>
               </a:ext>
             </a:extLst>
           </p:cNvPr>
@@ -36616,7 +36616,7 @@
           <p:cNvPr id="7222" name="Picture 54" descr="Edit">
             <a:extLst>
               <a:ext uri="{FF2B5EF4-FFF2-40B4-BE49-F238E27FC236}">
-                <a16:creationId xmlns:a16="http://schemas.microsoft.com/office/drawing/2014/main" xmlns="" id="{D9AFD85A-CE4B-484A-A5B8-BAEABB586A99}"/>
+                <a16:creationId xmlns:a16="http://schemas.microsoft.com/office/drawing/2014/main" id="{D9AFD85A-CE4B-484A-A5B8-BAEABB586A99}"/>
               </a:ext>
             </a:extLst>
           </p:cNvPr>
@@ -36663,7 +36663,7 @@
           <p:cNvPr id="7223" name="Picture 55" descr="Copy">
             <a:extLst>
               <a:ext uri="{FF2B5EF4-FFF2-40B4-BE49-F238E27FC236}">
-                <a16:creationId xmlns:a16="http://schemas.microsoft.com/office/drawing/2014/main" xmlns="" id="{A44154A1-1786-3F4C-9953-8101DE25013C}"/>
+                <a16:creationId xmlns:a16="http://schemas.microsoft.com/office/drawing/2014/main" id="{A44154A1-1786-3F4C-9953-8101DE25013C}"/>
               </a:ext>
             </a:extLst>
           </p:cNvPr>
@@ -36710,7 +36710,7 @@
           <p:cNvPr id="7224" name="Picture 56" descr="Delete">
             <a:extLst>
               <a:ext uri="{FF2B5EF4-FFF2-40B4-BE49-F238E27FC236}">
-                <a16:creationId xmlns:a16="http://schemas.microsoft.com/office/drawing/2014/main" xmlns="" id="{CDB26216-F520-9D43-9F03-CC6078D11A7C}"/>
+                <a16:creationId xmlns:a16="http://schemas.microsoft.com/office/drawing/2014/main" id="{CDB26216-F520-9D43-9F03-CC6078D11A7C}"/>
               </a:ext>
             </a:extLst>
           </p:cNvPr>
@@ -36757,7 +36757,7 @@
           <p:cNvPr id="7225" name="Picture 57" descr="Edit">
             <a:extLst>
               <a:ext uri="{FF2B5EF4-FFF2-40B4-BE49-F238E27FC236}">
-                <a16:creationId xmlns:a16="http://schemas.microsoft.com/office/drawing/2014/main" xmlns="" id="{10F1DB99-8A42-A348-AA03-2A064895E56E}"/>
+                <a16:creationId xmlns:a16="http://schemas.microsoft.com/office/drawing/2014/main" id="{10F1DB99-8A42-A348-AA03-2A064895E56E}"/>
               </a:ext>
             </a:extLst>
           </p:cNvPr>
@@ -36804,7 +36804,7 @@
           <p:cNvPr id="7226" name="Picture 58" descr="Copy">
             <a:extLst>
               <a:ext uri="{FF2B5EF4-FFF2-40B4-BE49-F238E27FC236}">
-                <a16:creationId xmlns:a16="http://schemas.microsoft.com/office/drawing/2014/main" xmlns="" id="{313C5482-C410-FE44-9B67-CFA917740410}"/>
+                <a16:creationId xmlns:a16="http://schemas.microsoft.com/office/drawing/2014/main" id="{313C5482-C410-FE44-9B67-CFA917740410}"/>
               </a:ext>
             </a:extLst>
           </p:cNvPr>
@@ -36851,7 +36851,7 @@
           <p:cNvPr id="7227" name="Picture 59" descr="Delete">
             <a:extLst>
               <a:ext uri="{FF2B5EF4-FFF2-40B4-BE49-F238E27FC236}">
-                <a16:creationId xmlns:a16="http://schemas.microsoft.com/office/drawing/2014/main" xmlns="" id="{C5120BAF-0DD1-3B4A-8782-ADEE7BB95F62}"/>
+                <a16:creationId xmlns:a16="http://schemas.microsoft.com/office/drawing/2014/main" id="{C5120BAF-0DD1-3B4A-8782-ADEE7BB95F62}"/>
               </a:ext>
             </a:extLst>
           </p:cNvPr>
@@ -36898,7 +36898,7 @@
           <p:cNvPr id="7228" name="Picture 60" descr="Edit">
             <a:extLst>
               <a:ext uri="{FF2B5EF4-FFF2-40B4-BE49-F238E27FC236}">
-                <a16:creationId xmlns:a16="http://schemas.microsoft.com/office/drawing/2014/main" xmlns="" id="{5D659988-94E0-AD4F-9466-4B46A9CCA9AC}"/>
+                <a16:creationId xmlns:a16="http://schemas.microsoft.com/office/drawing/2014/main" id="{5D659988-94E0-AD4F-9466-4B46A9CCA9AC}"/>
               </a:ext>
             </a:extLst>
           </p:cNvPr>
@@ -36945,7 +36945,7 @@
           <p:cNvPr id="7229" name="Picture 61" descr="Copy">
             <a:extLst>
               <a:ext uri="{FF2B5EF4-FFF2-40B4-BE49-F238E27FC236}">
-                <a16:creationId xmlns:a16="http://schemas.microsoft.com/office/drawing/2014/main" xmlns="" id="{9AA81DD6-A2AC-D749-A4FE-F82626FFFA96}"/>
+                <a16:creationId xmlns:a16="http://schemas.microsoft.com/office/drawing/2014/main" id="{9AA81DD6-A2AC-D749-A4FE-F82626FFFA96}"/>
               </a:ext>
             </a:extLst>
           </p:cNvPr>
@@ -36992,7 +36992,7 @@
           <p:cNvPr id="7230" name="Picture 62" descr="Delete">
             <a:extLst>
               <a:ext uri="{FF2B5EF4-FFF2-40B4-BE49-F238E27FC236}">
-                <a16:creationId xmlns:a16="http://schemas.microsoft.com/office/drawing/2014/main" xmlns="" id="{EAD8EBD8-D30D-1544-AA88-0A043D10F320}"/>
+                <a16:creationId xmlns:a16="http://schemas.microsoft.com/office/drawing/2014/main" id="{EAD8EBD8-D30D-1544-AA88-0A043D10F320}"/>
               </a:ext>
             </a:extLst>
           </p:cNvPr>
@@ -37039,7 +37039,7 @@
           <p:cNvPr id="7231" name="Picture 63" descr="Edit">
             <a:extLst>
               <a:ext uri="{FF2B5EF4-FFF2-40B4-BE49-F238E27FC236}">
-                <a16:creationId xmlns:a16="http://schemas.microsoft.com/office/drawing/2014/main" xmlns="" id="{FA619B7B-F6B9-A24C-A391-BAB5A4C5DE99}"/>
+                <a16:creationId xmlns:a16="http://schemas.microsoft.com/office/drawing/2014/main" id="{FA619B7B-F6B9-A24C-A391-BAB5A4C5DE99}"/>
               </a:ext>
             </a:extLst>
           </p:cNvPr>
@@ -37086,7 +37086,7 @@
           <p:cNvPr id="7232" name="Picture 64" descr="Copy">
             <a:extLst>
               <a:ext uri="{FF2B5EF4-FFF2-40B4-BE49-F238E27FC236}">
-                <a16:creationId xmlns:a16="http://schemas.microsoft.com/office/drawing/2014/main" xmlns="" id="{2BFEEB2A-F10B-134C-957A-FC9FE673E0C1}"/>
+                <a16:creationId xmlns:a16="http://schemas.microsoft.com/office/drawing/2014/main" id="{2BFEEB2A-F10B-134C-957A-FC9FE673E0C1}"/>
               </a:ext>
             </a:extLst>
           </p:cNvPr>
@@ -37133,7 +37133,7 @@
           <p:cNvPr id="7233" name="Picture 65" descr="Delete">
             <a:extLst>
               <a:ext uri="{FF2B5EF4-FFF2-40B4-BE49-F238E27FC236}">
-                <a16:creationId xmlns:a16="http://schemas.microsoft.com/office/drawing/2014/main" xmlns="" id="{0D6CCC79-17D3-FF4B-9F32-D2EEBAADE4F0}"/>
+                <a16:creationId xmlns:a16="http://schemas.microsoft.com/office/drawing/2014/main" id="{0D6CCC79-17D3-FF4B-9F32-D2EEBAADE4F0}"/>
               </a:ext>
             </a:extLst>
           </p:cNvPr>
@@ -37180,7 +37180,7 @@
           <p:cNvPr id="7234" name="Picture 66" descr="Edit">
             <a:extLst>
               <a:ext uri="{FF2B5EF4-FFF2-40B4-BE49-F238E27FC236}">
-                <a16:creationId xmlns:a16="http://schemas.microsoft.com/office/drawing/2014/main" xmlns="" id="{B624129D-5217-2646-912D-1D1CB3349484}"/>
+                <a16:creationId xmlns:a16="http://schemas.microsoft.com/office/drawing/2014/main" id="{B624129D-5217-2646-912D-1D1CB3349484}"/>
               </a:ext>
             </a:extLst>
           </p:cNvPr>
@@ -37227,7 +37227,7 @@
           <p:cNvPr id="7235" name="Picture 67" descr="Copy">
             <a:extLst>
               <a:ext uri="{FF2B5EF4-FFF2-40B4-BE49-F238E27FC236}">
-                <a16:creationId xmlns:a16="http://schemas.microsoft.com/office/drawing/2014/main" xmlns="" id="{7522B05C-C3CC-3E45-A00A-168789630799}"/>
+                <a16:creationId xmlns:a16="http://schemas.microsoft.com/office/drawing/2014/main" id="{7522B05C-C3CC-3E45-A00A-168789630799}"/>
               </a:ext>
             </a:extLst>
           </p:cNvPr>
@@ -37274,7 +37274,7 @@
           <p:cNvPr id="7236" name="Picture 68" descr="Delete">
             <a:extLst>
               <a:ext uri="{FF2B5EF4-FFF2-40B4-BE49-F238E27FC236}">
-                <a16:creationId xmlns:a16="http://schemas.microsoft.com/office/drawing/2014/main" xmlns="" id="{0D38D860-0474-D14A-80E9-5351D3DCF75D}"/>
+                <a16:creationId xmlns:a16="http://schemas.microsoft.com/office/drawing/2014/main" id="{0D38D860-0474-D14A-80E9-5351D3DCF75D}"/>
               </a:ext>
             </a:extLst>
           </p:cNvPr>
@@ -37321,7 +37321,7 @@
           <p:cNvPr id="7237" name="Picture 69" descr="Edit">
             <a:extLst>
               <a:ext uri="{FF2B5EF4-FFF2-40B4-BE49-F238E27FC236}">
-                <a16:creationId xmlns:a16="http://schemas.microsoft.com/office/drawing/2014/main" xmlns="" id="{80A8FC36-88B1-5B47-A6B8-0EC244CDC4B1}"/>
+                <a16:creationId xmlns:a16="http://schemas.microsoft.com/office/drawing/2014/main" id="{80A8FC36-88B1-5B47-A6B8-0EC244CDC4B1}"/>
               </a:ext>
             </a:extLst>
           </p:cNvPr>
@@ -37368,7 +37368,7 @@
           <p:cNvPr id="7238" name="Picture 70" descr="Copy">
             <a:extLst>
               <a:ext uri="{FF2B5EF4-FFF2-40B4-BE49-F238E27FC236}">
-                <a16:creationId xmlns:a16="http://schemas.microsoft.com/office/drawing/2014/main" xmlns="" id="{2408ED3D-3FD3-1548-8A24-7583A66CEBD8}"/>
+                <a16:creationId xmlns:a16="http://schemas.microsoft.com/office/drawing/2014/main" id="{2408ED3D-3FD3-1548-8A24-7583A66CEBD8}"/>
               </a:ext>
             </a:extLst>
           </p:cNvPr>
@@ -37415,7 +37415,7 @@
           <p:cNvPr id="7239" name="Picture 71" descr="Delete">
             <a:extLst>
               <a:ext uri="{FF2B5EF4-FFF2-40B4-BE49-F238E27FC236}">
-                <a16:creationId xmlns:a16="http://schemas.microsoft.com/office/drawing/2014/main" xmlns="" id="{1B749367-0541-4C44-82A9-F1B7CB19D67D}"/>
+                <a16:creationId xmlns:a16="http://schemas.microsoft.com/office/drawing/2014/main" id="{1B749367-0541-4C44-82A9-F1B7CB19D67D}"/>
               </a:ext>
             </a:extLst>
           </p:cNvPr>
@@ -37462,7 +37462,7 @@
           <p:cNvPr id="7240" name="Picture 72" descr="Edit">
             <a:extLst>
               <a:ext uri="{FF2B5EF4-FFF2-40B4-BE49-F238E27FC236}">
-                <a16:creationId xmlns:a16="http://schemas.microsoft.com/office/drawing/2014/main" xmlns="" id="{24E149B0-2433-244D-B804-9F3558AB623A}"/>
+                <a16:creationId xmlns:a16="http://schemas.microsoft.com/office/drawing/2014/main" id="{24E149B0-2433-244D-B804-9F3558AB623A}"/>
               </a:ext>
             </a:extLst>
           </p:cNvPr>
@@ -37509,7 +37509,7 @@
           <p:cNvPr id="7241" name="Picture 73" descr="Copy">
             <a:extLst>
               <a:ext uri="{FF2B5EF4-FFF2-40B4-BE49-F238E27FC236}">
-                <a16:creationId xmlns:a16="http://schemas.microsoft.com/office/drawing/2014/main" xmlns="" id="{6B9CC010-A54E-4A43-9900-1713427C5389}"/>
+                <a16:creationId xmlns:a16="http://schemas.microsoft.com/office/drawing/2014/main" id="{6B9CC010-A54E-4A43-9900-1713427C5389}"/>
               </a:ext>
             </a:extLst>
           </p:cNvPr>
@@ -37556,7 +37556,7 @@
           <p:cNvPr id="7242" name="Picture 74" descr="Delete">
             <a:extLst>
               <a:ext uri="{FF2B5EF4-FFF2-40B4-BE49-F238E27FC236}">
-                <a16:creationId xmlns:a16="http://schemas.microsoft.com/office/drawing/2014/main" xmlns="" id="{63EED20F-110F-2E44-90C7-BA8FF3CA3B43}"/>
+                <a16:creationId xmlns:a16="http://schemas.microsoft.com/office/drawing/2014/main" id="{63EED20F-110F-2E44-90C7-BA8FF3CA3B43}"/>
               </a:ext>
             </a:extLst>
           </p:cNvPr>
@@ -37603,7 +37603,7 @@
           <p:cNvPr id="7243" name="Picture 75" descr="Edit">
             <a:extLst>
               <a:ext uri="{FF2B5EF4-FFF2-40B4-BE49-F238E27FC236}">
-                <a16:creationId xmlns:a16="http://schemas.microsoft.com/office/drawing/2014/main" xmlns="" id="{6CB6A258-CCF8-814C-8CF2-21999AF3E979}"/>
+                <a16:creationId xmlns:a16="http://schemas.microsoft.com/office/drawing/2014/main" id="{6CB6A258-CCF8-814C-8CF2-21999AF3E979}"/>
               </a:ext>
             </a:extLst>
           </p:cNvPr>
@@ -37650,7 +37650,7 @@
           <p:cNvPr id="7244" name="Picture 76" descr="Copy">
             <a:extLst>
               <a:ext uri="{FF2B5EF4-FFF2-40B4-BE49-F238E27FC236}">
-                <a16:creationId xmlns:a16="http://schemas.microsoft.com/office/drawing/2014/main" xmlns="" id="{C3214E57-8123-4545-B340-CB76673E8314}"/>
+                <a16:creationId xmlns:a16="http://schemas.microsoft.com/office/drawing/2014/main" id="{C3214E57-8123-4545-B340-CB76673E8314}"/>
               </a:ext>
             </a:extLst>
           </p:cNvPr>
@@ -37697,7 +37697,7 @@
           <p:cNvPr id="7245" name="Picture 77" descr="Delete">
             <a:extLst>
               <a:ext uri="{FF2B5EF4-FFF2-40B4-BE49-F238E27FC236}">
-                <a16:creationId xmlns:a16="http://schemas.microsoft.com/office/drawing/2014/main" xmlns="" id="{080BFB43-39E9-794C-9627-DDD29B4864E3}"/>
+                <a16:creationId xmlns:a16="http://schemas.microsoft.com/office/drawing/2014/main" id="{080BFB43-39E9-794C-9627-DDD29B4864E3}"/>
               </a:ext>
             </a:extLst>
           </p:cNvPr>
@@ -37744,7 +37744,7 @@
           <p:cNvPr id="7246" name="Picture 78" descr="Edit">
             <a:extLst>
               <a:ext uri="{FF2B5EF4-FFF2-40B4-BE49-F238E27FC236}">
-                <a16:creationId xmlns:a16="http://schemas.microsoft.com/office/drawing/2014/main" xmlns="" id="{C76DB593-26D0-E546-8BDF-F53B764FC1DE}"/>
+                <a16:creationId xmlns:a16="http://schemas.microsoft.com/office/drawing/2014/main" id="{C76DB593-26D0-E546-8BDF-F53B764FC1DE}"/>
               </a:ext>
             </a:extLst>
           </p:cNvPr>
@@ -37791,7 +37791,7 @@
           <p:cNvPr id="7247" name="Picture 79" descr="Copy">
             <a:extLst>
               <a:ext uri="{FF2B5EF4-FFF2-40B4-BE49-F238E27FC236}">
-                <a16:creationId xmlns:a16="http://schemas.microsoft.com/office/drawing/2014/main" xmlns="" id="{7F2B36A3-2DE8-4640-A9C9-59972A5534DA}"/>
+                <a16:creationId xmlns:a16="http://schemas.microsoft.com/office/drawing/2014/main" id="{7F2B36A3-2DE8-4640-A9C9-59972A5534DA}"/>
               </a:ext>
             </a:extLst>
           </p:cNvPr>
@@ -37838,7 +37838,7 @@
           <p:cNvPr id="7248" name="Picture 80" descr="Delete">
             <a:extLst>
               <a:ext uri="{FF2B5EF4-FFF2-40B4-BE49-F238E27FC236}">
-                <a16:creationId xmlns:a16="http://schemas.microsoft.com/office/drawing/2014/main" xmlns="" id="{E7DACCCE-1B2F-DE48-856A-87DE97669EA0}"/>
+                <a16:creationId xmlns:a16="http://schemas.microsoft.com/office/drawing/2014/main" id="{E7DACCCE-1B2F-DE48-856A-87DE97669EA0}"/>
               </a:ext>
             </a:extLst>
           </p:cNvPr>
@@ -37885,7 +37885,7 @@
           <p:cNvPr id="7249" name="Picture 81" descr="Edit">
             <a:extLst>
               <a:ext uri="{FF2B5EF4-FFF2-40B4-BE49-F238E27FC236}">
-                <a16:creationId xmlns:a16="http://schemas.microsoft.com/office/drawing/2014/main" xmlns="" id="{9638018F-7630-CE4A-9355-CE11B3FC8154}"/>
+                <a16:creationId xmlns:a16="http://schemas.microsoft.com/office/drawing/2014/main" id="{9638018F-7630-CE4A-9355-CE11B3FC8154}"/>
               </a:ext>
             </a:extLst>
           </p:cNvPr>
@@ -37932,7 +37932,7 @@
           <p:cNvPr id="7250" name="Picture 82" descr="Copy">
             <a:extLst>
               <a:ext uri="{FF2B5EF4-FFF2-40B4-BE49-F238E27FC236}">
-                <a16:creationId xmlns:a16="http://schemas.microsoft.com/office/drawing/2014/main" xmlns="" id="{50905964-6153-3940-8581-4E33AE5F6ED0}"/>
+                <a16:creationId xmlns:a16="http://schemas.microsoft.com/office/drawing/2014/main" id="{50905964-6153-3940-8581-4E33AE5F6ED0}"/>
               </a:ext>
             </a:extLst>
           </p:cNvPr>
@@ -37979,7 +37979,7 @@
           <p:cNvPr id="7251" name="Picture 83" descr="Delete">
             <a:extLst>
               <a:ext uri="{FF2B5EF4-FFF2-40B4-BE49-F238E27FC236}">
-                <a16:creationId xmlns:a16="http://schemas.microsoft.com/office/drawing/2014/main" xmlns="" id="{D90C0E12-E72B-8C41-91FA-7DF163990621}"/>
+                <a16:creationId xmlns:a16="http://schemas.microsoft.com/office/drawing/2014/main" id="{D90C0E12-E72B-8C41-91FA-7DF163990621}"/>
               </a:ext>
             </a:extLst>
           </p:cNvPr>
@@ -38026,7 +38026,7 @@
           <p:cNvPr id="7252" name="Picture 84" descr="Edit">
             <a:extLst>
               <a:ext uri="{FF2B5EF4-FFF2-40B4-BE49-F238E27FC236}">
-                <a16:creationId xmlns:a16="http://schemas.microsoft.com/office/drawing/2014/main" xmlns="" id="{30F2445D-97CB-F446-BBD3-81BDB7D577EF}"/>
+                <a16:creationId xmlns:a16="http://schemas.microsoft.com/office/drawing/2014/main" id="{30F2445D-97CB-F446-BBD3-81BDB7D577EF}"/>
               </a:ext>
             </a:extLst>
           </p:cNvPr>
@@ -38073,7 +38073,7 @@
           <p:cNvPr id="7253" name="Picture 85" descr="Copy">
             <a:extLst>
               <a:ext uri="{FF2B5EF4-FFF2-40B4-BE49-F238E27FC236}">
-                <a16:creationId xmlns:a16="http://schemas.microsoft.com/office/drawing/2014/main" xmlns="" id="{DDA7856D-5189-AF45-BD0B-651D084E9898}"/>
+                <a16:creationId xmlns:a16="http://schemas.microsoft.com/office/drawing/2014/main" id="{DDA7856D-5189-AF45-BD0B-651D084E9898}"/>
               </a:ext>
             </a:extLst>
           </p:cNvPr>
@@ -38120,7 +38120,7 @@
           <p:cNvPr id="7254" name="Picture 86" descr="Delete">
             <a:extLst>
               <a:ext uri="{FF2B5EF4-FFF2-40B4-BE49-F238E27FC236}">
-                <a16:creationId xmlns:a16="http://schemas.microsoft.com/office/drawing/2014/main" xmlns="" id="{A7D85B9A-C557-D74F-922A-932BAC48CAA2}"/>
+                <a16:creationId xmlns:a16="http://schemas.microsoft.com/office/drawing/2014/main" id="{A7D85B9A-C557-D74F-922A-932BAC48CAA2}"/>
               </a:ext>
             </a:extLst>
           </p:cNvPr>
@@ -38167,7 +38167,7 @@
           <p:cNvPr id="7255" name="Picture 87" descr="Edit">
             <a:extLst>
               <a:ext uri="{FF2B5EF4-FFF2-40B4-BE49-F238E27FC236}">
-                <a16:creationId xmlns:a16="http://schemas.microsoft.com/office/drawing/2014/main" xmlns="" id="{DFB52E64-6476-7944-90C6-78AE57050C7F}"/>
+                <a16:creationId xmlns:a16="http://schemas.microsoft.com/office/drawing/2014/main" id="{DFB52E64-6476-7944-90C6-78AE57050C7F}"/>
               </a:ext>
             </a:extLst>
           </p:cNvPr>
@@ -38214,7 +38214,7 @@
           <p:cNvPr id="7256" name="Picture 88" descr="Copy">
             <a:extLst>
               <a:ext uri="{FF2B5EF4-FFF2-40B4-BE49-F238E27FC236}">
-                <a16:creationId xmlns:a16="http://schemas.microsoft.com/office/drawing/2014/main" xmlns="" id="{B3F011E5-D843-6544-AD01-1FD7E3440534}"/>
+                <a16:creationId xmlns:a16="http://schemas.microsoft.com/office/drawing/2014/main" id="{B3F011E5-D843-6544-AD01-1FD7E3440534}"/>
               </a:ext>
             </a:extLst>
           </p:cNvPr>
@@ -38261,7 +38261,7 @@
           <p:cNvPr id="7257" name="Picture 89" descr="Delete">
             <a:extLst>
               <a:ext uri="{FF2B5EF4-FFF2-40B4-BE49-F238E27FC236}">
-                <a16:creationId xmlns:a16="http://schemas.microsoft.com/office/drawing/2014/main" xmlns="" id="{49753787-A49F-444B-850C-1D303F93BDE0}"/>
+                <a16:creationId xmlns:a16="http://schemas.microsoft.com/office/drawing/2014/main" id="{49753787-A49F-444B-850C-1D303F93BDE0}"/>
               </a:ext>
             </a:extLst>
           </p:cNvPr>
@@ -38308,7 +38308,7 @@
           <p:cNvPr id="7258" name="Picture 90" descr="Edit">
             <a:extLst>
               <a:ext uri="{FF2B5EF4-FFF2-40B4-BE49-F238E27FC236}">
-                <a16:creationId xmlns:a16="http://schemas.microsoft.com/office/drawing/2014/main" xmlns="" id="{A2F0A34A-E701-D941-A355-5E02B70A6833}"/>
+                <a16:creationId xmlns:a16="http://schemas.microsoft.com/office/drawing/2014/main" id="{A2F0A34A-E701-D941-A355-5E02B70A6833}"/>
               </a:ext>
             </a:extLst>
           </p:cNvPr>
@@ -38355,7 +38355,7 @@
           <p:cNvPr id="7259" name="Picture 91" descr="Copy">
             <a:extLst>
               <a:ext uri="{FF2B5EF4-FFF2-40B4-BE49-F238E27FC236}">
-                <a16:creationId xmlns:a16="http://schemas.microsoft.com/office/drawing/2014/main" xmlns="" id="{F8EAB2C0-102B-FF43-BE7C-6D36924E0F0D}"/>
+                <a16:creationId xmlns:a16="http://schemas.microsoft.com/office/drawing/2014/main" id="{F8EAB2C0-102B-FF43-BE7C-6D36924E0F0D}"/>
               </a:ext>
             </a:extLst>
           </p:cNvPr>
@@ -38402,7 +38402,7 @@
           <p:cNvPr id="7260" name="Picture 92" descr="Delete">
             <a:extLst>
               <a:ext uri="{FF2B5EF4-FFF2-40B4-BE49-F238E27FC236}">
-                <a16:creationId xmlns:a16="http://schemas.microsoft.com/office/drawing/2014/main" xmlns="" id="{A6194C9D-95F5-3D41-94AA-75EF90B754E3}"/>
+                <a16:creationId xmlns:a16="http://schemas.microsoft.com/office/drawing/2014/main" id="{A6194C9D-95F5-3D41-94AA-75EF90B754E3}"/>
               </a:ext>
             </a:extLst>
           </p:cNvPr>
@@ -38449,7 +38449,7 @@
           <p:cNvPr id="7261" name="Picture 93" descr="Edit">
             <a:extLst>
               <a:ext uri="{FF2B5EF4-FFF2-40B4-BE49-F238E27FC236}">
-                <a16:creationId xmlns:a16="http://schemas.microsoft.com/office/drawing/2014/main" xmlns="" id="{11FD369F-C6F5-7F48-8A4B-6A0971EC7A1A}"/>
+                <a16:creationId xmlns:a16="http://schemas.microsoft.com/office/drawing/2014/main" id="{11FD369F-C6F5-7F48-8A4B-6A0971EC7A1A}"/>
               </a:ext>
             </a:extLst>
           </p:cNvPr>
@@ -38496,7 +38496,7 @@
           <p:cNvPr id="7262" name="Picture 94" descr="Copy">
             <a:extLst>
               <a:ext uri="{FF2B5EF4-FFF2-40B4-BE49-F238E27FC236}">
-                <a16:creationId xmlns:a16="http://schemas.microsoft.com/office/drawing/2014/main" xmlns="" id="{C9DC0687-5FE1-034F-8A4A-9C58ABD5DBF0}"/>
+                <a16:creationId xmlns:a16="http://schemas.microsoft.com/office/drawing/2014/main" id="{C9DC0687-5FE1-034F-8A4A-9C58ABD5DBF0}"/>
               </a:ext>
             </a:extLst>
           </p:cNvPr>
@@ -38543,7 +38543,7 @@
           <p:cNvPr id="7263" name="Picture 95" descr="Delete">
             <a:extLst>
               <a:ext uri="{FF2B5EF4-FFF2-40B4-BE49-F238E27FC236}">
-                <a16:creationId xmlns:a16="http://schemas.microsoft.com/office/drawing/2014/main" xmlns="" id="{2AD73EEB-6ABD-9B44-A756-C32352F27449}"/>
+                <a16:creationId xmlns:a16="http://schemas.microsoft.com/office/drawing/2014/main" id="{2AD73EEB-6ABD-9B44-A756-C32352F27449}"/>
               </a:ext>
             </a:extLst>
           </p:cNvPr>
@@ -38590,7 +38590,7 @@
           <p:cNvPr id="7264" name="Picture 96" descr="Edit">
             <a:extLst>
               <a:ext uri="{FF2B5EF4-FFF2-40B4-BE49-F238E27FC236}">
-                <a16:creationId xmlns:a16="http://schemas.microsoft.com/office/drawing/2014/main" xmlns="" id="{10B34E61-15B9-2E49-87B9-73B2D7CA68DA}"/>
+                <a16:creationId xmlns:a16="http://schemas.microsoft.com/office/drawing/2014/main" id="{10B34E61-15B9-2E49-87B9-73B2D7CA68DA}"/>
               </a:ext>
             </a:extLst>
           </p:cNvPr>
@@ -38637,7 +38637,7 @@
           <p:cNvPr id="7265" name="Picture 97" descr="Copy">
             <a:extLst>
               <a:ext uri="{FF2B5EF4-FFF2-40B4-BE49-F238E27FC236}">
-                <a16:creationId xmlns:a16="http://schemas.microsoft.com/office/drawing/2014/main" xmlns="" id="{DD2D3E0B-9847-AB49-B1D3-F4D1036F531D}"/>
+                <a16:creationId xmlns:a16="http://schemas.microsoft.com/office/drawing/2014/main" id="{DD2D3E0B-9847-AB49-B1D3-F4D1036F531D}"/>
               </a:ext>
             </a:extLst>
           </p:cNvPr>
@@ -38684,7 +38684,7 @@
           <p:cNvPr id="7266" name="Picture 98" descr="Delete">
             <a:extLst>
               <a:ext uri="{FF2B5EF4-FFF2-40B4-BE49-F238E27FC236}">
-                <a16:creationId xmlns:a16="http://schemas.microsoft.com/office/drawing/2014/main" xmlns="" id="{2E6B4D75-18BB-A144-816D-F2B4619AF434}"/>
+                <a16:creationId xmlns:a16="http://schemas.microsoft.com/office/drawing/2014/main" id="{2E6B4D75-18BB-A144-816D-F2B4619AF434}"/>
               </a:ext>
             </a:extLst>
           </p:cNvPr>
@@ -38731,7 +38731,7 @@
           <p:cNvPr id="7267" name="Picture 99" descr="Edit">
             <a:extLst>
               <a:ext uri="{FF2B5EF4-FFF2-40B4-BE49-F238E27FC236}">
-                <a16:creationId xmlns:a16="http://schemas.microsoft.com/office/drawing/2014/main" xmlns="" id="{FD1EDE04-2CAE-0944-85C6-942CAF846D65}"/>
+                <a16:creationId xmlns:a16="http://schemas.microsoft.com/office/drawing/2014/main" id="{FD1EDE04-2CAE-0944-85C6-942CAF846D65}"/>
               </a:ext>
             </a:extLst>
           </p:cNvPr>
@@ -38778,7 +38778,7 @@
           <p:cNvPr id="7268" name="Picture 100" descr="Copy">
             <a:extLst>
               <a:ext uri="{FF2B5EF4-FFF2-40B4-BE49-F238E27FC236}">
-                <a16:creationId xmlns:a16="http://schemas.microsoft.com/office/drawing/2014/main" xmlns="" id="{0311F970-C813-0046-B959-F2B02CFB0C75}"/>
+                <a16:creationId xmlns:a16="http://schemas.microsoft.com/office/drawing/2014/main" id="{0311F970-C813-0046-B959-F2B02CFB0C75}"/>
               </a:ext>
             </a:extLst>
           </p:cNvPr>
@@ -38825,7 +38825,7 @@
           <p:cNvPr id="7269" name="Picture 101" descr="Delete">
             <a:extLst>
               <a:ext uri="{FF2B5EF4-FFF2-40B4-BE49-F238E27FC236}">
-                <a16:creationId xmlns:a16="http://schemas.microsoft.com/office/drawing/2014/main" xmlns="" id="{A29F9472-4262-2E49-AB07-394AEC0363F4}"/>
+                <a16:creationId xmlns:a16="http://schemas.microsoft.com/office/drawing/2014/main" id="{A29F9472-4262-2E49-AB07-394AEC0363F4}"/>
               </a:ext>
             </a:extLst>
           </p:cNvPr>
@@ -38872,7 +38872,7 @@
           <p:cNvPr id="7270" name="Picture 102" descr="Edit">
             <a:extLst>
               <a:ext uri="{FF2B5EF4-FFF2-40B4-BE49-F238E27FC236}">
-                <a16:creationId xmlns:a16="http://schemas.microsoft.com/office/drawing/2014/main" xmlns="" id="{388DB9D5-6E65-7643-A25E-3D38446B6373}"/>
+                <a16:creationId xmlns:a16="http://schemas.microsoft.com/office/drawing/2014/main" id="{388DB9D5-6E65-7643-A25E-3D38446B6373}"/>
               </a:ext>
             </a:extLst>
           </p:cNvPr>
@@ -38919,7 +38919,7 @@
           <p:cNvPr id="7271" name="Picture 103" descr="Copy">
             <a:extLst>
               <a:ext uri="{FF2B5EF4-FFF2-40B4-BE49-F238E27FC236}">
-                <a16:creationId xmlns:a16="http://schemas.microsoft.com/office/drawing/2014/main" xmlns="" id="{E1D696C6-1DB6-C149-BB26-B53BCEAF2704}"/>
+                <a16:creationId xmlns:a16="http://schemas.microsoft.com/office/drawing/2014/main" id="{E1D696C6-1DB6-C149-BB26-B53BCEAF2704}"/>
               </a:ext>
             </a:extLst>
           </p:cNvPr>
@@ -38966,7 +38966,7 @@
           <p:cNvPr id="7272" name="Picture 104" descr="Delete">
             <a:extLst>
               <a:ext uri="{FF2B5EF4-FFF2-40B4-BE49-F238E27FC236}">
-                <a16:creationId xmlns:a16="http://schemas.microsoft.com/office/drawing/2014/main" xmlns="" id="{2BF06DD9-3B1A-D34C-9A63-B55958FEB6F4}"/>
+                <a16:creationId xmlns:a16="http://schemas.microsoft.com/office/drawing/2014/main" id="{2BF06DD9-3B1A-D34C-9A63-B55958FEB6F4}"/>
               </a:ext>
             </a:extLst>
           </p:cNvPr>
@@ -39013,7 +39013,7 @@
           <p:cNvPr id="7273" name="Picture 105" descr="Edit">
             <a:extLst>
               <a:ext uri="{FF2B5EF4-FFF2-40B4-BE49-F238E27FC236}">
-                <a16:creationId xmlns:a16="http://schemas.microsoft.com/office/drawing/2014/main" xmlns="" id="{F779866C-856E-6145-9265-3FC104F23607}"/>
+                <a16:creationId xmlns:a16="http://schemas.microsoft.com/office/drawing/2014/main" id="{F779866C-856E-6145-9265-3FC104F23607}"/>
               </a:ext>
             </a:extLst>
           </p:cNvPr>
@@ -39060,7 +39060,7 @@
           <p:cNvPr id="7274" name="Picture 106" descr="Copy">
             <a:extLst>
               <a:ext uri="{FF2B5EF4-FFF2-40B4-BE49-F238E27FC236}">
-                <a16:creationId xmlns:a16="http://schemas.microsoft.com/office/drawing/2014/main" xmlns="" id="{70D9D364-C44A-0144-80C8-EF4A1A6A6CA3}"/>
+                <a16:creationId xmlns:a16="http://schemas.microsoft.com/office/drawing/2014/main" id="{70D9D364-C44A-0144-80C8-EF4A1A6A6CA3}"/>
               </a:ext>
             </a:extLst>
           </p:cNvPr>
@@ -39107,7 +39107,7 @@
           <p:cNvPr id="7275" name="Picture 107" descr="Delete">
             <a:extLst>
               <a:ext uri="{FF2B5EF4-FFF2-40B4-BE49-F238E27FC236}">
-                <a16:creationId xmlns:a16="http://schemas.microsoft.com/office/drawing/2014/main" xmlns="" id="{3C3379C6-BD39-4B4A-8BE6-AA5F77C4966E}"/>
+                <a16:creationId xmlns:a16="http://schemas.microsoft.com/office/drawing/2014/main" id="{3C3379C6-BD39-4B4A-8BE6-AA5F77C4966E}"/>
               </a:ext>
             </a:extLst>
           </p:cNvPr>
@@ -39154,7 +39154,7 @@
           <p:cNvPr id="7276" name="Picture 108" descr="Edit">
             <a:extLst>
               <a:ext uri="{FF2B5EF4-FFF2-40B4-BE49-F238E27FC236}">
-                <a16:creationId xmlns:a16="http://schemas.microsoft.com/office/drawing/2014/main" xmlns="" id="{3FE1382E-5F62-5649-BC20-91DE8CB6801E}"/>
+                <a16:creationId xmlns:a16="http://schemas.microsoft.com/office/drawing/2014/main" id="{3FE1382E-5F62-5649-BC20-91DE8CB6801E}"/>
               </a:ext>
             </a:extLst>
           </p:cNvPr>
@@ -39201,7 +39201,7 @@
           <p:cNvPr id="7277" name="Picture 109" descr="Copy">
             <a:extLst>
               <a:ext uri="{FF2B5EF4-FFF2-40B4-BE49-F238E27FC236}">
-                <a16:creationId xmlns:a16="http://schemas.microsoft.com/office/drawing/2014/main" xmlns="" id="{739E4073-C04F-E843-82FD-4DE1266AE603}"/>
+                <a16:creationId xmlns:a16="http://schemas.microsoft.com/office/drawing/2014/main" id="{739E4073-C04F-E843-82FD-4DE1266AE603}"/>
               </a:ext>
             </a:extLst>
           </p:cNvPr>
@@ -39248,7 +39248,7 @@
           <p:cNvPr id="7278" name="Picture 110" descr="Delete">
             <a:extLst>
               <a:ext uri="{FF2B5EF4-FFF2-40B4-BE49-F238E27FC236}">
-                <a16:creationId xmlns:a16="http://schemas.microsoft.com/office/drawing/2014/main" xmlns="" id="{C66F04BA-9996-1348-9DF2-1AB3D889B199}"/>
+                <a16:creationId xmlns:a16="http://schemas.microsoft.com/office/drawing/2014/main" id="{C66F04BA-9996-1348-9DF2-1AB3D889B199}"/>
               </a:ext>
             </a:extLst>
           </p:cNvPr>
@@ -39399,7 +39399,7 @@
           <p:cNvPr id="2" name="Title 1">
             <a:extLst>
               <a:ext uri="{FF2B5EF4-FFF2-40B4-BE49-F238E27FC236}">
-                <a16:creationId xmlns:a16="http://schemas.microsoft.com/office/drawing/2014/main" xmlns="" id="{E0197DAE-2794-2A48-B881-72AD9F2E19E6}"/>
+                <a16:creationId xmlns:a16="http://schemas.microsoft.com/office/drawing/2014/main" id="{E0197DAE-2794-2A48-B881-72AD9F2E19E6}"/>
               </a:ext>
             </a:extLst>
           </p:cNvPr>
@@ -39432,7 +39432,7 @@
           <p:cNvPr id="3" name="Content Placeholder 2">
             <a:extLst>
               <a:ext uri="{FF2B5EF4-FFF2-40B4-BE49-F238E27FC236}">
-                <a16:creationId xmlns:a16="http://schemas.microsoft.com/office/drawing/2014/main" xmlns="" id="{47654F44-B3B5-5746-93E9-8536EF5C9CF8}"/>
+                <a16:creationId xmlns:a16="http://schemas.microsoft.com/office/drawing/2014/main" id="{47654F44-B3B5-5746-93E9-8536EF5C9CF8}"/>
               </a:ext>
             </a:extLst>
           </p:cNvPr>
@@ -40247,7 +40247,7 @@
           <p:cNvPr id="2" name="Title 1">
             <a:extLst>
               <a:ext uri="{FF2B5EF4-FFF2-40B4-BE49-F238E27FC236}">
-                <a16:creationId xmlns:a16="http://schemas.microsoft.com/office/drawing/2014/main" xmlns="" id="{272473BD-73F3-F250-5FE7-3EA97C866409}"/>
+                <a16:creationId xmlns:a16="http://schemas.microsoft.com/office/drawing/2014/main" id="{272473BD-73F3-F250-5FE7-3EA97C866409}"/>
               </a:ext>
             </a:extLst>
           </p:cNvPr>
@@ -40281,7 +40281,7 @@
           <p:cNvPr id="3" name="Content Placeholder 2">
             <a:extLst>
               <a:ext uri="{FF2B5EF4-FFF2-40B4-BE49-F238E27FC236}">
-                <a16:creationId xmlns:a16="http://schemas.microsoft.com/office/drawing/2014/main" xmlns="" id="{D8CD099E-FF4E-F319-9432-69F0548E0E7E}"/>
+                <a16:creationId xmlns:a16="http://schemas.microsoft.com/office/drawing/2014/main" id="{D8CD099E-FF4E-F319-9432-69F0548E0E7E}"/>
               </a:ext>
             </a:extLst>
           </p:cNvPr>
@@ -40589,7 +40589,7 @@
           <p:cNvPr id="2" name="Title 1">
             <a:extLst>
               <a:ext uri="{FF2B5EF4-FFF2-40B4-BE49-F238E27FC236}">
-                <a16:creationId xmlns:a16="http://schemas.microsoft.com/office/drawing/2014/main" xmlns="" id="{EA30D645-AE7D-B6CF-EFC7-B56CF19198C3}"/>
+                <a16:creationId xmlns:a16="http://schemas.microsoft.com/office/drawing/2014/main" id="{EA30D645-AE7D-B6CF-EFC7-B56CF19198C3}"/>
               </a:ext>
             </a:extLst>
           </p:cNvPr>
@@ -40617,7 +40617,7 @@
           <p:cNvPr id="3" name="Content Placeholder 2">
             <a:extLst>
               <a:ext uri="{FF2B5EF4-FFF2-40B4-BE49-F238E27FC236}">
-                <a16:creationId xmlns:a16="http://schemas.microsoft.com/office/drawing/2014/main" xmlns="" id="{07567EC5-D7CB-AE1A-C119-377D3A671018}"/>
+                <a16:creationId xmlns:a16="http://schemas.microsoft.com/office/drawing/2014/main" id="{07567EC5-D7CB-AE1A-C119-377D3A671018}"/>
               </a:ext>
             </a:extLst>
           </p:cNvPr>
@@ -41393,6 +41393,15 @@
 </file>
 
 <file path=customXml/item1.xml><?xml version="1.0" encoding="utf-8"?>
+<?mso-contentType ?>
+<FormTemplates xmlns="http://schemas.microsoft.com/sharepoint/v3/contenttype/forms">
+  <Display>DocumentLibraryForm</Display>
+  <Edit>DocumentLibraryForm</Edit>
+  <New>DocumentLibraryForm</New>
+</FormTemplates>
+</file>
+
+<file path=customXml/item2.xml><?xml version="1.0" encoding="utf-8"?>
 <ct:contentTypeSchema xmlns:ct="http://schemas.microsoft.com/office/2006/metadata/contentType" xmlns:ma="http://schemas.microsoft.com/office/2006/metadata/properties/metaAttributes" ct:_="" ma:_="" ma:contentTypeName="Document" ma:contentTypeID="0x010100080C3346745D2A44898E7C00B26BA3DF" ma:contentTypeVersion="8" ma:contentTypeDescription="Create a new document." ma:contentTypeScope="" ma:versionID="d47a56e76954139babc54a88d80e6969">
   <xsd:schema xmlns:xsd="http://www.w3.org/2001/XMLSchema" xmlns:xs="http://www.w3.org/2001/XMLSchema" xmlns:p="http://schemas.microsoft.com/office/2006/metadata/properties" xmlns:ns3="b94cf9f7-a8e4-46ed-a738-1528c1b4a8b4" xmlns:ns4="89e3a213-c188-43cc-91c0-e14b70b4fad2" targetNamespace="http://schemas.microsoft.com/office/2006/metadata/properties" ma:root="true" ma:fieldsID="44c30f9887d90218b9b2ec057a4cd5b7" ns3:_="" ns4:_="">
     <xsd:import namespace="b94cf9f7-a8e4-46ed-a738-1528c1b4a8b4"/>
@@ -41581,22 +41590,21 @@
 </ct:contentTypeSchema>
 </file>
 
-<file path=customXml/item2.xml><?xml version="1.0" encoding="utf-8"?>
+<file path=customXml/item3.xml><?xml version="1.0" encoding="utf-8"?>
 <p:properties xmlns:p="http://schemas.microsoft.com/office/2006/metadata/properties" xmlns:xsi="http://www.w3.org/2001/XMLSchema-instance" xmlns:pc="http://schemas.microsoft.com/office/infopath/2007/PartnerControls">
   <documentManagement/>
 </p:properties>
 </file>
 
-<file path=customXml/item3.xml><?xml version="1.0" encoding="utf-8"?>
-<?mso-contentType ?>
-<FormTemplates xmlns="http://schemas.microsoft.com/sharepoint/v3/contenttype/forms">
-  <Display>DocumentLibraryForm</Display>
-  <Edit>DocumentLibraryForm</Edit>
-  <New>DocumentLibraryForm</New>
-</FormTemplates>
+<file path=customXml/itemProps1.xml><?xml version="1.0" encoding="utf-8"?>
+<ds:datastoreItem xmlns:ds="http://schemas.openxmlformats.org/officeDocument/2006/customXml" ds:itemID="{E93B4755-80B4-4FE9-9650-4C8006444834}">
+  <ds:schemaRefs>
+    <ds:schemaRef ds:uri="http://schemas.microsoft.com/sharepoint/v3/contenttype/forms"/>
+  </ds:schemaRefs>
+</ds:datastoreItem>
 </file>
 
-<file path=customXml/itemProps1.xml><?xml version="1.0" encoding="utf-8"?>
+<file path=customXml/itemProps2.xml><?xml version="1.0" encoding="utf-8"?>
 <ds:datastoreItem xmlns:ds="http://schemas.openxmlformats.org/officeDocument/2006/customXml" ds:itemID="{EB149AA4-09F0-4EA4-AEDC-F683534FABF6}">
   <ds:schemaRefs>
     <ds:schemaRef ds:uri="89e3a213-c188-43cc-91c0-e14b70b4fad2"/>
@@ -41615,7 +41623,7 @@
 </ds:datastoreItem>
 </file>
 
-<file path=customXml/itemProps2.xml><?xml version="1.0" encoding="utf-8"?>
+<file path=customXml/itemProps3.xml><?xml version="1.0" encoding="utf-8"?>
 <ds:datastoreItem xmlns:ds="http://schemas.openxmlformats.org/officeDocument/2006/customXml" ds:itemID="{D6F79D9B-5A67-492D-BB4F-F3913BAD9421}">
   <ds:schemaRefs>
     <ds:schemaRef ds:uri="89e3a213-c188-43cc-91c0-e14b70b4fad2"/>
@@ -41630,12 +41638,4 @@
     <ds:schemaRef ds:uri="http://www.w3.org/XML/1998/namespace"/>
   </ds:schemaRefs>
 </ds:datastoreItem>
-</file>
-
-<file path=customXml/itemProps3.xml><?xml version="1.0" encoding="utf-8"?>
-<ds:datastoreItem xmlns:ds="http://schemas.openxmlformats.org/officeDocument/2006/customXml" ds:itemID="{E93B4755-80B4-4FE9-9650-4C8006444834}">
-  <ds:schemaRefs>
-    <ds:schemaRef ds:uri="http://schemas.microsoft.com/sharepoint/v3/contenttype/forms"/>
-  </ds:schemaRefs>
-</ds:datastoreItem>
 </file>
</xml_diff>